<commit_message>
Revise CIS-421 presentation to rubric-aligned RonyGuard fictitious company deck
Agent-Logs-Url: https://github.com/Ronykipkemboi/ai-legal-rights-assistant/sessions/38fbd81a-5282-4dc4-8963-b2a356bf90b3

Co-authored-by: Ronykipkemboi <149723274+Ronykipkemboi@users.noreply.github.com>
</commit_message>
<xml_diff>
--- a/Presentation.pptx
+++ b/Presentation.pptx
@@ -124,7 +124,7 @@
           <a:lstStyle/>
           <a:p>
             <a:r>
-              <a:t>Cost Comparison (USD)</a:t>
+              <a:t>Cost Comparison: Traditional Lawyer vs RonyGuard Subscription</a:t>
             </a:r>
           </a:p>
         </c:rich>
@@ -146,7 +146,7 @@
               <c:strCache>
                 <c:ptCount val="1"/>
                 <c:pt idx="0">
-                  <c:v>Cost</c:v>
+                  <c:v>Cost (USD)</c:v>
                 </c:pt>
               </c:strCache>
             </c:strRef>
@@ -168,7 +168,7 @@
                   <c:v>Traditional Lawyer</c:v>
                 </c:pt>
                 <c:pt idx="1">
-                  <c:v>LexiGuard AI</c:v>
+                  <c:v>RonyGuard Subscription</c:v>
                 </c:pt>
               </c:strCache>
             </c:strRef>
@@ -180,7 +180,7 @@
                 <c:formatCode>General</c:formatCode>
                 <c:ptCount val="2"/>
                 <c:pt idx="0">
-                  <c:v>300</c:v>
+                  <c:v>600</c:v>
                 </c:pt>
                 <c:pt idx="1">
                   <c:v>15</c:v>
@@ -199,6 +199,21 @@
         </c:scaling>
         <c:delete val="0"/>
         <c:axPos val="b"/>
+        <c:title>
+          <c:tx>
+            <c:rich>
+              <a:bodyPr/>
+              <a:lstStyle/>
+              <a:p>
+                <a:r>
+                  <a:t>Service Type</a:t>
+                </a:r>
+              </a:p>
+            </c:rich>
+          </c:tx>
+          <c:layout/>
+          <c:overlay val="0"/>
+        </c:title>
         <c:majorTickMark val="out"/>
         <c:minorTickMark val="none"/>
         <c:tickLblPos val="nextTo"/>
@@ -218,6 +233,21 @@
         <c:delete val="0"/>
         <c:axPos val="l"/>
         <c:majorGridlines/>
+        <c:title>
+          <c:tx>
+            <c:rich>
+              <a:bodyPr/>
+              <a:lstStyle/>
+              <a:p>
+                <a:r>
+                  <a:t>Cost (USD)</a:t>
+                </a:r>
+              </a:p>
+            </c:rich>
+          </c:tx>
+          <c:layout/>
+          <c:overlay val="0"/>
+        </c:title>
         <c:majorTickMark val="out"/>
         <c:minorTickMark val="none"/>
         <c:tickLblPos val="nextTo"/>
@@ -242,6 +272,846 @@
     <c:autoUpdate val="0"/>
   </c:externalData>
 </c:chartSpace>
+</file>
+
+<file path=ppt/notesMasters/notesMaster1.xml><?xml version="1.0" encoding="utf-8"?>
+<p:notesMaster xmlns:a="http://schemas.openxmlformats.org/drawingml/2006/main" xmlns:p="http://schemas.openxmlformats.org/presentationml/2006/main" xmlns:r="http://schemas.openxmlformats.org/officeDocument/2006/relationships">
+  <p:cSld>
+    <p:bg>
+      <p:bgRef idx="1001">
+        <a:schemeClr val="bg1"/>
+      </p:bgRef>
+    </p:bg>
+    <p:spTree>
+      <p:nvGrpSpPr>
+        <p:cNvPr id="1" name=""/>
+        <p:cNvGrpSpPr/>
+        <p:nvPr/>
+      </p:nvGrpSpPr>
+      <p:grpSpPr>
+        <a:xfrm>
+          <a:off x="0" y="0"/>
+          <a:ext cx="0" cy="0"/>
+          <a:chOff x="0" y="0"/>
+          <a:chExt cx="0" cy="0"/>
+        </a:xfrm>
+      </p:grpSpPr>
+      <p:sp>
+        <p:nvSpPr>
+          <p:cNvPr id="2" name="Header Placeholder 1"/>
+          <p:cNvSpPr>
+            <a:spLocks noGrp="1"/>
+          </p:cNvSpPr>
+          <p:nvPr>
+            <p:ph type="hdr" sz="quarter"/>
+          </p:nvPr>
+        </p:nvSpPr>
+        <p:spPr>
+          <a:xfrm>
+            <a:off x="0" y="0"/>
+            <a:ext cx="2971800" cy="457200"/>
+          </a:xfrm>
+          <a:prstGeom prst="rect">
+            <a:avLst/>
+          </a:prstGeom>
+        </p:spPr>
+        <p:txBody>
+          <a:bodyPr vert="horz" lIns="91440" tIns="45720" rIns="91440" bIns="45720" rtlCol="0"/>
+          <a:lstStyle>
+            <a:lvl1pPr algn="l">
+              <a:defRPr sz="1200"/>
+            </a:lvl1pPr>
+          </a:lstStyle>
+          <a:p>
+            <a:endParaRPr lang="en-US"/>
+          </a:p>
+        </p:txBody>
+      </p:sp>
+      <p:sp>
+        <p:nvSpPr>
+          <p:cNvPr id="3" name="Date Placeholder 2"/>
+          <p:cNvSpPr>
+            <a:spLocks noGrp="1"/>
+          </p:cNvSpPr>
+          <p:nvPr>
+            <p:ph type="dt" idx="1"/>
+          </p:nvPr>
+        </p:nvSpPr>
+        <p:spPr>
+          <a:xfrm>
+            <a:off x="3884613" y="0"/>
+            <a:ext cx="2971800" cy="457200"/>
+          </a:xfrm>
+          <a:prstGeom prst="rect">
+            <a:avLst/>
+          </a:prstGeom>
+        </p:spPr>
+        <p:txBody>
+          <a:bodyPr vert="horz" lIns="91440" tIns="45720" rIns="91440" bIns="45720" rtlCol="0"/>
+          <a:lstStyle>
+            <a:lvl1pPr algn="r">
+              <a:defRPr sz="1200"/>
+            </a:lvl1pPr>
+          </a:lstStyle>
+          <a:p>
+            <a:fld id="{0F89C1C7-3DCD-1040-A9CF-14679D8B5DDD}" type="datetimeFigureOut">
+              <a:rPr lang="en-US" smtClean="0"/>
+              <a:t>10/17/16</a:t>
+            </a:fld>
+            <a:endParaRPr lang="en-US"/>
+          </a:p>
+        </p:txBody>
+      </p:sp>
+      <p:sp>
+        <p:nvSpPr>
+          <p:cNvPr id="4" name="Slide Image Placeholder 3"/>
+          <p:cNvSpPr>
+            <a:spLocks noGrp="1" noRot="1" noChangeAspect="1"/>
+          </p:cNvSpPr>
+          <p:nvPr>
+            <p:ph type="sldImg" idx="2"/>
+          </p:nvPr>
+        </p:nvSpPr>
+        <p:spPr>
+          <a:xfrm>
+            <a:off x="1143000" y="685800"/>
+            <a:ext cx="4572000" cy="3429000"/>
+          </a:xfrm>
+          <a:prstGeom prst="rect">
+            <a:avLst/>
+          </a:prstGeom>
+          <a:noFill/>
+          <a:ln w="12700">
+            <a:solidFill>
+              <a:prstClr val="black"/>
+            </a:solidFill>
+          </a:ln>
+        </p:spPr>
+        <p:txBody>
+          <a:bodyPr vert="horz" lIns="91440" tIns="45720" rIns="91440" bIns="45720" rtlCol="0" anchor="ctr"/>
+          <a:lstStyle/>
+          <a:p>
+            <a:endParaRPr lang="en-US"/>
+          </a:p>
+        </p:txBody>
+      </p:sp>
+      <p:sp>
+        <p:nvSpPr>
+          <p:cNvPr id="5" name="Notes Placeholder 4"/>
+          <p:cNvSpPr>
+            <a:spLocks noGrp="1"/>
+          </p:cNvSpPr>
+          <p:nvPr>
+            <p:ph type="body" sz="quarter" idx="3"/>
+          </p:nvPr>
+        </p:nvSpPr>
+        <p:spPr>
+          <a:xfrm>
+            <a:off x="685800" y="4343400"/>
+            <a:ext cx="5486400" cy="4114800"/>
+          </a:xfrm>
+          <a:prstGeom prst="rect">
+            <a:avLst/>
+          </a:prstGeom>
+        </p:spPr>
+        <p:txBody>
+          <a:bodyPr vert="horz" lIns="91440" tIns="45720" rIns="91440" bIns="45720" rtlCol="0"/>
+          <a:lstStyle/>
+          <a:p>
+            <a:pPr lvl="0"/>
+            <a:r>
+              <a:rPr lang="en-US" smtClean="0"/>
+              <a:t>Click to edit Master text styles</a:t>
+            </a:r>
+          </a:p>
+          <a:p>
+            <a:pPr lvl="1"/>
+            <a:r>
+              <a:rPr lang="en-US" smtClean="0"/>
+              <a:t>Second level</a:t>
+            </a:r>
+          </a:p>
+          <a:p>
+            <a:pPr lvl="2"/>
+            <a:r>
+              <a:rPr lang="en-US" smtClean="0"/>
+              <a:t>Third level</a:t>
+            </a:r>
+          </a:p>
+          <a:p>
+            <a:pPr lvl="3"/>
+            <a:r>
+              <a:rPr lang="en-US" smtClean="0"/>
+              <a:t>Fourth level</a:t>
+            </a:r>
+          </a:p>
+          <a:p>
+            <a:pPr lvl="4"/>
+            <a:r>
+              <a:rPr lang="en-US" smtClean="0"/>
+              <a:t>Fifth level</a:t>
+            </a:r>
+            <a:endParaRPr lang="en-US"/>
+          </a:p>
+        </p:txBody>
+      </p:sp>
+      <p:sp>
+        <p:nvSpPr>
+          <p:cNvPr id="6" name="Footer Placeholder 5"/>
+          <p:cNvSpPr>
+            <a:spLocks noGrp="1"/>
+          </p:cNvSpPr>
+          <p:nvPr>
+            <p:ph type="ftr" sz="quarter" idx="4"/>
+          </p:nvPr>
+        </p:nvSpPr>
+        <p:spPr>
+          <a:xfrm>
+            <a:off x="0" y="8685213"/>
+            <a:ext cx="2971800" cy="457200"/>
+          </a:xfrm>
+          <a:prstGeom prst="rect">
+            <a:avLst/>
+          </a:prstGeom>
+        </p:spPr>
+        <p:txBody>
+          <a:bodyPr vert="horz" lIns="91440" tIns="45720" rIns="91440" bIns="45720" rtlCol="0" anchor="b"/>
+          <a:lstStyle>
+            <a:lvl1pPr algn="l">
+              <a:defRPr sz="1200"/>
+            </a:lvl1pPr>
+          </a:lstStyle>
+          <a:p>
+            <a:endParaRPr lang="en-US"/>
+          </a:p>
+        </p:txBody>
+      </p:sp>
+      <p:sp>
+        <p:nvSpPr>
+          <p:cNvPr id="7" name="Slide Number Placeholder 6"/>
+          <p:cNvSpPr>
+            <a:spLocks noGrp="1"/>
+          </p:cNvSpPr>
+          <p:nvPr>
+            <p:ph type="sldNum" sz="quarter" idx="5"/>
+          </p:nvPr>
+        </p:nvSpPr>
+        <p:spPr>
+          <a:xfrm>
+            <a:off x="3884613" y="8685213"/>
+            <a:ext cx="2971800" cy="457200"/>
+          </a:xfrm>
+          <a:prstGeom prst="rect">
+            <a:avLst/>
+          </a:prstGeom>
+        </p:spPr>
+        <p:txBody>
+          <a:bodyPr vert="horz" lIns="91440" tIns="45720" rIns="91440" bIns="45720" rtlCol="0" anchor="b"/>
+          <a:lstStyle>
+            <a:lvl1pPr algn="r">
+              <a:defRPr sz="1200"/>
+            </a:lvl1pPr>
+          </a:lstStyle>
+          <a:p>
+            <a:fld id="{BB5E49A5-4136-284D-997B-48E1D791AD67}" type="slidenum">
+              <a:rPr lang="en-US" smtClean="0"/>
+              <a:t>‹#›</a:t>
+            </a:fld>
+            <a:endParaRPr lang="en-US"/>
+          </a:p>
+        </p:txBody>
+      </p:sp>
+    </p:spTree>
+    <p:extLst>
+      <p:ext uri="{BB962C8B-B14F-4D97-AF65-F5344CB8AC3E}">
+        <p14:creationId xmlns:p14="http://schemas.microsoft.com/office/powerpoint/2010/main" val="2623252185"/>
+      </p:ext>
+    </p:extLst>
+  </p:cSld>
+  <p:clrMap bg1="lt1" tx1="dk1" bg2="lt2" tx2="dk2" accent1="accent1" accent2="accent2" accent3="accent3" accent4="accent4" accent5="accent5" accent6="accent6" hlink="hlink" folHlink="folHlink"/>
+  <p:notesStyle>
+    <a:lvl1pPr marL="0" algn="l" defTabSz="457200" rtl="0" eaLnBrk="1" latinLnBrk="0" hangingPunct="1">
+      <a:defRPr sz="1200" kern="1200">
+        <a:solidFill>
+          <a:schemeClr val="tx1"/>
+        </a:solidFill>
+        <a:latin typeface="+mn-lt"/>
+        <a:ea typeface="+mn-ea"/>
+        <a:cs typeface="+mn-cs"/>
+      </a:defRPr>
+    </a:lvl1pPr>
+    <a:lvl2pPr marL="457200" algn="l" defTabSz="457200" rtl="0" eaLnBrk="1" latinLnBrk="0" hangingPunct="1">
+      <a:defRPr sz="1200" kern="1200">
+        <a:solidFill>
+          <a:schemeClr val="tx1"/>
+        </a:solidFill>
+        <a:latin typeface="+mn-lt"/>
+        <a:ea typeface="+mn-ea"/>
+        <a:cs typeface="+mn-cs"/>
+      </a:defRPr>
+    </a:lvl2pPr>
+    <a:lvl3pPr marL="914400" algn="l" defTabSz="457200" rtl="0" eaLnBrk="1" latinLnBrk="0" hangingPunct="1">
+      <a:defRPr sz="1200" kern="1200">
+        <a:solidFill>
+          <a:schemeClr val="tx1"/>
+        </a:solidFill>
+        <a:latin typeface="+mn-lt"/>
+        <a:ea typeface="+mn-ea"/>
+        <a:cs typeface="+mn-cs"/>
+      </a:defRPr>
+    </a:lvl3pPr>
+    <a:lvl4pPr marL="1371600" algn="l" defTabSz="457200" rtl="0" eaLnBrk="1" latinLnBrk="0" hangingPunct="1">
+      <a:defRPr sz="1200" kern="1200">
+        <a:solidFill>
+          <a:schemeClr val="tx1"/>
+        </a:solidFill>
+        <a:latin typeface="+mn-lt"/>
+        <a:ea typeface="+mn-ea"/>
+        <a:cs typeface="+mn-cs"/>
+      </a:defRPr>
+    </a:lvl4pPr>
+    <a:lvl5pPr marL="1828800" algn="l" defTabSz="457200" rtl="0" eaLnBrk="1" latinLnBrk="0" hangingPunct="1">
+      <a:defRPr sz="1200" kern="1200">
+        <a:solidFill>
+          <a:schemeClr val="tx1"/>
+        </a:solidFill>
+        <a:latin typeface="+mn-lt"/>
+        <a:ea typeface="+mn-ea"/>
+        <a:cs typeface="+mn-cs"/>
+      </a:defRPr>
+    </a:lvl5pPr>
+    <a:lvl6pPr marL="2286000" algn="l" defTabSz="457200" rtl="0" eaLnBrk="1" latinLnBrk="0" hangingPunct="1">
+      <a:defRPr sz="1200" kern="1200">
+        <a:solidFill>
+          <a:schemeClr val="tx1"/>
+        </a:solidFill>
+        <a:latin typeface="+mn-lt"/>
+        <a:ea typeface="+mn-ea"/>
+        <a:cs typeface="+mn-cs"/>
+      </a:defRPr>
+    </a:lvl6pPr>
+    <a:lvl7pPr marL="2743200" algn="l" defTabSz="457200" rtl="0" eaLnBrk="1" latinLnBrk="0" hangingPunct="1">
+      <a:defRPr sz="1200" kern="1200">
+        <a:solidFill>
+          <a:schemeClr val="tx1"/>
+        </a:solidFill>
+        <a:latin typeface="+mn-lt"/>
+        <a:ea typeface="+mn-ea"/>
+        <a:cs typeface="+mn-cs"/>
+      </a:defRPr>
+    </a:lvl7pPr>
+    <a:lvl8pPr marL="3200400" algn="l" defTabSz="457200" rtl="0" eaLnBrk="1" latinLnBrk="0" hangingPunct="1">
+      <a:defRPr sz="1200" kern="1200">
+        <a:solidFill>
+          <a:schemeClr val="tx1"/>
+        </a:solidFill>
+        <a:latin typeface="+mn-lt"/>
+        <a:ea typeface="+mn-ea"/>
+        <a:cs typeface="+mn-cs"/>
+      </a:defRPr>
+    </a:lvl8pPr>
+    <a:lvl9pPr marL="3657600" algn="l" defTabSz="457200" rtl="0" eaLnBrk="1" latinLnBrk="0" hangingPunct="1">
+      <a:defRPr sz="1200" kern="1200">
+        <a:solidFill>
+          <a:schemeClr val="tx1"/>
+        </a:solidFill>
+        <a:latin typeface="+mn-lt"/>
+        <a:ea typeface="+mn-ea"/>
+        <a:cs typeface="+mn-cs"/>
+      </a:defRPr>
+    </a:lvl9pPr>
+  </p:notesStyle>
+</p:notesMaster>
+</file>
+
+<file path=ppt/notesSlides/notesSlide1.xml><?xml version="1.0" encoding="utf-8"?>
+<p:notes xmlns:a="http://schemas.openxmlformats.org/drawingml/2006/main" xmlns:p="http://schemas.openxmlformats.org/presentationml/2006/main" xmlns:r="http://schemas.openxmlformats.org/officeDocument/2006/relationships">
+  <p:cSld>
+    <p:spTree>
+      <p:nvGrpSpPr>
+        <p:cNvPr id="1" name=""/>
+        <p:cNvGrpSpPr/>
+        <p:nvPr/>
+      </p:nvGrpSpPr>
+      <p:grpSpPr>
+        <a:xfrm>
+          <a:off x="0" y="0"/>
+          <a:ext cx="0" cy="0"/>
+          <a:chOff x="0" y="0"/>
+          <a:chExt cx="0" cy="0"/>
+        </a:xfrm>
+      </p:grpSpPr>
+      <p:sp>
+        <p:nvSpPr>
+          <p:cNvPr id="2" name="Slide Image Placeholder 1"/>
+          <p:cNvSpPr>
+            <a:spLocks noGrp="1"/>
+          </p:cNvSpPr>
+          <p:nvPr>
+            <p:ph type="sldImg" idx="2"/>
+          </p:nvPr>
+        </p:nvSpPr>
+        <p:spPr/>
+      </p:sp>
+      <p:sp>
+        <p:nvSpPr>
+          <p:cNvPr id="3" name="Notes Placeholder 2"/>
+          <p:cNvSpPr>
+            <a:spLocks noGrp="1"/>
+          </p:cNvSpPr>
+          <p:nvPr>
+            <p:ph type="body" idx="3" sz="quarter"/>
+          </p:nvPr>
+        </p:nvSpPr>
+        <p:spPr/>
+        <p:txBody>
+          <a:bodyPr/>
+          <a:lstStyle/>
+          <a:p>
+            <a:r>
+              <a:t>RonyGuard is a class concept, not a launched company. I will use future language throughout: the proposed app would provide real-time legal-rights guidance. This establishes the required fictitious (F) designation clearly before discussing the business case.</a:t>
+            </a:r>
+          </a:p>
+        </p:txBody>
+      </p:sp>
+      <p:sp>
+        <p:nvSpPr>
+          <p:cNvPr id="4" name="Slide Number Placeholder 3"/>
+          <p:cNvSpPr>
+            <a:spLocks noGrp="1"/>
+          </p:cNvSpPr>
+          <p:nvPr>
+            <p:ph type="sldNum" idx="5" sz="quarter"/>
+          </p:nvPr>
+        </p:nvSpPr>
+        <p:spPr/>
+      </p:sp>
+    </p:spTree>
+  </p:cSld>
+  <p:clrMapOvr>
+    <a:masterClrMapping/>
+  </p:clrMapOvr>
+</p:notes>
+</file>
+
+<file path=ppt/notesSlides/notesSlide2.xml><?xml version="1.0" encoding="utf-8"?>
+<p:notes xmlns:a="http://schemas.openxmlformats.org/drawingml/2006/main" xmlns:p="http://schemas.openxmlformats.org/presentationml/2006/main" xmlns:r="http://schemas.openxmlformats.org/officeDocument/2006/relationships">
+  <p:cSld>
+    <p:spTree>
+      <p:nvGrpSpPr>
+        <p:cNvPr id="1" name=""/>
+        <p:cNvGrpSpPr/>
+        <p:nvPr/>
+      </p:nvGrpSpPr>
+      <p:grpSpPr>
+        <a:xfrm>
+          <a:off x="0" y="0"/>
+          <a:ext cx="0" cy="0"/>
+          <a:chOff x="0" y="0"/>
+          <a:chExt cx="0" cy="0"/>
+        </a:xfrm>
+      </p:grpSpPr>
+      <p:sp>
+        <p:nvSpPr>
+          <p:cNvPr id="2" name="Slide Image Placeholder 1"/>
+          <p:cNvSpPr>
+            <a:spLocks noGrp="1"/>
+          </p:cNvSpPr>
+          <p:nvPr>
+            <p:ph type="sldImg" idx="2"/>
+          </p:nvPr>
+        </p:nvSpPr>
+        <p:spPr/>
+      </p:sp>
+      <p:sp>
+        <p:nvSpPr>
+          <p:cNvPr id="3" name="Notes Placeholder 2"/>
+          <p:cNvSpPr>
+            <a:spLocks noGrp="1"/>
+          </p:cNvSpPr>
+          <p:nvPr>
+            <p:ph type="body" idx="3" sz="quarter"/>
+          </p:nvPr>
+        </p:nvSpPr>
+        <p:spPr/>
+        <p:txBody>
+          <a:bodyPr/>
+          <a:lstStyle/>
+          <a:p>
+            <a:r>
+              <a:t>I define the problem in business terms, not only technical terms. The unmet need is large, frequent, and costly, creating a strong market opportunity. RonyGuard would target moments where conventional legal services are unavailable or unaffordable.</a:t>
+            </a:r>
+          </a:p>
+        </p:txBody>
+      </p:sp>
+      <p:sp>
+        <p:nvSpPr>
+          <p:cNvPr id="4" name="Slide Number Placeholder 3"/>
+          <p:cNvSpPr>
+            <a:spLocks noGrp="1"/>
+          </p:cNvSpPr>
+          <p:nvPr>
+            <p:ph type="sldNum" idx="5" sz="quarter"/>
+          </p:nvPr>
+        </p:nvSpPr>
+        <p:spPr/>
+      </p:sp>
+    </p:spTree>
+  </p:cSld>
+  <p:clrMapOvr>
+    <a:masterClrMapping/>
+  </p:clrMapOvr>
+</p:notes>
+</file>
+
+<file path=ppt/notesSlides/notesSlide3.xml><?xml version="1.0" encoding="utf-8"?>
+<p:notes xmlns:a="http://schemas.openxmlformats.org/drawingml/2006/main" xmlns:p="http://schemas.openxmlformats.org/presentationml/2006/main" xmlns:r="http://schemas.openxmlformats.org/officeDocument/2006/relationships">
+  <p:cSld>
+    <p:spTree>
+      <p:nvGrpSpPr>
+        <p:cNvPr id="1" name=""/>
+        <p:cNvGrpSpPr/>
+        <p:nvPr/>
+      </p:nvGrpSpPr>
+      <p:grpSpPr>
+        <a:xfrm>
+          <a:off x="0" y="0"/>
+          <a:ext cx="0" cy="0"/>
+          <a:chOff x="0" y="0"/>
+          <a:chExt cx="0" cy="0"/>
+        </a:xfrm>
+      </p:grpSpPr>
+      <p:sp>
+        <p:nvSpPr>
+          <p:cNvPr id="2" name="Slide Image Placeholder 1"/>
+          <p:cNvSpPr>
+            <a:spLocks noGrp="1"/>
+          </p:cNvSpPr>
+          <p:nvPr>
+            <p:ph type="sldImg" idx="2"/>
+          </p:nvPr>
+        </p:nvSpPr>
+        <p:spPr/>
+      </p:sp>
+      <p:sp>
+        <p:nvSpPr>
+          <p:cNvPr id="3" name="Notes Placeholder 2"/>
+          <p:cNvSpPr>
+            <a:spLocks noGrp="1"/>
+          </p:cNvSpPr>
+          <p:nvPr>
+            <p:ph type="body" idx="3" sz="quarter"/>
+          </p:nvPr>
+        </p:nvSpPr>
+        <p:spPr/>
+        <p:txBody>
+          <a:bodyPr/>
+          <a:lstStyle/>
+          <a:p>
+            <a:r>
+              <a:t>These are root causes, not a restatement of the problem. The justice gap persists because process, system, data, security, and strategy issues reinforce each other. This analysis justifies why a technology-enabled model is needed.</a:t>
+            </a:r>
+          </a:p>
+        </p:txBody>
+      </p:sp>
+      <p:sp>
+        <p:nvSpPr>
+          <p:cNvPr id="4" name="Slide Number Placeholder 3"/>
+          <p:cNvSpPr>
+            <a:spLocks noGrp="1"/>
+          </p:cNvSpPr>
+          <p:nvPr>
+            <p:ph type="sldNum" idx="5" sz="quarter"/>
+          </p:nvPr>
+        </p:nvSpPr>
+        <p:spPr/>
+      </p:sp>
+    </p:spTree>
+  </p:cSld>
+  <p:clrMapOvr>
+    <a:masterClrMapping/>
+  </p:clrMapOvr>
+</p:notes>
+</file>
+
+<file path=ppt/notesSlides/notesSlide4.xml><?xml version="1.0" encoding="utf-8"?>
+<p:notes xmlns:a="http://schemas.openxmlformats.org/drawingml/2006/main" xmlns:p="http://schemas.openxmlformats.org/presentationml/2006/main" xmlns:r="http://schemas.openxmlformats.org/officeDocument/2006/relationships">
+  <p:cSld>
+    <p:spTree>
+      <p:nvGrpSpPr>
+        <p:cNvPr id="1" name=""/>
+        <p:cNvGrpSpPr/>
+        <p:nvPr/>
+      </p:nvGrpSpPr>
+      <p:grpSpPr>
+        <a:xfrm>
+          <a:off x="0" y="0"/>
+          <a:ext cx="0" cy="0"/>
+          <a:chOff x="0" y="0"/>
+          <a:chExt cx="0" cy="0"/>
+        </a:xfrm>
+      </p:grpSpPr>
+      <p:sp>
+        <p:nvSpPr>
+          <p:cNvPr id="2" name="Slide Image Placeholder 1"/>
+          <p:cNvSpPr>
+            <a:spLocks noGrp="1"/>
+          </p:cNvSpPr>
+          <p:nvPr>
+            <p:ph type="sldImg" idx="2"/>
+          </p:nvPr>
+        </p:nvSpPr>
+        <p:spPr/>
+      </p:sp>
+      <p:sp>
+        <p:nvSpPr>
+          <p:cNvPr id="3" name="Notes Placeholder 2"/>
+          <p:cNvSpPr>
+            <a:spLocks noGrp="1"/>
+          </p:cNvSpPr>
+          <p:nvPr>
+            <p:ph type="body" idx="3" sz="quarter"/>
+          </p:nvPr>
+        </p:nvSpPr>
+        <p:spPr/>
+        <p:txBody>
+          <a:bodyPr/>
+          <a:lstStyle/>
+          <a:p>
+            <a:r>
+              <a:t>This slide links the business model to platform choices. SaaS supports predictable recurring revenue, while PaaS supports rapid scaling and lower operational burden. The value proposition is improved access at lower cost with sustainable economics.</a:t>
+            </a:r>
+          </a:p>
+        </p:txBody>
+      </p:sp>
+      <p:sp>
+        <p:nvSpPr>
+          <p:cNvPr id="4" name="Slide Number Placeholder 3"/>
+          <p:cNvSpPr>
+            <a:spLocks noGrp="1"/>
+          </p:cNvSpPr>
+          <p:nvPr>
+            <p:ph type="sldNum" idx="5" sz="quarter"/>
+          </p:nvPr>
+        </p:nvSpPr>
+        <p:spPr/>
+      </p:sp>
+    </p:spTree>
+  </p:cSld>
+  <p:clrMapOvr>
+    <a:masterClrMapping/>
+  </p:clrMapOvr>
+</p:notes>
+</file>
+
+<file path=ppt/notesSlides/notesSlide5.xml><?xml version="1.0" encoding="utf-8"?>
+<p:notes xmlns:a="http://schemas.openxmlformats.org/drawingml/2006/main" xmlns:p="http://schemas.openxmlformats.org/presentationml/2006/main" xmlns:r="http://schemas.openxmlformats.org/officeDocument/2006/relationships">
+  <p:cSld>
+    <p:spTree>
+      <p:nvGrpSpPr>
+        <p:cNvPr id="1" name=""/>
+        <p:cNvGrpSpPr/>
+        <p:nvPr/>
+      </p:nvGrpSpPr>
+      <p:grpSpPr>
+        <a:xfrm>
+          <a:off x="0" y="0"/>
+          <a:ext cx="0" cy="0"/>
+          <a:chOff x="0" y="0"/>
+          <a:chExt cx="0" cy="0"/>
+        </a:xfrm>
+      </p:grpSpPr>
+      <p:sp>
+        <p:nvSpPr>
+          <p:cNvPr id="2" name="Slide Image Placeholder 1"/>
+          <p:cNvSpPr>
+            <a:spLocks noGrp="1"/>
+          </p:cNvSpPr>
+          <p:nvPr>
+            <p:ph type="sldImg" idx="2"/>
+          </p:nvPr>
+        </p:nvSpPr>
+        <p:spPr/>
+      </p:sp>
+      <p:sp>
+        <p:nvSpPr>
+          <p:cNvPr id="3" name="Notes Placeholder 2"/>
+          <p:cNvSpPr>
+            <a:spLocks noGrp="1"/>
+          </p:cNvSpPr>
+          <p:nvPr>
+            <p:ph type="body" idx="3" sz="quarter"/>
+          </p:nvPr>
+        </p:nvSpPr>
+        <p:spPr/>
+        <p:txBody>
+          <a:bodyPr/>
+          <a:lstStyle/>
+          <a:p>
+            <a:r>
+              <a:t>Vector databases store embeddings so the system retrieves by meaning, not just keywords. Retrieval-augmented generation grounds model responses in trusted legal sources, which helps reduce hallucinations. Security is handled through encryption, access control, auditing, and resilience planning.</a:t>
+            </a:r>
+          </a:p>
+        </p:txBody>
+      </p:sp>
+      <p:sp>
+        <p:nvSpPr>
+          <p:cNvPr id="4" name="Slide Number Placeholder 3"/>
+          <p:cNvSpPr>
+            <a:spLocks noGrp="1"/>
+          </p:cNvSpPr>
+          <p:nvPr>
+            <p:ph type="sldNum" idx="5" sz="quarter"/>
+          </p:nvPr>
+        </p:nvSpPr>
+        <p:spPr/>
+      </p:sp>
+    </p:spTree>
+  </p:cSld>
+  <p:clrMapOvr>
+    <a:masterClrMapping/>
+  </p:clrMapOvr>
+</p:notes>
+</file>
+
+<file path=ppt/notesSlides/notesSlide6.xml><?xml version="1.0" encoding="utf-8"?>
+<p:notes xmlns:a="http://schemas.openxmlformats.org/drawingml/2006/main" xmlns:p="http://schemas.openxmlformats.org/presentationml/2006/main" xmlns:r="http://schemas.openxmlformats.org/officeDocument/2006/relationships">
+  <p:cSld>
+    <p:spTree>
+      <p:nvGrpSpPr>
+        <p:cNvPr id="1" name=""/>
+        <p:cNvGrpSpPr/>
+        <p:nvPr/>
+      </p:nvGrpSpPr>
+      <p:grpSpPr>
+        <a:xfrm>
+          <a:off x="0" y="0"/>
+          <a:ext cx="0" cy="0"/>
+          <a:chOff x="0" y="0"/>
+          <a:chExt cx="0" cy="0"/>
+        </a:xfrm>
+      </p:grpSpPr>
+      <p:sp>
+        <p:nvSpPr>
+          <p:cNvPr id="2" name="Slide Image Placeholder 1"/>
+          <p:cNvSpPr>
+            <a:spLocks noGrp="1"/>
+          </p:cNvSpPr>
+          <p:nvPr>
+            <p:ph type="sldImg" idx="2"/>
+          </p:nvPr>
+        </p:nvSpPr>
+        <p:spPr/>
+      </p:sp>
+      <p:sp>
+        <p:nvSpPr>
+          <p:cNvPr id="3" name="Notes Placeholder 2"/>
+          <p:cNvSpPr>
+            <a:spLocks noGrp="1"/>
+          </p:cNvSpPr>
+          <p:nvPr>
+            <p:ph type="body" idx="3" sz="quarter"/>
+          </p:nvPr>
+        </p:nvSpPr>
+        <p:spPr/>
+        <p:txBody>
+          <a:bodyPr/>
+          <a:lstStyle/>
+          <a:p>
+            <a:r>
+              <a:t>I will walk left-to-right on the chart: traditional legal help is high-cost and episodic, while RonyGuard is low-cost and recurring. Then I connect MRR and ARR to subscription scalability, followed by estimated operating costs and margin potential. This directly satisfies the rubric requirement for revenue-and-expense visualization tied to the business case.</a:t>
+            </a:r>
+          </a:p>
+        </p:txBody>
+      </p:sp>
+      <p:sp>
+        <p:nvSpPr>
+          <p:cNvPr id="4" name="Slide Number Placeholder 3"/>
+          <p:cNvSpPr>
+            <a:spLocks noGrp="1"/>
+          </p:cNvSpPr>
+          <p:nvPr>
+            <p:ph type="sldNum" idx="5" sz="quarter"/>
+          </p:nvPr>
+        </p:nvSpPr>
+        <p:spPr/>
+      </p:sp>
+    </p:spTree>
+  </p:cSld>
+  <p:clrMapOvr>
+    <a:masterClrMapping/>
+  </p:clrMapOvr>
+</p:notes>
+</file>
+
+<file path=ppt/notesSlides/notesSlide7.xml><?xml version="1.0" encoding="utf-8"?>
+<p:notes xmlns:a="http://schemas.openxmlformats.org/drawingml/2006/main" xmlns:p="http://schemas.openxmlformats.org/presentationml/2006/main" xmlns:r="http://schemas.openxmlformats.org/officeDocument/2006/relationships">
+  <p:cSld>
+    <p:spTree>
+      <p:nvGrpSpPr>
+        <p:cNvPr id="1" name=""/>
+        <p:cNvGrpSpPr/>
+        <p:nvPr/>
+      </p:nvGrpSpPr>
+      <p:grpSpPr>
+        <a:xfrm>
+          <a:off x="0" y="0"/>
+          <a:ext cx="0" cy="0"/>
+          <a:chOff x="0" y="0"/>
+          <a:chExt cx="0" cy="0"/>
+        </a:xfrm>
+      </p:grpSpPr>
+      <p:sp>
+        <p:nvSpPr>
+          <p:cNvPr id="2" name="Slide Image Placeholder 1"/>
+          <p:cNvSpPr>
+            <a:spLocks noGrp="1"/>
+          </p:cNvSpPr>
+          <p:nvPr>
+            <p:ph type="sldImg" idx="2"/>
+          </p:nvPr>
+        </p:nvSpPr>
+        <p:spPr/>
+      </p:sp>
+      <p:sp>
+        <p:nvSpPr>
+          <p:cNvPr id="3" name="Notes Placeholder 2"/>
+          <p:cNvSpPr>
+            <a:spLocks noGrp="1"/>
+          </p:cNvSpPr>
+          <p:nvPr>
+            <p:ph type="body" idx="3" sz="quarter"/>
+          </p:nvPr>
+        </p:nvSpPr>
+        <p:spPr/>
+        <p:txBody>
+          <a:bodyPr/>
+          <a:lstStyle/>
+          <a:p>
+            <a:r>
+              <a:t>Thank you for your time. RonyGuard is a realistic but fictitious model showing how MIS concepts can produce both social impact and business value. I am happy to answer questions on architecture, security controls, and financial assumptions.</a:t>
+            </a:r>
+          </a:p>
+        </p:txBody>
+      </p:sp>
+      <p:sp>
+        <p:nvSpPr>
+          <p:cNvPr id="4" name="Slide Number Placeholder 3"/>
+          <p:cNvSpPr>
+            <a:spLocks noGrp="1"/>
+          </p:cNvSpPr>
+          <p:nvPr>
+            <p:ph type="sldNum" idx="5" sz="quarter"/>
+          </p:nvPr>
+        </p:nvSpPr>
+        <p:spPr/>
+      </p:sp>
+    </p:spTree>
+  </p:cSld>
+  <p:clrMapOvr>
+    <a:masterClrMapping/>
+  </p:clrMapOvr>
+</p:notes>
 </file>
 
 <file path=ppt/slideLayouts/slideLayout1.xml><?xml version="1.0" encoding="utf-8"?>
@@ -3272,14 +4142,8 @@
           <a:bodyPr rtlCol="0" anchor="ctr"/>
           <a:lstStyle/>
           <a:p>
-            <a:pPr algn="l"/>
-            <a:r>
-              <a:rPr b="1" sz="2800">
-                <a:solidFill>
-                  <a:srgbClr val="FFFFFF"/>
-                </a:solidFill>
-              </a:rPr>
-              <a:t>Project Overview</a:t>
+            <a:r>
+              <a:t>Section 1 – Public or Fictitious Company: RonyGuard</a:t>
             </a:r>
           </a:p>
         </p:txBody>
@@ -3317,65 +4181,35 @@
               </a:defRPr>
             </a:pPr>
             <a:r>
-              <a:t>LexiGuard AI: Real-Time Legal Rights Assistant</a:t>
-            </a:r>
-          </a:p>
-          <a:p>
-            <a:pPr>
-              <a:spcAft>
-                <a:spcPts val="800"/>
-              </a:spcAft>
-              <a:defRPr sz="2400">
-                <a:solidFill>
-                  <a:srgbClr val="191919"/>
-                </a:solidFill>
-              </a:defRPr>
-            </a:pPr>
-            <a:r>
-              <a:t>Ronald Kipkemboi | CIS-421 | Shaw University</a:t>
-            </a:r>
-          </a:p>
-          <a:p>
-            <a:pPr>
-              <a:spcAft>
-                <a:spcPts val="800"/>
-              </a:spcAft>
-              <a:defRPr sz="2400">
-                <a:solidFill>
-                  <a:srgbClr val="191919"/>
-                </a:solidFill>
-              </a:defRPr>
-            </a:pPr>
-            <a:r>
-              <a:t>Company Designation: Fictitious (F)</a:t>
-            </a:r>
-          </a:p>
-        </p:txBody>
-      </p:sp>
-      <p:pic>
-        <p:nvPicPr>
-          <p:cNvPr id="4" name="Picture 3" descr="s1.png"/>
-          <p:cNvPicPr>
-            <a:picLocks noChangeAspect="1"/>
-          </p:cNvPicPr>
-          <p:nvPr/>
-        </p:nvPicPr>
-        <p:blipFill>
-          <a:blip r:embed="rId2"/>
-          <a:stretch>
-            <a:fillRect/>
-          </a:stretch>
-        </p:blipFill>
-        <p:spPr>
-          <a:xfrm>
-            <a:off x="6675120" y="1188720"/>
-            <a:ext cx="5212080" cy="5303520"/>
-          </a:xfrm>
-          <a:prstGeom prst="rect">
-            <a:avLst/>
-          </a:prstGeom>
-        </p:spPr>
-      </p:pic>
+              <a:t>Company Type: Fictitious (F)</a:t>
+            </a:r>
+          </a:p>
+          <a:p>
+            <a:pPr/>
+            <a:r>
+              <a:t>RonyGuard is a fictitious (F) legal-technology startup created for this CIS-421 project.</a:t>
+            </a:r>
+          </a:p>
+          <a:p>
+            <a:pPr/>
+            <a:r>
+              <a:t>Industry: Legal technology / justice access; proposed mobile + cloud legal rights assistant.</a:t>
+            </a:r>
+          </a:p>
+          <a:p>
+            <a:pPr/>
+            <a:r>
+              <a:t>Mission: RonyGuard plans to make legal-rights guidance fast, affordable, and privacy-preserving.</a:t>
+            </a:r>
+          </a:p>
+          <a:p>
+            <a:pPr/>
+            <a:r>
+              <a:t>Presented by Ronald Kipkemboi | CIS-421 | Shaw University | Spring 2026</a:t>
+            </a:r>
+          </a:p>
+        </p:txBody>
+      </p:sp>
     </p:spTree>
   </p:cSld>
   <p:clrMapOvr>
@@ -3441,14 +4275,8 @@
           <a:bodyPr rtlCol="0" anchor="ctr"/>
           <a:lstStyle/>
           <a:p>
-            <a:pPr algn="l"/>
-            <a:r>
-              <a:rPr b="1" sz="2800">
-                <a:solidFill>
-                  <a:srgbClr val="FFFFFF"/>
-                </a:solidFill>
-              </a:rPr>
-              <a:t>Section 2 – Defined the Problem</a:t>
+            <a:r>
+              <a:t>Section 2 – Defined the Problem: The Justice Gap &amp; Legal Amnesia</a:t>
             </a:r>
           </a:p>
         </p:txBody>
@@ -3486,65 +4314,35 @@
               </a:defRPr>
             </a:pPr>
             <a:r>
-              <a:t>Legal Amnesia: stress-induced inability to recall legal rights during encounters.</a:t>
-            </a:r>
-          </a:p>
-          <a:p>
-            <a:pPr>
-              <a:spcAft>
-                <a:spcPts val="800"/>
-              </a:spcAft>
-              <a:defRPr sz="2100">
-                <a:solidFill>
-                  <a:srgbClr val="191919"/>
-                </a:solidFill>
-              </a:defRPr>
-            </a:pPr>
-            <a:r>
-              <a:t>Appears in police stops, landlord disputes, and other high-pressure legal situations.</a:t>
-            </a:r>
-          </a:p>
-          <a:p>
-            <a:pPr>
-              <a:spcAft>
-                <a:spcPts val="800"/>
-              </a:spcAft>
-              <a:defRPr sz="2100">
-                <a:solidFill>
-                  <a:srgbClr val="191919"/>
-                </a:solidFill>
-              </a:defRPr>
-            </a:pPr>
-            <a:r>
-              <a:t>Disproportionately harms low-income individuals and students who lack immediate legal support.</a:t>
-            </a:r>
-          </a:p>
-        </p:txBody>
-      </p:sp>
-      <p:pic>
-        <p:nvPicPr>
-          <p:cNvPr id="4" name="Picture 3" descr="s2.png"/>
-          <p:cNvPicPr>
-            <a:picLocks noChangeAspect="1"/>
-          </p:cNvPicPr>
-          <p:nvPr/>
-        </p:nvPicPr>
-        <p:blipFill>
-          <a:blip r:embed="rId2"/>
-          <a:stretch>
-            <a:fillRect/>
-          </a:stretch>
-        </p:blipFill>
-        <p:spPr>
-          <a:xfrm>
-            <a:off x="6675120" y="1188720"/>
-            <a:ext cx="5212080" cy="5303520"/>
-          </a:xfrm>
-          <a:prstGeom prst="rect">
-            <a:avLst/>
-          </a:prstGeom>
-        </p:spPr>
-      </p:pic>
+              <a:t>Issue: During high-stress encounters, people often experience “legal amnesia” and cannot recall or apply their rights.</a:t>
+            </a:r>
+          </a:p>
+          <a:p>
+            <a:pPr/>
+            <a:r>
+              <a:t>Who it affects: Students, low-income individuals, and the public in police stops, landlord disputes, and workplace conflicts.</a:t>
+            </a:r>
+          </a:p>
+          <a:p>
+            <a:pPr/>
+            <a:r>
+              <a:t>Business impact: Traditional legal support is expensive and slow for real-time moments.</a:t>
+            </a:r>
+          </a:p>
+          <a:p>
+            <a:pPr/>
+            <a:r>
+              <a:t>Opportunity: This underserved market supports a scalable subscription model for proposed 24/7 guidance.</a:t>
+            </a:r>
+          </a:p>
+          <a:p>
+            <a:pPr/>
+            <a:r>
+              <a:t>RonyGuard would address this gap with immediate, plain-language rights assistance.</a:t>
+            </a:r>
+          </a:p>
+        </p:txBody>
+      </p:sp>
     </p:spTree>
   </p:cSld>
   <p:clrMapOvr>
@@ -3610,14 +4408,8 @@
           <a:bodyPr rtlCol="0" anchor="ctr"/>
           <a:lstStyle/>
           <a:p>
-            <a:pPr algn="l"/>
-            <a:r>
-              <a:rPr b="1" sz="2800">
-                <a:solidFill>
-                  <a:srgbClr val="FFFFFF"/>
-                </a:solidFill>
-              </a:rPr>
-              <a:t>Section 3 – Identified the Causes</a:t>
+            <a:r>
+              <a:t>Section 3 – Identified the Root Causes of the Justice Gap</a:t>
             </a:r>
           </a:p>
         </p:txBody>
@@ -3655,65 +4447,35 @@
               </a:defRPr>
             </a:pPr>
             <a:r>
-              <a:t>Inefficient manual legal aid workflows delay access to actionable guidance.</a:t>
-            </a:r>
-          </a:p>
-          <a:p>
-            <a:pPr>
-              <a:spcAft>
-                <a:spcPts val="800"/>
-              </a:spcAft>
-              <a:defRPr sz="2100">
-                <a:solidFill>
-                  <a:srgbClr val="191919"/>
-                </a:solidFill>
-              </a:defRPr>
-            </a:pPr>
-            <a:r>
-              <a:t>Lack of real-time digital 'bridges' to legal codes leaves users unsupported in the moment.</a:t>
-            </a:r>
-          </a:p>
-          <a:p>
-            <a:pPr>
-              <a:spcAft>
-                <a:spcPts val="800"/>
-              </a:spcAft>
-              <a:defRPr sz="2100">
-                <a:solidFill>
-                  <a:srgbClr val="191919"/>
-                </a:solidFill>
-              </a:defRPr>
-            </a:pPr>
-            <a:r>
-              <a:t>The traditional 'Billable Hour' model discourages automation and scalable access.</a:t>
-            </a:r>
-          </a:p>
-        </p:txBody>
-      </p:sp>
-      <p:pic>
-        <p:nvPicPr>
-          <p:cNvPr id="4" name="Picture 3" descr="s3.png"/>
-          <p:cNvPicPr>
-            <a:picLocks noChangeAspect="1"/>
-          </p:cNvPicPr>
-          <p:nvPr/>
-        </p:nvPicPr>
-        <p:blipFill>
-          <a:blip r:embed="rId2"/>
-          <a:stretch>
-            <a:fillRect/>
-          </a:stretch>
-        </p:blipFill>
-        <p:spPr>
-          <a:xfrm>
-            <a:off x="6675120" y="1188720"/>
-            <a:ext cx="5212080" cy="5303520"/>
-          </a:xfrm>
-          <a:prstGeom prst="rect">
-            <a:avLst/>
-          </a:prstGeom>
-        </p:spPr>
-      </p:pic>
+              <a:t>Inefficient, reactive processes: Legal help usually starts after incidents rather than during them.</a:t>
+            </a:r>
+          </a:p>
+          <a:p>
+            <a:pPr/>
+            <a:r>
+              <a:t>Outdated or missing information systems: Dense legal documents are hard to search quickly on mobile devices.</a:t>
+            </a:r>
+          </a:p>
+          <a:p>
+            <a:pPr/>
+            <a:r>
+              <a:t>Poor data management and analytics: Everyday rights questions are under-tracked, limiting service optimization.</a:t>
+            </a:r>
+          </a:p>
+          <a:p>
+            <a:pPr/>
+            <a:r>
+              <a:t>Security and infrastructure concerns: Fear of surveillance or misuse discourages people from seeking help.</a:t>
+            </a:r>
+          </a:p>
+          <a:p>
+            <a:pPr/>
+            <a:r>
+              <a:t>Organizational and strategic gaps: Billable-hour incentives reduce investment in low-cost public legal tools.</a:t>
+            </a:r>
+          </a:p>
+        </p:txBody>
+      </p:sp>
     </p:spTree>
   </p:cSld>
   <p:clrMapOvr>
@@ -3779,14 +4541,8 @@
           <a:bodyPr rtlCol="0" anchor="ctr"/>
           <a:lstStyle/>
           <a:p>
-            <a:pPr algn="l"/>
-            <a:r>
-              <a:rPr b="1" sz="2800">
-                <a:solidFill>
-                  <a:srgbClr val="FFFFFF"/>
-                </a:solidFill>
-              </a:rPr>
-              <a:t>Section 4 – Specified Solution (Architecture)</a:t>
+            <a:r>
+              <a:t>Section 4 – Specified Solution &amp; Technology Platform (Business Perspective)</a:t>
             </a:r>
           </a:p>
         </p:txBody>
@@ -3824,65 +4580,35 @@
               </a:defRPr>
             </a:pPr>
             <a:r>
-              <a:t>Delivery model: Software as a Service (SaaS).</a:t>
-            </a:r>
-          </a:p>
-          <a:p>
-            <a:pPr>
-              <a:spcAft>
-                <a:spcPts val="800"/>
-              </a:spcAft>
-              <a:defRPr sz="2100">
-                <a:solidFill>
-                  <a:srgbClr val="191919"/>
-                </a:solidFill>
-              </a:defRPr>
-            </a:pPr>
-            <a:r>
-              <a:t>Core platform: Platform as a Service (PaaS) on Google Vertex AI.</a:t>
-            </a:r>
-          </a:p>
-          <a:p>
-            <a:pPr>
-              <a:spcAft>
-                <a:spcPts val="800"/>
-              </a:spcAft>
-              <a:defRPr sz="2100">
-                <a:solidFill>
-                  <a:srgbClr val="191919"/>
-                </a:solidFill>
-              </a:defRPr>
-            </a:pPr>
-            <a:r>
-              <a:t>Development approach: Agile lifecycle with iterative releases and user feedback loops.</a:t>
-            </a:r>
-          </a:p>
-        </p:txBody>
-      </p:sp>
-      <p:pic>
-        <p:nvPicPr>
-          <p:cNvPr id="4" name="Picture 3" descr="s4.png"/>
-          <p:cNvPicPr>
-            <a:picLocks noChangeAspect="1"/>
-          </p:cNvPicPr>
-          <p:nvPr/>
-        </p:nvPicPr>
-        <p:blipFill>
-          <a:blip r:embed="rId2"/>
-          <a:stretch>
-            <a:fillRect/>
-          </a:stretch>
-        </p:blipFill>
-        <p:spPr>
-          <a:xfrm>
-            <a:off x="6675120" y="1188720"/>
-            <a:ext cx="5212080" cy="5303520"/>
-          </a:xfrm>
-          <a:prstGeom prst="rect">
-            <a:avLst/>
-          </a:prstGeom>
-        </p:spPr>
-      </p:pic>
+              <a:t>Solution: RonyGuard proposes a mobile app that would deliver real-time rights information and next-step guidance.</a:t>
+            </a:r>
+          </a:p>
+          <a:p>
+            <a:pPr/>
+            <a:r>
+              <a:t>SaaS: Mobile app + web portal offered as a subscription service for end users.</a:t>
+            </a:r>
+          </a:p>
+          <a:p>
+            <a:pPr/>
+            <a:r>
+              <a:t>PaaS: Vertex AI (or similar) would host AI inference and support scalable deployments.</a:t>
+            </a:r>
+          </a:p>
+          <a:p>
+            <a:pPr/>
+            <a:r>
+              <a:t>Platform fit: Reduces infrastructure overhead, accelerates releases, and supports modular legal-content expansion.</a:t>
+            </a:r>
+          </a:p>
+          <a:p>
+            <a:pPr/>
+            <a:r>
+              <a:t>Strategic impact: Converts one-time consultations into recurring revenue while expanding access without adding lawyers.</a:t>
+            </a:r>
+          </a:p>
+        </p:txBody>
+      </p:sp>
     </p:spTree>
   </p:cSld>
   <p:clrMapOvr>
@@ -3948,14 +4674,8 @@
           <a:bodyPr rtlCol="0" anchor="ctr"/>
           <a:lstStyle/>
           <a:p>
-            <a:pPr algn="l"/>
-            <a:r>
-              <a:rPr b="1" sz="2800">
-                <a:solidFill>
-                  <a:srgbClr val="FFFFFF"/>
-                </a:solidFill>
-              </a:rPr>
-              <a:t>Section 4 – Technology Platform</a:t>
+            <a:r>
+              <a:t>Section 4 (cont.) – Technology, Networking, Databases, Security, and Project Management</a:t>
             </a:r>
           </a:p>
         </p:txBody>
@@ -3993,80 +4713,35 @@
               </a:defRPr>
             </a:pPr>
             <a:r>
-              <a:t>Networking: 5G/LTE for low-latency mobile connectivity.</a:t>
-            </a:r>
-          </a:p>
-          <a:p>
-            <a:pPr>
-              <a:spcAft>
-                <a:spcPts val="800"/>
-              </a:spcAft>
-              <a:defRPr sz="2000">
-                <a:solidFill>
-                  <a:srgbClr val="191919"/>
-                </a:solidFill>
-              </a:defRPr>
-            </a:pPr>
-            <a:r>
-              <a:t>Databases: Vector Database (Pinecone) for semantic legal retrieval.</a:t>
-            </a:r>
-          </a:p>
-          <a:p>
-            <a:pPr>
-              <a:spcAft>
-                <a:spcPts val="800"/>
-              </a:spcAft>
-              <a:defRPr sz="2000">
-                <a:solidFill>
-                  <a:srgbClr val="191919"/>
-                </a:solidFill>
-              </a:defRPr>
-            </a:pPr>
-            <a:r>
-              <a:t>Security: AES-256 encryption and biometrics for secure access.</a:t>
-            </a:r>
-          </a:p>
-          <a:p>
-            <a:pPr>
-              <a:spcAft>
-                <a:spcPts val="800"/>
-              </a:spcAft>
-              <a:defRPr sz="2000">
-                <a:solidFill>
-                  <a:srgbClr val="191919"/>
-                </a:solidFill>
-              </a:defRPr>
-            </a:pPr>
-            <a:r>
-              <a:t>AI: NLP + Speech-to-Text for real-time rights guidance.</a:t>
-            </a:r>
-          </a:p>
-        </p:txBody>
-      </p:sp>
-      <p:pic>
-        <p:nvPicPr>
-          <p:cNvPr id="4" name="Picture 3" descr="s5.png"/>
-          <p:cNvPicPr>
-            <a:picLocks noChangeAspect="1"/>
-          </p:cNvPicPr>
-          <p:nvPr/>
-        </p:nvPicPr>
-        <p:blipFill>
-          <a:blip r:embed="rId2"/>
-          <a:stretch>
-            <a:fillRect/>
-          </a:stretch>
-        </p:blipFill>
-        <p:spPr>
-          <a:xfrm>
-            <a:off x="6675120" y="1188720"/>
-            <a:ext cx="5212080" cy="5303520"/>
-          </a:xfrm>
-          <a:prstGeom prst="rect">
-            <a:avLst/>
-          </a:prstGeom>
-        </p:spPr>
-      </p:pic>
+              <a:t>Networking: Mobile clients would use HTTPS REST APIs over 5G/LTE/Wi-Fi for low-latency responses.</a:t>
+            </a:r>
+          </a:p>
+          <a:p>
+            <a:pPr/>
+            <a:r>
+              <a:t>Data and analytics: A vector database (e.g., Pinecone) would enable semantic retrieval from legal texts and FAQs.</a:t>
+            </a:r>
+          </a:p>
+          <a:p>
+            <a:pPr/>
+            <a:r>
+              <a:t>Security controls: AES-256 at rest, TLS in transit, biometric app lock, RBAC, audit logs, backups, and disaster recovery.</a:t>
+            </a:r>
+          </a:p>
+          <a:p>
+            <a:pPr/>
+            <a:r>
+              <a:t>Enterprise AI: Vertex AI models + retrieval-augmented generation would improve relevance and reduce hallucinations.</a:t>
+            </a:r>
+          </a:p>
+          <a:p>
+            <a:pPr/>
+            <a:r>
+              <a:t>Development and global scope: Agile sprints, MVP feedback loops, and localization by jurisdiction/language.</a:t>
+            </a:r>
+          </a:p>
+        </p:txBody>
+      </p:sp>
     </p:spTree>
   </p:cSld>
   <p:clrMapOvr>
@@ -4132,13 +4807,7 @@
           <a:bodyPr rtlCol="0" anchor="ctr"/>
           <a:lstStyle/>
           <a:p>
-            <a:pPr algn="l"/>
-            <a:r>
-              <a:rPr b="1" sz="2800">
-                <a:solidFill>
-                  <a:srgbClr val="FFFFFF"/>
-                </a:solidFill>
-              </a:rPr>
+            <a:r>
               <a:t>Section 5 – Revenue and Expense Visualization</a:t>
             </a:r>
           </a:p>
@@ -4195,37 +4864,19 @@
               </a:defRPr>
             </a:pPr>
             <a:r>
-              <a:t>Traditional Lawyer: $300/hr</a:t>
-            </a:r>
-          </a:p>
-          <a:p>
-            <a:pPr>
-              <a:spcAft>
-                <a:spcPts val="1000"/>
-              </a:spcAft>
-              <a:defRPr sz="2100" b="0">
-                <a:solidFill>
-                  <a:srgbClr val="0E2A5C"/>
-                </a:solidFill>
-              </a:defRPr>
-            </a:pPr>
-            <a:r>
-              <a:t>LexiGuard AI: $15/mo</a:t>
-            </a:r>
-          </a:p>
-          <a:p>
-            <a:pPr>
-              <a:spcAft>
-                <a:spcPts val="1000"/>
-              </a:spcAft>
-              <a:defRPr sz="2400" b="1">
-                <a:solidFill>
-                  <a:srgbClr val="0E2A5C"/>
-                </a:solidFill>
-              </a:defRPr>
-            </a:pPr>
-            <a:r>
-              <a:t>≈95% cost reduction to help close the Justice Gap.</a:t>
+              <a:t>Cost comparison: Traditional consultation ≈ $600 (2 hours × $300/hr) vs. RonyGuard at $15/month for ongoing guidance.</a:t>
+            </a:r>
+          </a:p>
+          <a:p>
+            <a:pPr/>
+            <a:r>
+              <a:t>Revenue projection: 10,000 subscribers × $15/month = $150,000 MRR (~$1.8M ARR).</a:t>
+            </a:r>
+          </a:p>
+          <a:p>
+            <a:pPr/>
+            <a:r>
+              <a:t>Expense and ROI: Estimated cloud + operations cost ≈ $40,000/month, supporting strong gross-margin potential as users scale.</a:t>
             </a:r>
           </a:p>
         </p:txBody>
@@ -4295,14 +4946,8 @@
           <a:bodyPr rtlCol="0" anchor="ctr"/>
           <a:lstStyle/>
           <a:p>
-            <a:pPr algn="l"/>
-            <a:r>
-              <a:rPr b="1" sz="2800">
-                <a:solidFill>
-                  <a:srgbClr val="FFFFFF"/>
-                </a:solidFill>
-              </a:rPr>
-              <a:t>Evaluation Notes</a:t>
+            <a:r>
+              <a:t>Conclusion &amp; Evaluation</a:t>
             </a:r>
           </a:p>
         </p:txBody>
@@ -4340,65 +4985,35 @@
               </a:defRPr>
             </a:pPr>
             <a:r>
-              <a:t>LexiGuard AI is built for scalability across institutions and user populations.</a:t>
-            </a:r>
-          </a:p>
-          <a:p>
-            <a:pPr>
-              <a:spcAft>
-                <a:spcPts val="800"/>
-              </a:spcAft>
-              <a:defRPr sz="2100">
-                <a:solidFill>
-                  <a:srgbClr val="191919"/>
-                </a:solidFill>
-              </a:defRPr>
-            </a:pPr>
-            <a:r>
-              <a:t>The project aligns to all CIS-421 rubric sections and required course concepts.</a:t>
-            </a:r>
-          </a:p>
-          <a:p>
-            <a:pPr>
-              <a:spcAft>
-                <a:spcPts val="800"/>
-              </a:spcAft>
-              <a:defRPr sz="2100">
-                <a:solidFill>
-                  <a:srgbClr val="191919"/>
-                </a:solidFill>
-              </a:defRPr>
-            </a:pPr>
-            <a:r>
-              <a:t>The presentation demonstrates problem definition, cause analysis, solution architecture, and value impact.</a:t>
-            </a:r>
-          </a:p>
-        </p:txBody>
-      </p:sp>
-      <p:pic>
-        <p:nvPicPr>
-          <p:cNvPr id="4" name="Picture 3" descr="s7.png"/>
-          <p:cNvPicPr>
-            <a:picLocks noChangeAspect="1"/>
-          </p:cNvPicPr>
-          <p:nvPr/>
-        </p:nvPicPr>
-        <p:blipFill>
-          <a:blip r:embed="rId2"/>
-          <a:stretch>
-            <a:fillRect/>
-          </a:stretch>
-        </p:blipFill>
-        <p:spPr>
-          <a:xfrm>
-            <a:off x="6675120" y="1188720"/>
-            <a:ext cx="5212080" cy="5303520"/>
-          </a:xfrm>
-          <a:prstGeom prst="rect">
-            <a:avLst/>
-          </a:prstGeom>
-        </p:spPr>
-      </p:pic>
+              <a:t>Section 1: RonyGuard is clearly identified as a fictitious (F) legal-tech company for CIS-421.</a:t>
+            </a:r>
+          </a:p>
+          <a:p>
+            <a:pPr/>
+            <a:r>
+              <a:t>Sections 2–3: The justice-gap problem and legal-amnesia context are defined, with root causes across process, systems, data, security, and strategy.</a:t>
+            </a:r>
+          </a:p>
+          <a:p>
+            <a:pPr/>
+            <a:r>
+              <a:t>Section 4: The solution and platform are specified using SaaS/PaaS plus networking, databases, AI, security controls, Agile development, and global considerations.</a:t>
+            </a:r>
+          </a:p>
+          <a:p>
+            <a:pPr/>
+            <a:r>
+              <a:t>Section 5: A labeled financial chart shows cost savings, recurring-revenue potential, and expense/ROI logic.</a:t>
+            </a:r>
+          </a:p>
+          <a:p>
+            <a:pPr/>
+            <a:r>
+              <a:t>Closing: RonyGuard shows how MIS and AI can help close the justice gap through an accessible, scalable service.</a:t>
+            </a:r>
+          </a:p>
+        </p:txBody>
+      </p:sp>
     </p:spTree>
   </p:cSld>
   <p:clrMapOvr>
@@ -4725,4 +5340,324 @@
   </a:objectDefaults>
   <a:extraClrSchemeLst/>
 </a:theme>
+</file>
+
+<file path=ppt/theme/theme2.xml><?xml version="1.0" encoding="utf-8"?>
+<a:theme xmlns:a="http://schemas.openxmlformats.org/drawingml/2006/main" name="Office Theme">
+  <a:themeElements>
+    <a:clrScheme name="Office">
+      <a:dk1>
+        <a:sysClr val="windowText" lastClr="000000"/>
+      </a:dk1>
+      <a:lt1>
+        <a:sysClr val="window" lastClr="FFFFFF"/>
+      </a:lt1>
+      <a:dk2>
+        <a:srgbClr val="1F497D"/>
+      </a:dk2>
+      <a:lt2>
+        <a:srgbClr val="EEECE1"/>
+      </a:lt2>
+      <a:accent1>
+        <a:srgbClr val="4F81BD"/>
+      </a:accent1>
+      <a:accent2>
+        <a:srgbClr val="C0504D"/>
+      </a:accent2>
+      <a:accent3>
+        <a:srgbClr val="9BBB59"/>
+      </a:accent3>
+      <a:accent4>
+        <a:srgbClr val="8064A2"/>
+      </a:accent4>
+      <a:accent5>
+        <a:srgbClr val="4BACC6"/>
+      </a:accent5>
+      <a:accent6>
+        <a:srgbClr val="F79646"/>
+      </a:accent6>
+      <a:hlink>
+        <a:srgbClr val="0000FF"/>
+      </a:hlink>
+      <a:folHlink>
+        <a:srgbClr val="800080"/>
+      </a:folHlink>
+    </a:clrScheme>
+    <a:fontScheme name="Office">
+      <a:majorFont>
+        <a:latin typeface="Calibri"/>
+        <a:ea typeface=""/>
+        <a:cs typeface=""/>
+        <a:font script="Jpan" typeface="ＭＳ Ｐゴシック"/>
+        <a:font script="Hang" typeface="맑은 고딕"/>
+        <a:font script="Hans" typeface="宋体"/>
+        <a:font script="Hant" typeface="新細明體"/>
+        <a:font script="Arab" typeface="Times New Roman"/>
+        <a:font script="Hebr" typeface="Times New Roman"/>
+        <a:font script="Thai" typeface="Angsana New"/>
+        <a:font script="Ethi" typeface="Nyala"/>
+        <a:font script="Beng" typeface="Vrinda"/>
+        <a:font script="Gujr" typeface="Shruti"/>
+        <a:font script="Khmr" typeface="MoolBoran"/>
+        <a:font script="Knda" typeface="Tunga"/>
+        <a:font script="Guru" typeface="Raavi"/>
+        <a:font script="Cans" typeface="Euphemia"/>
+        <a:font script="Cher" typeface="Plantagenet Cherokee"/>
+        <a:font script="Yiii" typeface="Microsoft Yi Baiti"/>
+        <a:font script="Tibt" typeface="Microsoft Himalaya"/>
+        <a:font script="Thaa" typeface="MV Boli"/>
+        <a:font script="Deva" typeface="Mangal"/>
+        <a:font script="Telu" typeface="Gautami"/>
+        <a:font script="Taml" typeface="Latha"/>
+        <a:font script="Syrc" typeface="Estrangelo Edessa"/>
+        <a:font script="Orya" typeface="Kalinga"/>
+        <a:font script="Mlym" typeface="Kartika"/>
+        <a:font script="Laoo" typeface="DokChampa"/>
+        <a:font script="Sinh" typeface="Iskoola Pota"/>
+        <a:font script="Mong" typeface="Mongolian Baiti"/>
+        <a:font script="Viet" typeface="Times New Roman"/>
+        <a:font script="Uigh" typeface="Microsoft Uighur"/>
+        <a:font script="Geor" typeface="Sylfaen"/>
+      </a:majorFont>
+      <a:minorFont>
+        <a:latin typeface="Calibri"/>
+        <a:ea typeface=""/>
+        <a:cs typeface=""/>
+        <a:font script="Jpan" typeface="ＭＳ Ｐゴシック"/>
+        <a:font script="Hang" typeface="맑은 고딕"/>
+        <a:font script="Hans" typeface="宋体"/>
+        <a:font script="Hant" typeface="新細明體"/>
+        <a:font script="Arab" typeface="Arial"/>
+        <a:font script="Hebr" typeface="Arial"/>
+        <a:font script="Thai" typeface="Cordia New"/>
+        <a:font script="Ethi" typeface="Nyala"/>
+        <a:font script="Beng" typeface="Vrinda"/>
+        <a:font script="Gujr" typeface="Shruti"/>
+        <a:font script="Khmr" typeface="DaunPenh"/>
+        <a:font script="Knda" typeface="Tunga"/>
+        <a:font script="Guru" typeface="Raavi"/>
+        <a:font script="Cans" typeface="Euphemia"/>
+        <a:font script="Cher" typeface="Plantagenet Cherokee"/>
+        <a:font script="Yiii" typeface="Microsoft Yi Baiti"/>
+        <a:font script="Tibt" typeface="Microsoft Himalaya"/>
+        <a:font script="Thaa" typeface="MV Boli"/>
+        <a:font script="Deva" typeface="Mangal"/>
+        <a:font script="Telu" typeface="Gautami"/>
+        <a:font script="Taml" typeface="Latha"/>
+        <a:font script="Syrc" typeface="Estrangelo Edessa"/>
+        <a:font script="Orya" typeface="Kalinga"/>
+        <a:font script="Mlym" typeface="Kartika"/>
+        <a:font script="Laoo" typeface="DokChampa"/>
+        <a:font script="Sinh" typeface="Iskoola Pota"/>
+        <a:font script="Mong" typeface="Mongolian Baiti"/>
+        <a:font script="Viet" typeface="Arial"/>
+        <a:font script="Uigh" typeface="Microsoft Uighur"/>
+        <a:font script="Geor" typeface="Sylfaen"/>
+      </a:minorFont>
+    </a:fontScheme>
+    <a:fmtScheme name="Office">
+      <a:fillStyleLst>
+        <a:solidFill>
+          <a:schemeClr val="phClr"/>
+        </a:solidFill>
+        <a:gradFill rotWithShape="1">
+          <a:gsLst>
+            <a:gs pos="0">
+              <a:schemeClr val="phClr">
+                <a:tint val="50000"/>
+                <a:satMod val="300000"/>
+              </a:schemeClr>
+            </a:gs>
+            <a:gs pos="35000">
+              <a:schemeClr val="phClr">
+                <a:tint val="37000"/>
+                <a:satMod val="300000"/>
+              </a:schemeClr>
+            </a:gs>
+            <a:gs pos="100000">
+              <a:schemeClr val="phClr">
+                <a:tint val="15000"/>
+                <a:satMod val="350000"/>
+              </a:schemeClr>
+            </a:gs>
+          </a:gsLst>
+          <a:lin ang="16200000" scaled="1"/>
+        </a:gradFill>
+        <a:gradFill rotWithShape="1">
+          <a:gsLst>
+            <a:gs pos="0">
+              <a:schemeClr val="phClr">
+                <a:tint val="100000"/>
+                <a:shade val="100000"/>
+                <a:satMod val="130000"/>
+              </a:schemeClr>
+            </a:gs>
+            <a:gs pos="100000">
+              <a:schemeClr val="phClr">
+                <a:tint val="50000"/>
+                <a:shade val="100000"/>
+                <a:satMod val="350000"/>
+              </a:schemeClr>
+            </a:gs>
+          </a:gsLst>
+          <a:lin ang="16200000" scaled="0"/>
+        </a:gradFill>
+      </a:fillStyleLst>
+      <a:lnStyleLst>
+        <a:ln w="9525" cap="flat" cmpd="sng" algn="ctr">
+          <a:solidFill>
+            <a:schemeClr val="phClr">
+              <a:shade val="95000"/>
+              <a:satMod val="105000"/>
+            </a:schemeClr>
+          </a:solidFill>
+          <a:prstDash val="solid"/>
+        </a:ln>
+        <a:ln w="25400" cap="flat" cmpd="sng" algn="ctr">
+          <a:solidFill>
+            <a:schemeClr val="phClr"/>
+          </a:solidFill>
+          <a:prstDash val="solid"/>
+        </a:ln>
+        <a:ln w="38100" cap="flat" cmpd="sng" algn="ctr">
+          <a:solidFill>
+            <a:schemeClr val="phClr"/>
+          </a:solidFill>
+          <a:prstDash val="solid"/>
+        </a:ln>
+      </a:lnStyleLst>
+      <a:effectStyleLst>
+        <a:effectStyle>
+          <a:effectLst>
+            <a:outerShdw blurRad="40000" dist="20000" dir="5400000" rotWithShape="0">
+              <a:srgbClr val="000000">
+                <a:alpha val="38000"/>
+              </a:srgbClr>
+            </a:outerShdw>
+          </a:effectLst>
+        </a:effectStyle>
+        <a:effectStyle>
+          <a:effectLst>
+            <a:outerShdw blurRad="40000" dist="23000" dir="5400000" rotWithShape="0">
+              <a:srgbClr val="000000">
+                <a:alpha val="35000"/>
+              </a:srgbClr>
+            </a:outerShdw>
+          </a:effectLst>
+        </a:effectStyle>
+        <a:effectStyle>
+          <a:effectLst>
+            <a:outerShdw blurRad="40000" dist="23000" dir="5400000" rotWithShape="0">
+              <a:srgbClr val="000000">
+                <a:alpha val="35000"/>
+              </a:srgbClr>
+            </a:outerShdw>
+          </a:effectLst>
+          <a:scene3d>
+            <a:camera prst="orthographicFront">
+              <a:rot lat="0" lon="0" rev="0"/>
+            </a:camera>
+            <a:lightRig rig="threePt" dir="t">
+              <a:rot lat="0" lon="0" rev="1200000"/>
+            </a:lightRig>
+          </a:scene3d>
+          <a:sp3d>
+            <a:bevelT w="63500" h="25400"/>
+          </a:sp3d>
+        </a:effectStyle>
+      </a:effectStyleLst>
+      <a:bgFillStyleLst>
+        <a:solidFill>
+          <a:schemeClr val="phClr"/>
+        </a:solidFill>
+        <a:gradFill rotWithShape="1">
+          <a:gsLst>
+            <a:gs pos="0">
+              <a:schemeClr val="phClr">
+                <a:tint val="40000"/>
+                <a:satMod val="350000"/>
+              </a:schemeClr>
+            </a:gs>
+            <a:gs pos="40000">
+              <a:schemeClr val="phClr">
+                <a:tint val="45000"/>
+                <a:shade val="99000"/>
+                <a:satMod val="350000"/>
+              </a:schemeClr>
+            </a:gs>
+            <a:gs pos="100000">
+              <a:schemeClr val="phClr">
+                <a:shade val="20000"/>
+                <a:satMod val="255000"/>
+              </a:schemeClr>
+            </a:gs>
+          </a:gsLst>
+          <a:path path="circle">
+            <a:fillToRect l="50000" t="-80000" r="50000" b="180000"/>
+          </a:path>
+        </a:gradFill>
+        <a:gradFill rotWithShape="1">
+          <a:gsLst>
+            <a:gs pos="0">
+              <a:schemeClr val="phClr">
+                <a:tint val="80000"/>
+                <a:satMod val="300000"/>
+              </a:schemeClr>
+            </a:gs>
+            <a:gs pos="100000">
+              <a:schemeClr val="phClr">
+                <a:shade val="30000"/>
+                <a:satMod val="200000"/>
+              </a:schemeClr>
+            </a:gs>
+          </a:gsLst>
+          <a:path path="circle">
+            <a:fillToRect l="50000" t="50000" r="50000" b="50000"/>
+          </a:path>
+        </a:gradFill>
+      </a:bgFillStyleLst>
+    </a:fmtScheme>
+  </a:themeElements>
+  <a:objectDefaults>
+    <a:spDef>
+      <a:spPr/>
+      <a:bodyPr/>
+      <a:lstStyle/>
+      <a:style>
+        <a:lnRef idx="1">
+          <a:schemeClr val="accent1"/>
+        </a:lnRef>
+        <a:fillRef idx="3">
+          <a:schemeClr val="accent1"/>
+        </a:fillRef>
+        <a:effectRef idx="2">
+          <a:schemeClr val="accent1"/>
+        </a:effectRef>
+        <a:fontRef idx="minor">
+          <a:schemeClr val="lt1"/>
+        </a:fontRef>
+      </a:style>
+    </a:spDef>
+    <a:lnDef>
+      <a:spPr/>
+      <a:bodyPr/>
+      <a:lstStyle/>
+      <a:style>
+        <a:lnRef idx="2">
+          <a:schemeClr val="accent1"/>
+        </a:lnRef>
+        <a:fillRef idx="0">
+          <a:schemeClr val="accent1"/>
+        </a:fillRef>
+        <a:effectRef idx="1">
+          <a:schemeClr val="accent1"/>
+        </a:effectRef>
+        <a:fontRef idx="minor">
+          <a:schemeClr val="tx1"/>
+        </a:fontRef>
+      </a:style>
+    </a:lnDef>
+  </a:objectDefaults>
+  <a:extraClrSchemeLst/>
+</a:theme>
 </file>
</xml_diff>

<commit_message>
Changes before error encountered
Agent-Logs-Url: https://github.com/Ronykipkemboi/ai-legal-rights-assistant/sessions/84b1138c-25a6-4c56-a1bd-27dd5a5a172b

Co-authored-by: Ronykipkemboi <149723274+Ronykipkemboi@users.noreply.github.com>
</commit_message>
<xml_diff>
--- a/Presentation.pptx
+++ b/Presentation.pptx
@@ -256,6 +256,204 @@
         <c:majorUnit val="50.0"/>
       </c:valAx>
     </c:plotArea>
+    <c:dispBlanksAs val="gap"/>
+  </c:chart>
+  <c:txPr>
+    <a:bodyPr/>
+    <a:lstStyle/>
+    <a:p>
+      <a:pPr>
+        <a:defRPr sz="1800"/>
+      </a:pPr>
+      <a:endParaRPr lang="en-US"/>
+    </a:p>
+  </c:txPr>
+  <c:externalData r:id="rId1">
+    <c:autoUpdate val="0"/>
+  </c:externalData>
+</c:chartSpace>
+</file>
+
+<file path=ppt/charts/chart2.xml><?xml version="1.0" encoding="utf-8"?>
+<c:chartSpace xmlns:c="http://schemas.openxmlformats.org/drawingml/2006/chart" xmlns:a="http://schemas.openxmlformats.org/drawingml/2006/main" xmlns:r="http://schemas.openxmlformats.org/officeDocument/2006/relationships">
+  <c:date1904 val="0"/>
+  <c:chart>
+    <c:title>
+      <c:tx>
+        <c:rich>
+          <a:bodyPr/>
+          <a:lstStyle/>
+          <a:p>
+            <a:r>
+              <a:t>Traditional Lawyer vs. RonyGuard AI</a:t>
+            </a:r>
+          </a:p>
+        </c:rich>
+      </c:tx>
+      <c:layout/>
+      <c:overlay val="0"/>
+    </c:title>
+    <c:autoTitleDeleted val="0"/>
+    <c:plotArea>
+      <c:barChart>
+        <c:barDir val="col"/>
+        <c:grouping val="clustered"/>
+        <c:ser>
+          <c:idx val="0"/>
+          <c:order val="0"/>
+          <c:tx>
+            <c:strRef>
+              <c:f>Sheet1!$B$1</c:f>
+              <c:strCache>
+                <c:ptCount val="1"/>
+                <c:pt idx="0">
+                  <c:v>Traditional Lawyer</c:v>
+                </c:pt>
+              </c:strCache>
+            </c:strRef>
+          </c:tx>
+          <c:spPr>
+            <a:solidFill>
+              <a:srgbClr val="C0392B"/>
+            </a:solidFill>
+          </c:spPr>
+          <c:dLbls>
+            <c:numFmt formatCode="[$$-409]#,##0" sourceLinked="0"/>
+            <c:showLegendKey val="0"/>
+            <c:showVal val="0"/>
+            <c:showCatName val="0"/>
+            <c:showSerName val="0"/>
+            <c:showPercent val="0"/>
+            <c:showBubbleSize val="0"/>
+            <c:showLeaderLines val="1"/>
+          </c:dLbls>
+          <c:cat>
+            <c:strRef>
+              <c:f>Sheet1!$A$2:$A$2</c:f>
+              <c:strCache>
+                <c:ptCount val="1"/>
+                <c:pt idx="0">
+                  <c:v>Cost Comparison</c:v>
+                </c:pt>
+              </c:strCache>
+            </c:strRef>
+          </c:cat>
+          <c:val>
+            <c:numRef>
+              <c:f>Sheet1!$B$2:$B$2</c:f>
+              <c:numCache>
+                <c:formatCode>General</c:formatCode>
+                <c:ptCount val="1"/>
+                <c:pt idx="0">
+                  <c:v>300</c:v>
+                </c:pt>
+              </c:numCache>
+            </c:numRef>
+          </c:val>
+        </c:ser>
+        <c:ser>
+          <c:idx val="1"/>
+          <c:order val="1"/>
+          <c:tx>
+            <c:strRef>
+              <c:f>Sheet1!$C$1</c:f>
+              <c:strCache>
+                <c:ptCount val="1"/>
+                <c:pt idx="0">
+                  <c:v>RonyGuard AI</c:v>
+                </c:pt>
+              </c:strCache>
+            </c:strRef>
+          </c:tx>
+          <c:spPr>
+            <a:solidFill>
+              <a:srgbClr val="27AE60"/>
+            </a:solidFill>
+          </c:spPr>
+          <c:dLbls>
+            <c:numFmt formatCode="[$$-409]#,##0" sourceLinked="0"/>
+            <c:showLegendKey val="0"/>
+            <c:showVal val="0"/>
+            <c:showCatName val="0"/>
+            <c:showSerName val="0"/>
+            <c:showPercent val="0"/>
+            <c:showBubbleSize val="0"/>
+            <c:showLeaderLines val="1"/>
+          </c:dLbls>
+          <c:cat>
+            <c:strRef>
+              <c:f>Sheet1!$A$2:$A$2</c:f>
+              <c:strCache>
+                <c:ptCount val="1"/>
+                <c:pt idx="0">
+                  <c:v>Cost Comparison</c:v>
+                </c:pt>
+              </c:strCache>
+            </c:strRef>
+          </c:cat>
+          <c:val>
+            <c:numRef>
+              <c:f>Sheet1!$C$2:$C$2</c:f>
+              <c:numCache>
+                <c:formatCode>General</c:formatCode>
+                <c:ptCount val="1"/>
+                <c:pt idx="0">
+                  <c:v>15</c:v>
+                </c:pt>
+              </c:numCache>
+            </c:numRef>
+          </c:val>
+        </c:ser>
+        <c:dLbls>
+          <c:showLegendKey val="0"/>
+          <c:showVal val="1"/>
+          <c:showCatName val="0"/>
+          <c:showSerName val="0"/>
+          <c:showPercent val="0"/>
+          <c:showBubbleSize val="0"/>
+          <c:showLeaderLines val="1"/>
+        </c:dLbls>
+        <c:axId val="-2068027336"/>
+        <c:axId val="-2113994440"/>
+      </c:barChart>
+      <c:catAx>
+        <c:axId val="-2068027336"/>
+        <c:scaling>
+          <c:orientation val="minMax"/>
+        </c:scaling>
+        <c:delete val="0"/>
+        <c:axPos val="b"/>
+        <c:majorTickMark val="out"/>
+        <c:minorTickMark val="none"/>
+        <c:tickLblPos val="nextTo"/>
+        <c:crossAx val="-2113994440"/>
+        <c:crosses val="autoZero"/>
+        <c:auto val="1"/>
+        <c:lblAlgn val="ctr"/>
+        <c:lblOffset val="100"/>
+        <c:noMultiLvlLbl val="0"/>
+      </c:catAx>
+      <c:valAx>
+        <c:axId val="-2113994440"/>
+        <c:scaling>
+          <c:max val="320.0"/>
+          <c:min val="0.0"/>
+        </c:scaling>
+        <c:delete val="0"/>
+        <c:axPos val="l"/>
+        <c:majorGridlines/>
+        <c:numFmt formatCode="[$$-409]#,##0" sourceLinked="0"/>
+        <c:majorTickMark val="out"/>
+        <c:minorTickMark val="none"/>
+        <c:tickLblPos val="nextTo"/>
+        <c:crossAx val="-2068027336"/>
+        <c:crosses val="autoZero"/>
+        <c:majorUnit val="50.0"/>
+      </c:valAx>
+    </c:plotArea>
+    <c:legend>
+      <c:legendPos val="b"/>
+    </c:legend>
     <c:dispBlanksAs val="gap"/>
   </c:chart>
   <c:txPr>
@@ -4118,7 +4316,7 @@
             <a:avLst/>
           </a:prstGeom>
           <a:solidFill>
-            <a:srgbClr val="070D1C"/>
+            <a:srgbClr val="F6F8FB"/>
           </a:solidFill>
           <a:ln>
             <a:noFill/>
@@ -4161,7 +4359,7 @@
             <a:avLst/>
           </a:prstGeom>
           <a:solidFill>
-            <a:srgbClr val="2997FF"/>
+            <a:srgbClr val="DDE4EE"/>
           </a:solidFill>
           <a:ln>
             <a:noFill/>
@@ -4199,6 +4397,264 @@
           <a:xfrm>
             <a:off x="7589520" y="1920240"/>
             <a:ext cx="5029200" cy="5029200"/>
+          </a:xfrm>
+          <a:prstGeom prst="ellipse">
+            <a:avLst/>
+          </a:prstGeom>
+          <a:solidFill>
+            <a:srgbClr val="DFE6F0"/>
+          </a:solidFill>
+          <a:ln>
+            <a:noFill/>
+          </a:ln>
+        </p:spPr>
+        <p:style>
+          <a:lnRef idx="1">
+            <a:schemeClr val="accent1"/>
+          </a:lnRef>
+          <a:fillRef idx="3">
+            <a:schemeClr val="accent1"/>
+          </a:fillRef>
+          <a:effectRef idx="2">
+            <a:schemeClr val="accent1"/>
+          </a:effectRef>
+          <a:fontRef idx="minor">
+            <a:schemeClr val="lt1"/>
+          </a:fontRef>
+        </p:style>
+        <p:txBody>
+          <a:bodyPr rtlCol="0" anchor="ctr"/>
+          <a:lstStyle/>
+          <a:p>
+            <a:pPr algn="ctr"/>
+          </a:p>
+        </p:txBody>
+      </p:sp>
+      <p:sp>
+        <p:nvSpPr>
+          <p:cNvPr id="5" name="Rectangle 4"/>
+          <p:cNvSpPr/>
+          <p:nvPr/>
+        </p:nvSpPr>
+        <p:spPr>
+          <a:xfrm>
+            <a:off x="0" y="5394960"/>
+            <a:ext cx="12188952" cy="1463040"/>
+          </a:xfrm>
+          <a:prstGeom prst="rect">
+            <a:avLst/>
+          </a:prstGeom>
+          <a:solidFill>
+            <a:srgbClr val="E7ECF4"/>
+          </a:solidFill>
+          <a:ln>
+            <a:noFill/>
+          </a:ln>
+        </p:spPr>
+        <p:style>
+          <a:lnRef idx="1">
+            <a:schemeClr val="accent1"/>
+          </a:lnRef>
+          <a:fillRef idx="3">
+            <a:schemeClr val="accent1"/>
+          </a:fillRef>
+          <a:effectRef idx="2">
+            <a:schemeClr val="accent1"/>
+          </a:effectRef>
+          <a:fontRef idx="minor">
+            <a:schemeClr val="lt1"/>
+          </a:fontRef>
+        </p:style>
+        <p:txBody>
+          <a:bodyPr rtlCol="0" anchor="ctr"/>
+          <a:lstStyle/>
+          <a:p>
+            <a:pPr algn="ctr"/>
+          </a:p>
+        </p:txBody>
+      </p:sp>
+      <p:sp>
+        <p:nvSpPr>
+          <p:cNvPr id="6" name="TextBox 5"/>
+          <p:cNvSpPr txBox="1"/>
+          <p:nvPr/>
+        </p:nvSpPr>
+        <p:spPr>
+          <a:xfrm>
+            <a:off x="731520" y="822960"/>
+            <a:ext cx="5669280" cy="1097280"/>
+          </a:xfrm>
+          <a:prstGeom prst="rect">
+            <a:avLst/>
+          </a:prstGeom>
+          <a:noFill/>
+        </p:spPr>
+        <p:txBody>
+          <a:bodyPr wrap="none">
+            <a:spAutoFit/>
+          </a:bodyPr>
+          <a:lstStyle/>
+          <a:p>
+            <a:pPr algn="l"/>
+            <a:r>
+              <a:rPr b="1" sz="3800">
+                <a:solidFill>
+                  <a:srgbClr val="102B52"/>
+                </a:solidFill>
+                <a:latin typeface="Segoe UI"/>
+              </a:rPr>
+              <a:t>RonyGuard AI: Real-Time Legal Rights Assistant</a:t>
+            </a:r>
+          </a:p>
+        </p:txBody>
+      </p:sp>
+      <p:sp>
+        <p:nvSpPr>
+          <p:cNvPr id="7" name="TextBox 6"/>
+          <p:cNvSpPr txBox="1"/>
+          <p:nvPr/>
+        </p:nvSpPr>
+        <p:spPr>
+          <a:xfrm>
+            <a:off x="749808" y="1828800"/>
+            <a:ext cx="5760720" cy="731520"/>
+          </a:xfrm>
+          <a:prstGeom prst="rect">
+            <a:avLst/>
+          </a:prstGeom>
+          <a:noFill/>
+        </p:spPr>
+        <p:txBody>
+          <a:bodyPr wrap="none">
+            <a:spAutoFit/>
+          </a:bodyPr>
+          <a:lstStyle/>
+          <a:p>
+            <a:r>
+              <a:rPr sz="2200">
+                <a:solidFill>
+                  <a:srgbClr val="2D3848"/>
+                </a:solidFill>
+                <a:latin typeface="Segoe UI"/>
+              </a:rPr>
+              <a:t>Real-time legal rights guidance for everyday people.</a:t>
+            </a:r>
+          </a:p>
+        </p:txBody>
+      </p:sp>
+      <p:sp>
+        <p:nvSpPr>
+          <p:cNvPr id="8" name="TextBox 7"/>
+          <p:cNvSpPr txBox="1"/>
+          <p:nvPr/>
+        </p:nvSpPr>
+        <p:spPr>
+          <a:xfrm>
+            <a:off x="749808" y="2514600"/>
+            <a:ext cx="5669280" cy="457200"/>
+          </a:xfrm>
+          <a:prstGeom prst="rect">
+            <a:avLst/>
+          </a:prstGeom>
+          <a:noFill/>
+        </p:spPr>
+        <p:txBody>
+          <a:bodyPr wrap="none">
+            <a:spAutoFit/>
+          </a:bodyPr>
+          <a:lstStyle/>
+          <a:p>
+            <a:r>
+              <a:rPr sz="1400">
+                <a:solidFill>
+                  <a:srgbClr val="2D3848"/>
+                </a:solidFill>
+                <a:latin typeface="Segoe UI"/>
+              </a:rPr>
+              <a:t>Fictitious consumer legal-tech startup · CIS-421</a:t>
+            </a:r>
+          </a:p>
+        </p:txBody>
+      </p:sp>
+      <p:sp>
+        <p:nvSpPr>
+          <p:cNvPr id="9" name="Rounded Rectangle 8"/>
+          <p:cNvSpPr/>
+          <p:nvPr/>
+        </p:nvSpPr>
+        <p:spPr>
+          <a:xfrm>
+            <a:off x="6583680" y="868680"/>
+            <a:ext cx="4846320" cy="4754880"/>
+          </a:xfrm>
+          <a:prstGeom prst="roundRect">
+            <a:avLst/>
+          </a:prstGeom>
+          <a:solidFill>
+            <a:srgbClr val="FFFFFF"/>
+          </a:solidFill>
+          <a:ln w="15240">
+            <a:solidFill>
+              <a:srgbClr val="CBD6E5"/>
+            </a:solidFill>
+          </a:ln>
+        </p:spPr>
+        <p:style>
+          <a:lnRef idx="1">
+            <a:schemeClr val="accent1"/>
+          </a:lnRef>
+          <a:fillRef idx="3">
+            <a:schemeClr val="accent1"/>
+          </a:fillRef>
+          <a:effectRef idx="2">
+            <a:schemeClr val="accent1"/>
+          </a:effectRef>
+          <a:fontRef idx="minor">
+            <a:schemeClr val="lt1"/>
+          </a:fontRef>
+        </p:style>
+        <p:txBody>
+          <a:bodyPr rtlCol="0" anchor="ctr"/>
+          <a:lstStyle/>
+          <a:p>
+            <a:pPr algn="ctr"/>
+          </a:p>
+        </p:txBody>
+      </p:sp>
+      <p:sp>
+        <p:nvSpPr>
+          <p:cNvPr id="10" name="TextBox 9"/>
+          <p:cNvSpPr txBox="1"/>
+          <p:nvPr/>
+        </p:nvSpPr>
+        <p:spPr>
+          <a:xfrm>
+            <a:off x="6839712" y="1051560"/>
+            <a:ext cx="4334256" cy="4434840"/>
+          </a:xfrm>
+          <a:prstGeom prst="rect">
+            <a:avLst/>
+          </a:prstGeom>
+          <a:noFill/>
+        </p:spPr>
+        <p:txBody>
+          <a:bodyPr wrap="none">
+            <a:spAutoFit/>
+          </a:bodyPr>
+          <a:lstStyle/>
+          <a:p/>
+        </p:txBody>
+      </p:sp>
+      <p:sp>
+        <p:nvSpPr>
+          <p:cNvPr id="11" name="Oval 10"/>
+          <p:cNvSpPr/>
+          <p:nvPr/>
+        </p:nvSpPr>
+        <p:spPr>
+          <a:xfrm>
+            <a:off x="731520" y="5440680"/>
+            <a:ext cx="384048" cy="384048"/>
           </a:xfrm>
           <a:prstGeom prst="ellipse">
             <a:avLst/>
@@ -4234,57 +4690,14 @@
       </p:sp>
       <p:sp>
         <p:nvSpPr>
-          <p:cNvPr id="5" name="Rectangle 4"/>
-          <p:cNvSpPr/>
-          <p:nvPr/>
-        </p:nvSpPr>
-        <p:spPr>
-          <a:xfrm>
-            <a:off x="0" y="5394960"/>
-            <a:ext cx="12188952" cy="1463040"/>
-          </a:xfrm>
-          <a:prstGeom prst="rect">
-            <a:avLst/>
-          </a:prstGeom>
-          <a:solidFill>
-            <a:srgbClr val="111C35"/>
-          </a:solidFill>
-          <a:ln>
-            <a:noFill/>
-          </a:ln>
-        </p:spPr>
-        <p:style>
-          <a:lnRef idx="1">
-            <a:schemeClr val="accent1"/>
-          </a:lnRef>
-          <a:fillRef idx="3">
-            <a:schemeClr val="accent1"/>
-          </a:fillRef>
-          <a:effectRef idx="2">
-            <a:schemeClr val="accent1"/>
-          </a:effectRef>
-          <a:fontRef idx="minor">
-            <a:schemeClr val="lt1"/>
-          </a:fontRef>
-        </p:style>
-        <p:txBody>
-          <a:bodyPr rtlCol="0" anchor="ctr"/>
-          <a:lstStyle/>
-          <a:p>
-            <a:pPr algn="ctr"/>
-          </a:p>
-        </p:txBody>
-      </p:sp>
-      <p:sp>
-        <p:nvSpPr>
-          <p:cNvPr id="6" name="TextBox 5"/>
+          <p:cNvPr id="12" name="TextBox 11"/>
           <p:cNvSpPr txBox="1"/>
           <p:nvPr/>
         </p:nvSpPr>
         <p:spPr>
           <a:xfrm>
-            <a:off x="731520" y="822960"/>
-            <a:ext cx="5669280" cy="1097280"/>
+            <a:off x="731520" y="5449824"/>
+            <a:ext cx="384048" cy="384048"/>
           </a:xfrm>
           <a:prstGeom prst="rect">
             <a:avLst/>
@@ -4297,28 +4710,29 @@
           </a:bodyPr>
           <a:lstStyle/>
           <a:p>
-            <a:r>
-              <a:rPr sz="5400" b="1">
+            <a:pPr algn="ctr"/>
+            <a:r>
+              <a:rPr b="1" sz="1300">
                 <a:solidFill>
-                  <a:srgbClr val="2997FF"/>
+                  <a:srgbClr val="2D3848"/>
                 </a:solidFill>
-                <a:latin typeface="Poppins"/>
+                <a:latin typeface="Segoe UI"/>
               </a:rPr>
-              <a:t>RonyGuard</a:t>
-            </a:r>
-          </a:p>
-        </p:txBody>
-      </p:sp>
-      <p:sp>
-        <p:nvSpPr>
-          <p:cNvPr id="7" name="TextBox 6"/>
+              <a:t>R</a:t>
+            </a:r>
+          </a:p>
+        </p:txBody>
+      </p:sp>
+      <p:sp>
+        <p:nvSpPr>
+          <p:cNvPr id="13" name="TextBox 12"/>
           <p:cNvSpPr txBox="1"/>
           <p:nvPr/>
         </p:nvSpPr>
         <p:spPr>
           <a:xfrm>
-            <a:off x="749808" y="1828800"/>
-            <a:ext cx="5760720" cy="731520"/>
+            <a:off x="1207008" y="5495544"/>
+            <a:ext cx="4754880" cy="274320"/>
           </a:xfrm>
           <a:prstGeom prst="rect">
             <a:avLst/>
@@ -4332,278 +4746,41 @@
           <a:lstStyle/>
           <a:p>
             <a:r>
-              <a:rPr sz="2200">
-                <a:solidFill>
-                  <a:srgbClr val="E6EEFC"/>
-                </a:solidFill>
-                <a:latin typeface="Inter"/>
-              </a:rPr>
-              <a:t>Real-time legal rights guidance for everyday people.</a:t>
-            </a:r>
-          </a:p>
-        </p:txBody>
-      </p:sp>
-      <p:sp>
-        <p:nvSpPr>
-          <p:cNvPr id="8" name="TextBox 7"/>
-          <p:cNvSpPr txBox="1"/>
-          <p:nvPr/>
-        </p:nvSpPr>
-        <p:spPr>
-          <a:xfrm>
-            <a:off x="749808" y="2514600"/>
-            <a:ext cx="5669280" cy="457200"/>
-          </a:xfrm>
-          <a:prstGeom prst="rect">
-            <a:avLst/>
-          </a:prstGeom>
-          <a:noFill/>
-        </p:spPr>
-        <p:txBody>
-          <a:bodyPr wrap="none">
-            <a:spAutoFit/>
-          </a:bodyPr>
-          <a:lstStyle/>
-          <a:p>
-            <a:r>
               <a:rPr sz="1400">
                 <a:solidFill>
-                  <a:srgbClr val="A6B4D1"/>
+                  <a:srgbClr val="2D3848"/>
                 </a:solidFill>
-                <a:latin typeface="Inter"/>
+                <a:latin typeface="Segoe UI"/>
               </a:rPr>
-              <a:t>Fictitious consumer legal-tech startup · CIS-421</a:t>
-            </a:r>
-          </a:p>
-        </p:txBody>
-      </p:sp>
-      <p:sp>
-        <p:nvSpPr>
-          <p:cNvPr id="9" name="Rounded Rectangle 8"/>
-          <p:cNvSpPr/>
-          <p:nvPr/>
-        </p:nvSpPr>
-        <p:spPr>
-          <a:xfrm>
-            <a:off x="6583680" y="868680"/>
-            <a:ext cx="4846320" cy="4754880"/>
-          </a:xfrm>
-          <a:prstGeom prst="roundRect">
-            <a:avLst/>
-          </a:prstGeom>
-          <a:solidFill>
-            <a:srgbClr val="16213D"/>
-          </a:solidFill>
-          <a:ln w="15240">
-            <a:solidFill>
-              <a:srgbClr val="3A5184"/>
-            </a:solidFill>
-          </a:ln>
-        </p:spPr>
-        <p:style>
-          <a:lnRef idx="1">
-            <a:schemeClr val="accent1"/>
-          </a:lnRef>
-          <a:fillRef idx="3">
-            <a:schemeClr val="accent1"/>
-          </a:fillRef>
-          <a:effectRef idx="2">
-            <a:schemeClr val="accent1"/>
-          </a:effectRef>
-          <a:fontRef idx="minor">
-            <a:schemeClr val="lt1"/>
-          </a:fontRef>
-        </p:style>
-        <p:txBody>
-          <a:bodyPr rtlCol="0" anchor="ctr"/>
-          <a:lstStyle/>
-          <a:p>
-            <a:pPr algn="ctr"/>
-          </a:p>
-        </p:txBody>
-      </p:sp>
-      <p:sp>
-        <p:nvSpPr>
-          <p:cNvPr id="10" name="TextBox 9"/>
-          <p:cNvSpPr txBox="1"/>
-          <p:nvPr/>
-        </p:nvSpPr>
-        <p:spPr>
-          <a:xfrm>
-            <a:off x="6839712" y="1051560"/>
-            <a:ext cx="4334256" cy="4434840"/>
+              <a:t>Ronald Kipkemboi | Shaw University | Fictitious Company (F)</a:t>
+            </a:r>
+          </a:p>
+        </p:txBody>
+      </p:sp>
+      <p:pic>
+        <p:nvPicPr>
+          <p:cNvPr id="14" name="Picture 13" descr="digital_gavel_shield.png"/>
+          <p:cNvPicPr>
+            <a:picLocks noChangeAspect="1"/>
+          </p:cNvPicPr>
+          <p:nvPr/>
+        </p:nvPicPr>
+        <p:blipFill>
+          <a:blip r:embed="rId4"/>
+          <a:stretch>
+            <a:fillRect/>
+          </a:stretch>
+        </p:blipFill>
+        <p:spPr>
+          <a:xfrm>
+            <a:off x="6720840" y="1005840"/>
+            <a:ext cx="4572000" cy="4480560"/>
           </a:xfrm>
           <a:prstGeom prst="rect">
             <a:avLst/>
           </a:prstGeom>
-          <a:noFill/>
-        </p:spPr>
-        <p:txBody>
-          <a:bodyPr wrap="none">
-            <a:spAutoFit/>
-          </a:bodyPr>
-          <a:lstStyle/>
-          <a:p>
-            <a:r>
-              <a:rPr sz="2000" b="1">
-                <a:solidFill>
-                  <a:srgbClr val="E6EEFC"/>
-                </a:solidFill>
-                <a:latin typeface="Poppins"/>
-              </a:rPr>
-              <a:t>Hero Visual Placeholder</a:t>
-            </a:r>
-          </a:p>
-          <a:p>
-            <a:pPr/>
-            <a:r>
-              <a:rPr sz="1800">
-                <a:solidFill>
-                  <a:srgbClr val="A6B4D1"/>
-                </a:solidFill>
-                <a:latin typeface="Inter"/>
-              </a:rPr>
-              <a:t>• Abstract legal-tech dashboard + phone mockup</a:t>
-            </a:r>
-          </a:p>
-          <a:p>
-            <a:pPr/>
-            <a:r>
-              <a:rPr sz="1800">
-                <a:solidFill>
-                  <a:srgbClr val="A6B4D1"/>
-                </a:solidFill>
-                <a:latin typeface="Inter"/>
-              </a:rPr>
-              <a:t>• Glow lines, app UI cards, and trust/security cues</a:t>
-            </a:r>
-          </a:p>
-          <a:p>
-            <a:pPr/>
-            <a:r>
-              <a:rPr sz="1800">
-                <a:solidFill>
-                  <a:srgbClr val="A6B4D1"/>
-                </a:solidFill>
-                <a:latin typeface="Inter"/>
-              </a:rPr>
-              <a:t>• Replace with branded screenshot when available</a:t>
-            </a:r>
-          </a:p>
-        </p:txBody>
-      </p:sp>
-      <p:sp>
-        <p:nvSpPr>
-          <p:cNvPr id="11" name="Oval 10"/>
-          <p:cNvSpPr/>
-          <p:nvPr/>
-        </p:nvSpPr>
-        <p:spPr>
-          <a:xfrm>
-            <a:off x="731520" y="5440680"/>
-            <a:ext cx="384048" cy="384048"/>
-          </a:xfrm>
-          <a:prstGeom prst="ellipse">
-            <a:avLst/>
-          </a:prstGeom>
-          <a:solidFill>
-            <a:srgbClr val="00D6C9"/>
-          </a:solidFill>
-          <a:ln>
-            <a:noFill/>
-          </a:ln>
-        </p:spPr>
-        <p:style>
-          <a:lnRef idx="1">
-            <a:schemeClr val="accent1"/>
-          </a:lnRef>
-          <a:fillRef idx="3">
-            <a:schemeClr val="accent1"/>
-          </a:fillRef>
-          <a:effectRef idx="2">
-            <a:schemeClr val="accent1"/>
-          </a:effectRef>
-          <a:fontRef idx="minor">
-            <a:schemeClr val="lt1"/>
-          </a:fontRef>
-        </p:style>
-        <p:txBody>
-          <a:bodyPr rtlCol="0" anchor="ctr"/>
-          <a:lstStyle/>
-          <a:p>
-            <a:pPr algn="ctr"/>
-          </a:p>
-        </p:txBody>
-      </p:sp>
-      <p:sp>
-        <p:nvSpPr>
-          <p:cNvPr id="12" name="TextBox 11"/>
-          <p:cNvSpPr txBox="1"/>
-          <p:nvPr/>
-        </p:nvSpPr>
-        <p:spPr>
-          <a:xfrm>
-            <a:off x="731520" y="5449824"/>
-            <a:ext cx="384048" cy="384048"/>
-          </a:xfrm>
-          <a:prstGeom prst="rect">
-            <a:avLst/>
-          </a:prstGeom>
-          <a:noFill/>
-        </p:spPr>
-        <p:txBody>
-          <a:bodyPr wrap="none">
-            <a:spAutoFit/>
-          </a:bodyPr>
-          <a:lstStyle/>
-          <a:p>
-            <a:pPr algn="ctr"/>
-            <a:r>
-              <a:rPr b="1" sz="1300">
-                <a:solidFill>
-                  <a:srgbClr val="070D1C"/>
-                </a:solidFill>
-                <a:latin typeface="Poppins"/>
-              </a:rPr>
-              <a:t>R</a:t>
-            </a:r>
-          </a:p>
-        </p:txBody>
-      </p:sp>
-      <p:sp>
-        <p:nvSpPr>
-          <p:cNvPr id="13" name="TextBox 12"/>
-          <p:cNvSpPr txBox="1"/>
-          <p:nvPr/>
-        </p:nvSpPr>
-        <p:spPr>
-          <a:xfrm>
-            <a:off x="1207008" y="5495544"/>
-            <a:ext cx="4754880" cy="274320"/>
-          </a:xfrm>
-          <a:prstGeom prst="rect">
-            <a:avLst/>
-          </a:prstGeom>
-          <a:noFill/>
-        </p:spPr>
-        <p:txBody>
-          <a:bodyPr wrap="none">
-            <a:spAutoFit/>
-          </a:bodyPr>
-          <a:lstStyle/>
-          <a:p>
-            <a:r>
-              <a:rPr sz="1200">
-                <a:solidFill>
-                  <a:srgbClr val="A6B4D1"/>
-                </a:solidFill>
-                <a:latin typeface="Inter"/>
-              </a:rPr>
-              <a:t>Ronald Kipkemboi  ·  March 2026</a:t>
-            </a:r>
-          </a:p>
-        </p:txBody>
-      </p:sp>
+        </p:spPr>
+      </p:pic>
     </p:spTree>
   </p:cSld>
   <p:clrMapOvr>
@@ -4645,7 +4822,7 @@
             <a:avLst/>
           </a:prstGeom>
           <a:solidFill>
-            <a:srgbClr val="070D1C"/>
+            <a:srgbClr val="F6F8FB"/>
           </a:solidFill>
           <a:ln>
             <a:noFill/>
@@ -4688,7 +4865,7 @@
             <a:avLst/>
           </a:prstGeom>
           <a:solidFill>
-            <a:srgbClr val="2997FF"/>
+            <a:srgbClr val="DDE4EE"/>
           </a:solidFill>
           <a:ln>
             <a:noFill/>
@@ -4731,7 +4908,7 @@
             <a:avLst/>
           </a:prstGeom>
           <a:solidFill>
-            <a:srgbClr val="00D6C9"/>
+            <a:srgbClr val="DFE6F0"/>
           </a:solidFill>
           <a:ln>
             <a:noFill/>
@@ -4774,7 +4951,7 @@
             <a:avLst/>
           </a:prstGeom>
           <a:solidFill>
-            <a:srgbClr val="111C35"/>
+            <a:srgbClr val="E7ECF4"/>
           </a:solidFill>
           <a:ln>
             <a:noFill/>
@@ -4827,9 +5004,9 @@
             <a:r>
               <a:rPr sz="3600" b="1">
                 <a:solidFill>
-                  <a:srgbClr val="2997FF"/>
+                  <a:srgbClr val="102B52"/>
                 </a:solidFill>
-                <a:latin typeface="Poppins"/>
+                <a:latin typeface="Segoe UI"/>
               </a:rPr>
               <a:t>The Problem: The Justice Gap</a:t>
             </a:r>
@@ -4906,9 +5083,9 @@
             <a:r>
               <a:rPr sz="2000" b="1">
                 <a:solidFill>
-                  <a:srgbClr val="E6EEFC"/>
+                  <a:srgbClr val="2D3848"/>
                 </a:solidFill>
-                <a:latin typeface="Poppins"/>
+                <a:latin typeface="Segoe UI"/>
               </a:rPr>
               <a:t>Why consumers struggle in critical moments</a:t>
             </a:r>
@@ -4918,9 +5095,9 @@
             <a:r>
               <a:rPr sz="1800">
                 <a:solidFill>
-                  <a:srgbClr val="A6B4D1"/>
+                  <a:srgbClr val="2D3848"/>
                 </a:solidFill>
-                <a:latin typeface="Inter"/>
+                <a:latin typeface="Segoe UI"/>
               </a:rPr>
               <a:t>• High-stress legal encounters cause “legal amnesia.”</a:t>
             </a:r>
@@ -4930,9 +5107,9 @@
             <a:r>
               <a:rPr sz="1800">
                 <a:solidFill>
-                  <a:srgbClr val="A6B4D1"/>
+                  <a:srgbClr val="2D3848"/>
                 </a:solidFill>
-                <a:latin typeface="Inter"/>
+                <a:latin typeface="Segoe UI"/>
               </a:rPr>
               <a:t>• People can’t quickly recall rights during stops or disputes.</a:t>
             </a:r>
@@ -4942,9 +5119,9 @@
             <a:r>
               <a:rPr sz="1800">
                 <a:solidFill>
-                  <a:srgbClr val="A6B4D1"/>
+                  <a:srgbClr val="2D3848"/>
                 </a:solidFill>
-                <a:latin typeface="Inter"/>
+                <a:latin typeface="Segoe UI"/>
               </a:rPr>
               <a:t>• Traditional legal help is too slow and expensive for real-time use.</a:t>
             </a:r>
@@ -4954,9 +5131,9 @@
             <a:r>
               <a:rPr sz="1800">
                 <a:solidFill>
-                  <a:srgbClr val="A6B4D1"/>
+                  <a:srgbClr val="2D3848"/>
                 </a:solidFill>
-                <a:latin typeface="Inter"/>
+                <a:latin typeface="Segoe UI"/>
               </a:rPr>
               <a:t>• Large underserved market needs always-on plain-language support.</a:t>
             </a:r>
@@ -4978,11 +5155,11 @@
             <a:avLst/>
           </a:prstGeom>
           <a:solidFill>
-            <a:srgbClr val="16213D"/>
+            <a:srgbClr val="FFFFFF"/>
           </a:solidFill>
           <a:ln w="15240">
             <a:solidFill>
-              <a:srgbClr val="3A5184"/>
+              <a:srgbClr val="CBD6E5"/>
             </a:solidFill>
           </a:ln>
         </p:spPr>
@@ -5029,41 +5206,7 @@
             <a:spAutoFit/>
           </a:bodyPr>
           <a:lstStyle/>
-          <a:p>
-            <a:r>
-              <a:rPr sz="2000" b="1">
-                <a:solidFill>
-                  <a:srgbClr val="E6EEFC"/>
-                </a:solidFill>
-                <a:latin typeface="Poppins"/>
-              </a:rPr>
-              <a:t>Illustration Placeholder</a:t>
-            </a:r>
-          </a:p>
-          <a:p>
-            <a:pPr/>
-            <a:r>
-              <a:rPr sz="1800">
-                <a:solidFill>
-                  <a:srgbClr val="A6B4D1"/>
-                </a:solidFill>
-                <a:latin typeface="Inter"/>
-              </a:rPr>
-              <a:t>• Person using mobile app during legal scenario</a:t>
-            </a:r>
-          </a:p>
-          <a:p>
-            <a:pPr/>
-            <a:r>
-              <a:rPr sz="1800">
-                <a:solidFill>
-                  <a:srgbClr val="A6B4D1"/>
-                </a:solidFill>
-                <a:latin typeface="Inter"/>
-              </a:rPr>
-              <a:t>• Overlay UI cards: rights, next steps, emergency tips</a:t>
-            </a:r>
-          </a:p>
+          <a:p/>
         </p:txBody>
       </p:sp>
       <p:sp>
@@ -5137,15 +5280,39 @@
             <a:r>
               <a:rPr sz="1400" b="1">
                 <a:solidFill>
-                  <a:srgbClr val="070D1C"/>
+                  <a:srgbClr val="2D3848"/>
                 </a:solidFill>
-                <a:latin typeface="Inter"/>
+                <a:latin typeface="Segoe UI"/>
               </a:rPr>
               <a:t>!</a:t>
             </a:r>
           </a:p>
         </p:txBody>
       </p:sp>
+      <p:pic>
+        <p:nvPicPr>
+          <p:cNvPr id="13" name="Picture 12" descr="stressed_encounter.png"/>
+          <p:cNvPicPr>
+            <a:picLocks noChangeAspect="1"/>
+          </p:cNvPicPr>
+          <p:nvPr/>
+        </p:nvPicPr>
+        <p:blipFill>
+          <a:blip r:embed="rId4"/>
+          <a:stretch>
+            <a:fillRect/>
+          </a:stretch>
+        </p:blipFill>
+        <p:spPr>
+          <a:xfrm>
+            <a:off x="6967728" y="1344168"/>
+            <a:ext cx="4352544" cy="4169664"/>
+          </a:xfrm>
+          <a:prstGeom prst="rect">
+            <a:avLst/>
+          </a:prstGeom>
+        </p:spPr>
+      </p:pic>
     </p:spTree>
   </p:cSld>
   <p:clrMapOvr>
@@ -5187,7 +5354,7 @@
             <a:avLst/>
           </a:prstGeom>
           <a:solidFill>
-            <a:srgbClr val="070D1C"/>
+            <a:srgbClr val="F6F8FB"/>
           </a:solidFill>
           <a:ln>
             <a:noFill/>
@@ -5230,7 +5397,7 @@
             <a:avLst/>
           </a:prstGeom>
           <a:solidFill>
-            <a:srgbClr val="2997FF"/>
+            <a:srgbClr val="DDE4EE"/>
           </a:solidFill>
           <a:ln>
             <a:noFill/>
@@ -5273,7 +5440,7 @@
             <a:avLst/>
           </a:prstGeom>
           <a:solidFill>
-            <a:srgbClr val="00D6C9"/>
+            <a:srgbClr val="DFE6F0"/>
           </a:solidFill>
           <a:ln>
             <a:noFill/>
@@ -5316,7 +5483,7 @@
             <a:avLst/>
           </a:prstGeom>
           <a:solidFill>
-            <a:srgbClr val="111C35"/>
+            <a:srgbClr val="E7ECF4"/>
           </a:solidFill>
           <a:ln>
             <a:noFill/>
@@ -5369,9 +5536,9 @@
             <a:r>
               <a:rPr sz="3400" b="1">
                 <a:solidFill>
-                  <a:srgbClr val="2997FF"/>
+                  <a:srgbClr val="102B52"/>
                 </a:solidFill>
-                <a:latin typeface="Poppins"/>
+                <a:latin typeface="Segoe UI"/>
               </a:rPr>
               <a:t>Why the Gap Persists</a:t>
             </a:r>
@@ -5386,18 +5553,18 @@
         </p:nvSpPr>
         <p:spPr>
           <a:xfrm>
-            <a:off x="731520" y="1280160"/>
-            <a:ext cx="3200400" cy="2011680"/>
+            <a:off x="548640" y="1280160"/>
+            <a:ext cx="5669280" cy="822960"/>
           </a:xfrm>
           <a:prstGeom prst="roundRect">
             <a:avLst/>
           </a:prstGeom>
           <a:solidFill>
-            <a:srgbClr val="16213D"/>
+            <a:srgbClr val="FFFFFF"/>
           </a:solidFill>
           <a:ln w="15240">
             <a:solidFill>
-              <a:srgbClr val="3A5184"/>
+              <a:srgbClr val="CBD6E5"/>
             </a:solidFill>
           </a:ln>
         </p:spPr>
@@ -5431,14 +5598,14 @@
         </p:nvSpPr>
         <p:spPr>
           <a:xfrm>
-            <a:off x="914400" y="1463040"/>
-            <a:ext cx="402336" cy="402336"/>
+            <a:off x="713232" y="1444752"/>
+            <a:ext cx="320040" cy="320040"/>
           </a:xfrm>
           <a:prstGeom prst="ellipse">
             <a:avLst/>
           </a:prstGeom>
           <a:solidFill>
-            <a:srgbClr val="2997FF"/>
+            <a:srgbClr val="0F2445"/>
           </a:solidFill>
           <a:ln>
             <a:solidFill>
@@ -5476,8 +5643,8 @@
         </p:nvSpPr>
         <p:spPr>
           <a:xfrm>
-            <a:off x="914400" y="1481328"/>
-            <a:ext cx="402336" cy="402336"/>
+            <a:off x="713232" y="1444752"/>
+            <a:ext cx="320040" cy="320040"/>
           </a:xfrm>
           <a:prstGeom prst="rect">
             <a:avLst/>
@@ -5494,9 +5661,9 @@
             <a:r>
               <a:rPr sz="1400" b="1">
                 <a:solidFill>
-                  <a:srgbClr val="070D1C"/>
+                  <a:srgbClr val="2D3848"/>
                 </a:solidFill>
-                <a:latin typeface="Inter"/>
+                <a:latin typeface="Segoe UI"/>
               </a:rPr>
               <a:t>•</a:t>
             </a:r>
@@ -5511,8 +5678,8 @@
         </p:nvSpPr>
         <p:spPr>
           <a:xfrm>
-            <a:off x="1417320" y="1463040"/>
-            <a:ext cx="2377440" cy="1645920"/>
+            <a:off x="1188720" y="1371600"/>
+            <a:ext cx="4800600" cy="658368"/>
           </a:xfrm>
           <a:prstGeom prst="rect">
             <a:avLst/>
@@ -5528,9 +5695,9 @@
             <a:r>
               <a:rPr b="1" sz="1800">
                 <a:solidFill>
-                  <a:srgbClr val="E6EEFC"/>
+                  <a:srgbClr val="2D3848"/>
                 </a:solidFill>
-                <a:latin typeface="Poppins"/>
+                <a:latin typeface="Segoe UI"/>
               </a:rPr>
               <a:t>Process</a:t>
             </a:r>
@@ -5539,9 +5706,9 @@
             <a:r>
               <a:rPr sz="1400">
                 <a:solidFill>
-                  <a:srgbClr val="A6B4D1"/>
+                  <a:srgbClr val="2D3848"/>
                 </a:solidFill>
-                <a:latin typeface="Inter"/>
+                <a:latin typeface="Segoe UI"/>
               </a:rPr>
               <a:t>Legal help starts after incidents, not during them.</a:t>
             </a:r>
@@ -5556,18 +5723,18 @@
         </p:nvSpPr>
         <p:spPr>
           <a:xfrm>
-            <a:off x="4526280" y="1280160"/>
-            <a:ext cx="3200400" cy="2011680"/>
+            <a:off x="548640" y="2267712"/>
+            <a:ext cx="5669280" cy="822960"/>
           </a:xfrm>
           <a:prstGeom prst="roundRect">
             <a:avLst/>
           </a:prstGeom>
           <a:solidFill>
-            <a:srgbClr val="16213D"/>
+            <a:srgbClr val="FFFFFF"/>
           </a:solidFill>
           <a:ln w="15240">
             <a:solidFill>
-              <a:srgbClr val="3A5184"/>
+              <a:srgbClr val="CBD6E5"/>
             </a:solidFill>
           </a:ln>
         </p:spPr>
@@ -5601,14 +5768,14 @@
         </p:nvSpPr>
         <p:spPr>
           <a:xfrm>
-            <a:off x="4709160" y="1463040"/>
-            <a:ext cx="402336" cy="402336"/>
+            <a:off x="713232" y="2432304"/>
+            <a:ext cx="320040" cy="320040"/>
           </a:xfrm>
           <a:prstGeom prst="ellipse">
             <a:avLst/>
           </a:prstGeom>
           <a:solidFill>
-            <a:srgbClr val="2997FF"/>
+            <a:srgbClr val="0F2445"/>
           </a:solidFill>
           <a:ln>
             <a:solidFill>
@@ -5646,8 +5813,8 @@
         </p:nvSpPr>
         <p:spPr>
           <a:xfrm>
-            <a:off x="4709160" y="1481328"/>
-            <a:ext cx="402336" cy="402336"/>
+            <a:off x="713232" y="2432304"/>
+            <a:ext cx="320040" cy="320040"/>
           </a:xfrm>
           <a:prstGeom prst="rect">
             <a:avLst/>
@@ -5664,9 +5831,9 @@
             <a:r>
               <a:rPr sz="1400" b="1">
                 <a:solidFill>
-                  <a:srgbClr val="070D1C"/>
+                  <a:srgbClr val="2D3848"/>
                 </a:solidFill>
-                <a:latin typeface="Inter"/>
+                <a:latin typeface="Segoe UI"/>
               </a:rPr>
               <a:t>•</a:t>
             </a:r>
@@ -5681,8 +5848,8 @@
         </p:nvSpPr>
         <p:spPr>
           <a:xfrm>
-            <a:off x="5212080" y="1463040"/>
-            <a:ext cx="2377440" cy="1645920"/>
+            <a:off x="1188720" y="2359152"/>
+            <a:ext cx="4800600" cy="658368"/>
           </a:xfrm>
           <a:prstGeom prst="rect">
             <a:avLst/>
@@ -5698,9 +5865,9 @@
             <a:r>
               <a:rPr b="1" sz="1800">
                 <a:solidFill>
-                  <a:srgbClr val="E6EEFC"/>
+                  <a:srgbClr val="2D3848"/>
                 </a:solidFill>
-                <a:latin typeface="Poppins"/>
+                <a:latin typeface="Segoe UI"/>
               </a:rPr>
               <a:t>Systems</a:t>
             </a:r>
@@ -5709,9 +5876,9 @@
             <a:r>
               <a:rPr sz="1400">
                 <a:solidFill>
-                  <a:srgbClr val="A6B4D1"/>
+                  <a:srgbClr val="2D3848"/>
                 </a:solidFill>
-                <a:latin typeface="Inter"/>
+                <a:latin typeface="Segoe UI"/>
               </a:rPr>
               <a:t>Dense legal docs are hard to search on mobile.</a:t>
             </a:r>
@@ -5726,18 +5893,18 @@
         </p:nvSpPr>
         <p:spPr>
           <a:xfrm>
-            <a:off x="8321040" y="1280160"/>
-            <a:ext cx="3200400" cy="2011680"/>
+            <a:off x="548640" y="3255264"/>
+            <a:ext cx="5669280" cy="822960"/>
           </a:xfrm>
           <a:prstGeom prst="roundRect">
             <a:avLst/>
           </a:prstGeom>
           <a:solidFill>
-            <a:srgbClr val="16213D"/>
+            <a:srgbClr val="FFFFFF"/>
           </a:solidFill>
           <a:ln w="15240">
             <a:solidFill>
-              <a:srgbClr val="3A5184"/>
+              <a:srgbClr val="CBD6E5"/>
             </a:solidFill>
           </a:ln>
         </p:spPr>
@@ -5771,14 +5938,14 @@
         </p:nvSpPr>
         <p:spPr>
           <a:xfrm>
-            <a:off x="8503920" y="1463040"/>
-            <a:ext cx="402336" cy="402336"/>
+            <a:off x="713232" y="3419856"/>
+            <a:ext cx="320040" cy="320040"/>
           </a:xfrm>
           <a:prstGeom prst="ellipse">
             <a:avLst/>
           </a:prstGeom>
           <a:solidFill>
-            <a:srgbClr val="2997FF"/>
+            <a:srgbClr val="0F2445"/>
           </a:solidFill>
           <a:ln>
             <a:solidFill>
@@ -5816,8 +5983,8 @@
         </p:nvSpPr>
         <p:spPr>
           <a:xfrm>
-            <a:off x="8503920" y="1481328"/>
-            <a:ext cx="402336" cy="402336"/>
+            <a:off x="713232" y="3419856"/>
+            <a:ext cx="320040" cy="320040"/>
           </a:xfrm>
           <a:prstGeom prst="rect">
             <a:avLst/>
@@ -5834,9 +6001,9 @@
             <a:r>
               <a:rPr sz="1400" b="1">
                 <a:solidFill>
-                  <a:srgbClr val="070D1C"/>
+                  <a:srgbClr val="2D3848"/>
                 </a:solidFill>
-                <a:latin typeface="Inter"/>
+                <a:latin typeface="Segoe UI"/>
               </a:rPr>
               <a:t>•</a:t>
             </a:r>
@@ -5851,8 +6018,8 @@
         </p:nvSpPr>
         <p:spPr>
           <a:xfrm>
-            <a:off x="9006840" y="1463040"/>
-            <a:ext cx="2377440" cy="1645920"/>
+            <a:off x="1188720" y="3346704"/>
+            <a:ext cx="4800600" cy="658368"/>
           </a:xfrm>
           <a:prstGeom prst="rect">
             <a:avLst/>
@@ -5868,9 +6035,9 @@
             <a:r>
               <a:rPr b="1" sz="1800">
                 <a:solidFill>
-                  <a:srgbClr val="E6EEFC"/>
+                  <a:srgbClr val="2D3848"/>
                 </a:solidFill>
-                <a:latin typeface="Poppins"/>
+                <a:latin typeface="Segoe UI"/>
               </a:rPr>
               <a:t>Data</a:t>
             </a:r>
@@ -5879,9 +6046,9 @@
             <a:r>
               <a:rPr sz="1400">
                 <a:solidFill>
-                  <a:srgbClr val="A6B4D1"/>
+                  <a:srgbClr val="2D3848"/>
                 </a:solidFill>
-                <a:latin typeface="Inter"/>
+                <a:latin typeface="Segoe UI"/>
               </a:rPr>
               <a:t>Rights questions are under-tracked, limiting insights.</a:t>
             </a:r>
@@ -5896,18 +6063,18 @@
         </p:nvSpPr>
         <p:spPr>
           <a:xfrm>
-            <a:off x="2651760" y="3657600"/>
-            <a:ext cx="3200400" cy="2011680"/>
+            <a:off x="548640" y="4242816"/>
+            <a:ext cx="5669280" cy="822960"/>
           </a:xfrm>
           <a:prstGeom prst="roundRect">
             <a:avLst/>
           </a:prstGeom>
           <a:solidFill>
-            <a:srgbClr val="16213D"/>
+            <a:srgbClr val="FFFFFF"/>
           </a:solidFill>
           <a:ln w="15240">
             <a:solidFill>
-              <a:srgbClr val="3A5184"/>
+              <a:srgbClr val="CBD6E5"/>
             </a:solidFill>
           </a:ln>
         </p:spPr>
@@ -5941,14 +6108,14 @@
         </p:nvSpPr>
         <p:spPr>
           <a:xfrm>
-            <a:off x="2834640" y="3840480"/>
-            <a:ext cx="402336" cy="402336"/>
+            <a:off x="713232" y="4407408"/>
+            <a:ext cx="320040" cy="320040"/>
           </a:xfrm>
           <a:prstGeom prst="ellipse">
             <a:avLst/>
           </a:prstGeom>
           <a:solidFill>
-            <a:srgbClr val="2997FF"/>
+            <a:srgbClr val="0F2445"/>
           </a:solidFill>
           <a:ln>
             <a:solidFill>
@@ -5986,8 +6153,8 @@
         </p:nvSpPr>
         <p:spPr>
           <a:xfrm>
-            <a:off x="2834640" y="3858768"/>
-            <a:ext cx="402336" cy="402336"/>
+            <a:off x="713232" y="4407408"/>
+            <a:ext cx="320040" cy="320040"/>
           </a:xfrm>
           <a:prstGeom prst="rect">
             <a:avLst/>
@@ -6004,9 +6171,9 @@
             <a:r>
               <a:rPr sz="1400" b="1">
                 <a:solidFill>
-                  <a:srgbClr val="070D1C"/>
+                  <a:srgbClr val="2D3848"/>
                 </a:solidFill>
-                <a:latin typeface="Inter"/>
+                <a:latin typeface="Segoe UI"/>
               </a:rPr>
               <a:t>•</a:t>
             </a:r>
@@ -6021,8 +6188,8 @@
         </p:nvSpPr>
         <p:spPr>
           <a:xfrm>
-            <a:off x="3337560" y="3840480"/>
-            <a:ext cx="2377440" cy="1645920"/>
+            <a:off x="1188720" y="4334256"/>
+            <a:ext cx="4800600" cy="658368"/>
           </a:xfrm>
           <a:prstGeom prst="rect">
             <a:avLst/>
@@ -6038,9 +6205,9 @@
             <a:r>
               <a:rPr b="1" sz="1800">
                 <a:solidFill>
-                  <a:srgbClr val="E6EEFC"/>
+                  <a:srgbClr val="2D3848"/>
                 </a:solidFill>
-                <a:latin typeface="Poppins"/>
+                <a:latin typeface="Segoe UI"/>
               </a:rPr>
               <a:t>Security</a:t>
             </a:r>
@@ -6049,9 +6216,9 @@
             <a:r>
               <a:rPr sz="1400">
                 <a:solidFill>
-                  <a:srgbClr val="A6B4D1"/>
+                  <a:srgbClr val="2D3848"/>
                 </a:solidFill>
-                <a:latin typeface="Inter"/>
+                <a:latin typeface="Segoe UI"/>
               </a:rPr>
               <a:t>Surveillance concerns prevent people from asking.</a:t>
             </a:r>
@@ -6066,18 +6233,18 @@
         </p:nvSpPr>
         <p:spPr>
           <a:xfrm>
-            <a:off x="6446520" y="3657600"/>
-            <a:ext cx="3200400" cy="2011680"/>
+            <a:off x="548640" y="5230368"/>
+            <a:ext cx="5669280" cy="822960"/>
           </a:xfrm>
           <a:prstGeom prst="roundRect">
             <a:avLst/>
           </a:prstGeom>
           <a:solidFill>
-            <a:srgbClr val="16213D"/>
+            <a:srgbClr val="FFFFFF"/>
           </a:solidFill>
           <a:ln w="15240">
             <a:solidFill>
-              <a:srgbClr val="3A5184"/>
+              <a:srgbClr val="CBD6E5"/>
             </a:solidFill>
           </a:ln>
         </p:spPr>
@@ -6111,14 +6278,14 @@
         </p:nvSpPr>
         <p:spPr>
           <a:xfrm>
-            <a:off x="6629400" y="3840480"/>
-            <a:ext cx="402336" cy="402336"/>
+            <a:off x="713232" y="5394960"/>
+            <a:ext cx="320040" cy="320040"/>
           </a:xfrm>
           <a:prstGeom prst="ellipse">
             <a:avLst/>
           </a:prstGeom>
           <a:solidFill>
-            <a:srgbClr val="2997FF"/>
+            <a:srgbClr val="0F2445"/>
           </a:solidFill>
           <a:ln>
             <a:solidFill>
@@ -6156,8 +6323,8 @@
         </p:nvSpPr>
         <p:spPr>
           <a:xfrm>
-            <a:off x="6629400" y="3858768"/>
-            <a:ext cx="402336" cy="402336"/>
+            <a:off x="713232" y="5394960"/>
+            <a:ext cx="320040" cy="320040"/>
           </a:xfrm>
           <a:prstGeom prst="rect">
             <a:avLst/>
@@ -6174,9 +6341,9 @@
             <a:r>
               <a:rPr sz="1400" b="1">
                 <a:solidFill>
-                  <a:srgbClr val="070D1C"/>
+                  <a:srgbClr val="2D3848"/>
                 </a:solidFill>
-                <a:latin typeface="Inter"/>
+                <a:latin typeface="Segoe UI"/>
               </a:rPr>
               <a:t>•</a:t>
             </a:r>
@@ -6191,8 +6358,8 @@
         </p:nvSpPr>
         <p:spPr>
           <a:xfrm>
-            <a:off x="7132320" y="3840480"/>
-            <a:ext cx="2377440" cy="1645920"/>
+            <a:off x="1188720" y="5321808"/>
+            <a:ext cx="4800600" cy="658368"/>
           </a:xfrm>
           <a:prstGeom prst="rect">
             <a:avLst/>
@@ -6208,9 +6375,9 @@
             <a:r>
               <a:rPr b="1" sz="1800">
                 <a:solidFill>
-                  <a:srgbClr val="E6EEFC"/>
+                  <a:srgbClr val="2D3848"/>
                 </a:solidFill>
-                <a:latin typeface="Poppins"/>
+                <a:latin typeface="Segoe UI"/>
               </a:rPr>
               <a:t>Strategy</a:t>
             </a:r>
@@ -6219,15 +6386,39 @@
             <a:r>
               <a:rPr sz="1400">
                 <a:solidFill>
-                  <a:srgbClr val="A6B4D1"/>
+                  <a:srgbClr val="2D3848"/>
                 </a:solidFill>
-                <a:latin typeface="Inter"/>
+                <a:latin typeface="Segoe UI"/>
               </a:rPr>
               <a:t>Legacy incentives underfund low-cost legal tools.</a:t>
             </a:r>
           </a:p>
         </p:txBody>
       </p:sp>
+      <p:pic>
+        <p:nvPicPr>
+          <p:cNvPr id="27" name="Picture 26" descr="time_bureaucracy.png"/>
+          <p:cNvPicPr>
+            <a:picLocks noChangeAspect="1"/>
+          </p:cNvPicPr>
+          <p:nvPr/>
+        </p:nvPicPr>
+        <p:blipFill>
+          <a:blip r:embed="rId4"/>
+          <a:stretch>
+            <a:fillRect/>
+          </a:stretch>
+        </p:blipFill>
+        <p:spPr>
+          <a:xfrm>
+            <a:off x="6400800" y="1280160"/>
+            <a:ext cx="3931920" cy="4480560"/>
+          </a:xfrm>
+          <a:prstGeom prst="rect">
+            <a:avLst/>
+          </a:prstGeom>
+        </p:spPr>
+      </p:pic>
     </p:spTree>
   </p:cSld>
   <p:clrMapOvr>
@@ -6269,7 +6460,7 @@
             <a:avLst/>
           </a:prstGeom>
           <a:solidFill>
-            <a:srgbClr val="070D1C"/>
+            <a:srgbClr val="F6F8FB"/>
           </a:solidFill>
           <a:ln>
             <a:noFill/>
@@ -6312,7 +6503,7 @@
             <a:avLst/>
           </a:prstGeom>
           <a:solidFill>
-            <a:srgbClr val="2997FF"/>
+            <a:srgbClr val="DDE4EE"/>
           </a:solidFill>
           <a:ln>
             <a:noFill/>
@@ -6355,7 +6546,7 @@
             <a:avLst/>
           </a:prstGeom>
           <a:solidFill>
-            <a:srgbClr val="00D6C9"/>
+            <a:srgbClr val="DFE6F0"/>
           </a:solidFill>
           <a:ln>
             <a:noFill/>
@@ -6398,7 +6589,7 @@
             <a:avLst/>
           </a:prstGeom>
           <a:solidFill>
-            <a:srgbClr val="111C35"/>
+            <a:srgbClr val="E7ECF4"/>
           </a:solidFill>
           <a:ln>
             <a:noFill/>
@@ -6449,11 +6640,11 @@
           <a:lstStyle/>
           <a:p>
             <a:r>
-              <a:rPr sz="3400" b="1">
+              <a:rPr b="1" sz="3000">
                 <a:solidFill>
-                  <a:srgbClr val="2997FF"/>
+                  <a:srgbClr val="102B52"/>
                 </a:solidFill>
-                <a:latin typeface="Poppins"/>
+                <a:latin typeface="Segoe UI"/>
               </a:rPr>
               <a:t>Solution: RonyGuard Platform</a:t>
             </a:r>
@@ -6520,11 +6711,11 @@
             <a:avLst/>
           </a:prstGeom>
           <a:solidFill>
-            <a:srgbClr val="1A2C4D"/>
+            <a:srgbClr val="FFFFFF"/>
           </a:solidFill>
           <a:ln>
             <a:solidFill>
-              <a:srgbClr val="2997FF"/>
+              <a:srgbClr val="CBD6E5"/>
             </a:solidFill>
           </a:ln>
         </p:spPr>
@@ -6571,50 +6762,7 @@
             <a:spAutoFit/>
           </a:bodyPr>
           <a:lstStyle/>
-          <a:p>
-            <a:r>
-              <a:rPr sz="1800" b="1">
-                <a:solidFill>
-                  <a:srgbClr val="E6EEFC"/>
-                </a:solidFill>
-                <a:latin typeface="Inter"/>
-              </a:rPr>
-              <a:t>App Mockup Placeholder</a:t>
-            </a:r>
-          </a:p>
-          <a:p>
-            <a:r>
-              <a:rPr sz="1500" b="0">
-                <a:solidFill>
-                  <a:srgbClr val="A6B4D1"/>
-                </a:solidFill>
-                <a:latin typeface="Inter"/>
-              </a:rPr>
-              <a:t>Rights by scenario</a:t>
-            </a:r>
-          </a:p>
-          <a:p>
-            <a:r>
-              <a:rPr sz="1500" b="0">
-                <a:solidFill>
-                  <a:srgbClr val="A6B4D1"/>
-                </a:solidFill>
-                <a:latin typeface="Inter"/>
-              </a:rPr>
-              <a:t>Voice + text guidance</a:t>
-            </a:r>
-          </a:p>
-          <a:p>
-            <a:r>
-              <a:rPr sz="1500" b="0">
-                <a:solidFill>
-                  <a:srgbClr val="A6B4D1"/>
-                </a:solidFill>
-                <a:latin typeface="Inter"/>
-              </a:rPr>
-              <a:t>Save incident timeline</a:t>
-            </a:r>
-          </a:p>
+          <a:p/>
         </p:txBody>
       </p:sp>
       <p:sp>
@@ -6640,11 +6788,11 @@
           <a:lstStyle/>
           <a:p>
             <a:r>
-              <a:rPr sz="1800">
+              <a:rPr sz="1400">
                 <a:solidFill>
-                  <a:srgbClr val="E6EEFC"/>
+                  <a:srgbClr val="2D3848"/>
                 </a:solidFill>
-                <a:latin typeface="Inter"/>
+                <a:latin typeface="Segoe UI"/>
               </a:rPr>
               <a:t>A subscription mobile + web service that gives immediate, plain-language legal guidance.</a:t>
             </a:r>
@@ -6763,13 +6911,12 @@
           </a:bodyPr>
           <a:lstStyle/>
           <a:p>
-            <a:pPr algn="ctr"/>
-            <a:r>
-              <a:rPr sz="1400" b="1">
+            <a:r>
+              <a:rPr sz="1400">
                 <a:solidFill>
-                  <a:srgbClr val="070D1C"/>
+                  <a:srgbClr val="2D3848"/>
                 </a:solidFill>
-                <a:latin typeface="Inter"/>
+                <a:latin typeface="Segoe UI"/>
               </a:rPr>
               <a:t>✓</a:t>
             </a:r>
@@ -6799,22 +6946,22 @@
           <a:lstStyle/>
           <a:p>
             <a:r>
-              <a:rPr b="1" sz="1600">
+              <a:rPr sz="1400">
                 <a:solidFill>
-                  <a:srgbClr val="E6EEFC"/>
+                  <a:srgbClr val="2D3848"/>
                 </a:solidFill>
-                <a:latin typeface="Poppins"/>
+                <a:latin typeface="Segoe UI"/>
               </a:rPr>
               <a:t>24/7 Instant Support</a:t>
             </a:r>
           </a:p>
           <a:p>
             <a:r>
-              <a:rPr sz="1300">
+              <a:rPr sz="1400">
                 <a:solidFill>
-                  <a:srgbClr val="A6B4D1"/>
+                  <a:srgbClr val="2D3848"/>
                 </a:solidFill>
-                <a:latin typeface="Inter"/>
+                <a:latin typeface="Segoe UI"/>
               </a:rPr>
               <a:t>Real-time next steps in high-stress moments.</a:t>
             </a:r>
@@ -6933,13 +7080,12 @@
           </a:bodyPr>
           <a:lstStyle/>
           <a:p>
-            <a:pPr algn="ctr"/>
-            <a:r>
-              <a:rPr sz="1400" b="1">
+            <a:r>
+              <a:rPr sz="1400">
                 <a:solidFill>
-                  <a:srgbClr val="070D1C"/>
+                  <a:srgbClr val="2D3848"/>
                 </a:solidFill>
-                <a:latin typeface="Inter"/>
+                <a:latin typeface="Segoe UI"/>
               </a:rPr>
               <a:t>✓</a:t>
             </a:r>
@@ -6969,22 +7115,22 @@
           <a:lstStyle/>
           <a:p>
             <a:r>
-              <a:rPr b="1" sz="1600">
+              <a:rPr sz="1400">
                 <a:solidFill>
-                  <a:srgbClr val="E6EEFC"/>
+                  <a:srgbClr val="2D3848"/>
                 </a:solidFill>
-                <a:latin typeface="Poppins"/>
+                <a:latin typeface="Segoe UI"/>
               </a:rPr>
               <a:t>Scalable AI Platform</a:t>
             </a:r>
           </a:p>
           <a:p>
             <a:r>
-              <a:rPr sz="1300">
+              <a:rPr sz="1400">
                 <a:solidFill>
-                  <a:srgbClr val="A6B4D1"/>
+                  <a:srgbClr val="2D3848"/>
                 </a:solidFill>
-                <a:latin typeface="Inter"/>
+                <a:latin typeface="Segoe UI"/>
               </a:rPr>
               <a:t>SaaS + PaaS architecture for fast iteration.</a:t>
             </a:r>
@@ -7103,13 +7249,12 @@
           </a:bodyPr>
           <a:lstStyle/>
           <a:p>
-            <a:pPr algn="ctr"/>
-            <a:r>
-              <a:rPr sz="1400" b="1">
+            <a:r>
+              <a:rPr sz="1400">
                 <a:solidFill>
-                  <a:srgbClr val="070D1C"/>
+                  <a:srgbClr val="2D3848"/>
                 </a:solidFill>
-                <a:latin typeface="Inter"/>
+                <a:latin typeface="Segoe UI"/>
               </a:rPr>
               <a:t>✓</a:t>
             </a:r>
@@ -7139,28 +7284,52 @@
           <a:lstStyle/>
           <a:p>
             <a:r>
-              <a:rPr b="1" sz="1600">
+              <a:rPr sz="1400">
                 <a:solidFill>
-                  <a:srgbClr val="E6EEFC"/>
+                  <a:srgbClr val="2D3848"/>
                 </a:solidFill>
-                <a:latin typeface="Poppins"/>
+                <a:latin typeface="Segoe UI"/>
               </a:rPr>
               <a:t>Business Upside</a:t>
             </a:r>
           </a:p>
           <a:p>
             <a:r>
-              <a:rPr sz="1300">
+              <a:rPr sz="1400">
                 <a:solidFill>
-                  <a:srgbClr val="A6B4D1"/>
+                  <a:srgbClr val="2D3848"/>
                 </a:solidFill>
-                <a:latin typeface="Inter"/>
+                <a:latin typeface="Segoe UI"/>
               </a:rPr>
               <a:t>Recurring revenue without linear staffing growth.</a:t>
             </a:r>
           </a:p>
         </p:txBody>
       </p:sp>
+      <p:pic>
+        <p:nvPicPr>
+          <p:cNvPr id="23" name="Picture 22" descr="smartphone_5g_cloud.png"/>
+          <p:cNvPicPr>
+            <a:picLocks noChangeAspect="1"/>
+          </p:cNvPicPr>
+          <p:nvPr/>
+        </p:nvPicPr>
+        <p:blipFill>
+          <a:blip r:embed="rId4"/>
+          <a:stretch>
+            <a:fillRect/>
+          </a:stretch>
+        </p:blipFill>
+        <p:spPr>
+          <a:xfrm>
+            <a:off x="1399032" y="1709928"/>
+            <a:ext cx="3419855" cy="3474720"/>
+          </a:xfrm>
+          <a:prstGeom prst="rect">
+            <a:avLst/>
+          </a:prstGeom>
+        </p:spPr>
+      </p:pic>
     </p:spTree>
   </p:cSld>
   <p:clrMapOvr>
@@ -7202,7 +7371,7 @@
             <a:avLst/>
           </a:prstGeom>
           <a:solidFill>
-            <a:srgbClr val="070D1C"/>
+            <a:srgbClr val="F6F8FB"/>
           </a:solidFill>
           <a:ln>
             <a:noFill/>
@@ -7245,7 +7414,7 @@
             <a:avLst/>
           </a:prstGeom>
           <a:solidFill>
-            <a:srgbClr val="2997FF"/>
+            <a:srgbClr val="DDE4EE"/>
           </a:solidFill>
           <a:ln>
             <a:noFill/>
@@ -7288,7 +7457,7 @@
             <a:avLst/>
           </a:prstGeom>
           <a:solidFill>
-            <a:srgbClr val="00D6C9"/>
+            <a:srgbClr val="DFE6F0"/>
           </a:solidFill>
           <a:ln>
             <a:noFill/>
@@ -7331,7 +7500,7 @@
             <a:avLst/>
           </a:prstGeom>
           <a:solidFill>
-            <a:srgbClr val="111C35"/>
+            <a:srgbClr val="E7ECF4"/>
           </a:solidFill>
           <a:ln>
             <a:noFill/>
@@ -7382,13 +7551,13 @@
           <a:lstStyle/>
           <a:p>
             <a:r>
-              <a:rPr sz="3200" b="1">
+              <a:rPr b="1" sz="3000">
                 <a:solidFill>
-                  <a:srgbClr val="2997FF"/>
+                  <a:srgbClr val="102B52"/>
                 </a:solidFill>
-                <a:latin typeface="Poppins"/>
+                <a:latin typeface="Segoe UI"/>
               </a:rPr>
-              <a:t>How It Works: Tech, Data, Security</a:t>
+              <a:t>Revenue &amp; Expense Visualization</a:t>
             </a:r>
           </a:p>
         </p:txBody>
@@ -7509,9 +7678,9 @@
             <a:r>
               <a:rPr sz="1400" b="1">
                 <a:solidFill>
-                  <a:srgbClr val="070D1C"/>
+                  <a:srgbClr val="2D3848"/>
                 </a:solidFill>
-                <a:latin typeface="Inter"/>
+                <a:latin typeface="Segoe UI"/>
               </a:rPr>
               <a:t>1</a:t>
             </a:r>
@@ -7543,9 +7712,9 @@
             <a:r>
               <a:rPr b="1" sz="1600">
                 <a:solidFill>
-                  <a:srgbClr val="E6EEFC"/>
+                  <a:srgbClr val="2D3848"/>
                 </a:solidFill>
-                <a:latin typeface="Poppins"/>
+                <a:latin typeface="Segoe UI"/>
               </a:rPr>
               <a:t>API Networking</a:t>
             </a:r>
@@ -7554,9 +7723,9 @@
             <a:r>
               <a:rPr sz="1250">
                 <a:solidFill>
-                  <a:srgbClr val="A6B4D1"/>
+                  <a:srgbClr val="2D3848"/>
                 </a:solidFill>
-                <a:latin typeface="Inter"/>
+                <a:latin typeface="Segoe UI"/>
               </a:rPr>
               <a:t>HTTPS APIs over mobile networks for low-latency responses.</a:t>
             </a:r>
@@ -7679,9 +7848,9 @@
             <a:r>
               <a:rPr sz="1400" b="1">
                 <a:solidFill>
-                  <a:srgbClr val="070D1C"/>
+                  <a:srgbClr val="2D3848"/>
                 </a:solidFill>
-                <a:latin typeface="Inter"/>
+                <a:latin typeface="Segoe UI"/>
               </a:rPr>
               <a:t>2</a:t>
             </a:r>
@@ -7713,9 +7882,9 @@
             <a:r>
               <a:rPr b="1" sz="1600">
                 <a:solidFill>
-                  <a:srgbClr val="E6EEFC"/>
+                  <a:srgbClr val="2D3848"/>
                 </a:solidFill>
-                <a:latin typeface="Poppins"/>
+                <a:latin typeface="Segoe UI"/>
               </a:rPr>
               <a:t>Vector Retrieval</a:t>
             </a:r>
@@ -7724,9 +7893,9 @@
             <a:r>
               <a:rPr sz="1250">
                 <a:solidFill>
-                  <a:srgbClr val="A6B4D1"/>
+                  <a:srgbClr val="2D3848"/>
                 </a:solidFill>
-                <a:latin typeface="Inter"/>
+                <a:latin typeface="Segoe UI"/>
               </a:rPr>
               <a:t>Semantic search across legal texts and FAQs.</a:t>
             </a:r>
@@ -7849,9 +8018,9 @@
             <a:r>
               <a:rPr sz="1400" b="1">
                 <a:solidFill>
-                  <a:srgbClr val="070D1C"/>
+                  <a:srgbClr val="2D3848"/>
                 </a:solidFill>
-                <a:latin typeface="Inter"/>
+                <a:latin typeface="Segoe UI"/>
               </a:rPr>
               <a:t>3</a:t>
             </a:r>
@@ -7883,9 +8052,9 @@
             <a:r>
               <a:rPr b="1" sz="1600">
                 <a:solidFill>
-                  <a:srgbClr val="E6EEFC"/>
+                  <a:srgbClr val="2D3848"/>
                 </a:solidFill>
-                <a:latin typeface="Poppins"/>
+                <a:latin typeface="Segoe UI"/>
               </a:rPr>
               <a:t>Security Controls</a:t>
             </a:r>
@@ -7894,9 +8063,9 @@
             <a:r>
               <a:rPr sz="1250">
                 <a:solidFill>
-                  <a:srgbClr val="A6B4D1"/>
+                  <a:srgbClr val="2D3848"/>
                 </a:solidFill>
-                <a:latin typeface="Inter"/>
+                <a:latin typeface="Segoe UI"/>
               </a:rPr>
               <a:t>AES-256, TLS, biometrics, RBAC, audit logs, backups.</a:t>
             </a:r>
@@ -8019,9 +8188,9 @@
             <a:r>
               <a:rPr sz="1400" b="1">
                 <a:solidFill>
-                  <a:srgbClr val="070D1C"/>
+                  <a:srgbClr val="2D3848"/>
                 </a:solidFill>
-                <a:latin typeface="Inter"/>
+                <a:latin typeface="Segoe UI"/>
               </a:rPr>
               <a:t>4</a:t>
             </a:r>
@@ -8053,9 +8222,9 @@
             <a:r>
               <a:rPr b="1" sz="1600">
                 <a:solidFill>
-                  <a:srgbClr val="E6EEFC"/>
+                  <a:srgbClr val="2D3848"/>
                 </a:solidFill>
-                <a:latin typeface="Poppins"/>
+                <a:latin typeface="Segoe UI"/>
               </a:rPr>
               <a:t>Enterprise AI</a:t>
             </a:r>
@@ -8064,9 +8233,9 @@
             <a:r>
               <a:rPr sz="1250">
                 <a:solidFill>
-                  <a:srgbClr val="A6B4D1"/>
+                  <a:srgbClr val="2D3848"/>
                 </a:solidFill>
-                <a:latin typeface="Inter"/>
+                <a:latin typeface="Segoe UI"/>
               </a:rPr>
               <a:t>RAG on Vertex AI-style stack to improve relevance.</a:t>
             </a:r>
@@ -8189,9 +8358,9 @@
             <a:r>
               <a:rPr sz="1400" b="1">
                 <a:solidFill>
-                  <a:srgbClr val="070D1C"/>
+                  <a:srgbClr val="2D3848"/>
                 </a:solidFill>
-                <a:latin typeface="Inter"/>
+                <a:latin typeface="Segoe UI"/>
               </a:rPr>
               <a:t>5</a:t>
             </a:r>
@@ -8223,9 +8392,9 @@
             <a:r>
               <a:rPr b="1" sz="1600">
                 <a:solidFill>
-                  <a:srgbClr val="E6EEFC"/>
+                  <a:srgbClr val="2D3848"/>
                 </a:solidFill>
-                <a:latin typeface="Poppins"/>
+                <a:latin typeface="Segoe UI"/>
               </a:rPr>
               <a:t>Agile Delivery</a:t>
             </a:r>
@@ -8234,15 +8403,33 @@
             <a:r>
               <a:rPr sz="1250">
                 <a:solidFill>
-                  <a:srgbClr val="A6B4D1"/>
+                  <a:srgbClr val="2D3848"/>
                 </a:solidFill>
-                <a:latin typeface="Inter"/>
+                <a:latin typeface="Segoe UI"/>
               </a:rPr>
               <a:t>MVP sprints, feedback loops, and localization readiness.</a:t>
             </a:r>
           </a:p>
         </p:txBody>
       </p:sp>
+      <p:graphicFrame>
+        <p:nvGraphicFramePr>
+          <p:cNvPr id="27" name="Chart 26"/>
+          <p:cNvGraphicFramePr>
+            <a:graphicFrameLocks noGrp="1"/>
+          </p:cNvGraphicFramePr>
+          <p:nvPr/>
+        </p:nvGraphicFramePr>
+        <p:xfrm>
+          <a:off x="914400" y="1737360"/>
+          <a:ext cx="9144000" cy="3383280"/>
+        </p:xfrm>
+        <a:graphic>
+          <a:graphicData uri="http://schemas.openxmlformats.org/drawingml/2006/chart">
+            <c:chart xmlns:c="http://schemas.openxmlformats.org/drawingml/2006/chart" r:id="rId4"/>
+          </a:graphicData>
+        </a:graphic>
+      </p:graphicFrame>
     </p:spTree>
   </p:cSld>
   <p:clrMapOvr>
@@ -8284,7 +8471,7 @@
             <a:avLst/>
           </a:prstGeom>
           <a:solidFill>
-            <a:srgbClr val="070D1C"/>
+            <a:srgbClr val="F6F8FB"/>
           </a:solidFill>
           <a:ln>
             <a:noFill/>
@@ -8322,6 +8509,619 @@
           <a:xfrm>
             <a:off x="-1097280" y="-914400"/>
             <a:ext cx="5029200" cy="5029200"/>
+          </a:xfrm>
+          <a:prstGeom prst="ellipse">
+            <a:avLst/>
+          </a:prstGeom>
+          <a:solidFill>
+            <a:srgbClr val="DDE4EE"/>
+          </a:solidFill>
+          <a:ln>
+            <a:noFill/>
+          </a:ln>
+        </p:spPr>
+        <p:style>
+          <a:lnRef idx="1">
+            <a:schemeClr val="accent1"/>
+          </a:lnRef>
+          <a:fillRef idx="3">
+            <a:schemeClr val="accent1"/>
+          </a:fillRef>
+          <a:effectRef idx="2">
+            <a:schemeClr val="accent1"/>
+          </a:effectRef>
+          <a:fontRef idx="minor">
+            <a:schemeClr val="lt1"/>
+          </a:fontRef>
+        </p:style>
+        <p:txBody>
+          <a:bodyPr rtlCol="0" anchor="ctr"/>
+          <a:lstStyle/>
+          <a:p>
+            <a:pPr algn="ctr"/>
+          </a:p>
+        </p:txBody>
+      </p:sp>
+      <p:sp>
+        <p:nvSpPr>
+          <p:cNvPr id="4" name="Oval 3"/>
+          <p:cNvSpPr/>
+          <p:nvPr/>
+        </p:nvSpPr>
+        <p:spPr>
+          <a:xfrm>
+            <a:off x="7589520" y="1920240"/>
+            <a:ext cx="5029200" cy="5029200"/>
+          </a:xfrm>
+          <a:prstGeom prst="ellipse">
+            <a:avLst/>
+          </a:prstGeom>
+          <a:solidFill>
+            <a:srgbClr val="DFE6F0"/>
+          </a:solidFill>
+          <a:ln>
+            <a:noFill/>
+          </a:ln>
+        </p:spPr>
+        <p:style>
+          <a:lnRef idx="1">
+            <a:schemeClr val="accent1"/>
+          </a:lnRef>
+          <a:fillRef idx="3">
+            <a:schemeClr val="accent1"/>
+          </a:fillRef>
+          <a:effectRef idx="2">
+            <a:schemeClr val="accent1"/>
+          </a:effectRef>
+          <a:fontRef idx="minor">
+            <a:schemeClr val="lt1"/>
+          </a:fontRef>
+        </p:style>
+        <p:txBody>
+          <a:bodyPr rtlCol="0" anchor="ctr"/>
+          <a:lstStyle/>
+          <a:p>
+            <a:pPr algn="ctr"/>
+          </a:p>
+        </p:txBody>
+      </p:sp>
+      <p:sp>
+        <p:nvSpPr>
+          <p:cNvPr id="5" name="Rectangle 4"/>
+          <p:cNvSpPr/>
+          <p:nvPr/>
+        </p:nvSpPr>
+        <p:spPr>
+          <a:xfrm>
+            <a:off x="0" y="5394960"/>
+            <a:ext cx="12188952" cy="1463040"/>
+          </a:xfrm>
+          <a:prstGeom prst="rect">
+            <a:avLst/>
+          </a:prstGeom>
+          <a:solidFill>
+            <a:srgbClr val="E7ECF4"/>
+          </a:solidFill>
+          <a:ln>
+            <a:noFill/>
+          </a:ln>
+        </p:spPr>
+        <p:style>
+          <a:lnRef idx="1">
+            <a:schemeClr val="accent1"/>
+          </a:lnRef>
+          <a:fillRef idx="3">
+            <a:schemeClr val="accent1"/>
+          </a:fillRef>
+          <a:effectRef idx="2">
+            <a:schemeClr val="accent1"/>
+          </a:effectRef>
+          <a:fontRef idx="minor">
+            <a:schemeClr val="lt1"/>
+          </a:fontRef>
+        </p:style>
+        <p:txBody>
+          <a:bodyPr rtlCol="0" anchor="ctr"/>
+          <a:lstStyle/>
+          <a:p>
+            <a:pPr algn="ctr"/>
+          </a:p>
+        </p:txBody>
+      </p:sp>
+      <p:sp>
+        <p:nvSpPr>
+          <p:cNvPr id="6" name="TextBox 5"/>
+          <p:cNvSpPr txBox="1"/>
+          <p:nvPr/>
+        </p:nvSpPr>
+        <p:spPr>
+          <a:xfrm>
+            <a:off x="731520" y="411480"/>
+            <a:ext cx="5577840" cy="914400"/>
+          </a:xfrm>
+          <a:prstGeom prst="rect">
+            <a:avLst/>
+          </a:prstGeom>
+          <a:noFill/>
+        </p:spPr>
+        <p:txBody>
+          <a:bodyPr wrap="none">
+            <a:spAutoFit/>
+          </a:bodyPr>
+          <a:lstStyle/>
+          <a:p>
+            <a:r>
+              <a:rPr b="1" sz="3000">
+                <a:solidFill>
+                  <a:srgbClr val="102B52"/>
+                </a:solidFill>
+                <a:latin typeface="Segoe UI"/>
+              </a:rPr>
+              <a:t>Project Roadmap &amp; Evaluation Notes</a:t>
+            </a:r>
+          </a:p>
+        </p:txBody>
+      </p:sp>
+      <p:sp>
+        <p:nvSpPr>
+          <p:cNvPr id="7" name="Rounded Rectangle 6"/>
+          <p:cNvSpPr/>
+          <p:nvPr/>
+        </p:nvSpPr>
+        <p:spPr>
+          <a:xfrm>
+            <a:off x="640080" y="1645920"/>
+            <a:ext cx="5303520" cy="914400"/>
+          </a:xfrm>
+          <a:prstGeom prst="roundRect">
+            <a:avLst/>
+          </a:prstGeom>
+          <a:solidFill>
+            <a:srgbClr val="FFFFFF"/>
+          </a:solidFill>
+          <a:ln w="15240">
+            <a:solidFill>
+              <a:srgbClr val="CBD6E5"/>
+            </a:solidFill>
+          </a:ln>
+        </p:spPr>
+        <p:style>
+          <a:lnRef idx="1">
+            <a:schemeClr val="accent1"/>
+          </a:lnRef>
+          <a:fillRef idx="3">
+            <a:schemeClr val="accent1"/>
+          </a:fillRef>
+          <a:effectRef idx="2">
+            <a:schemeClr val="accent1"/>
+          </a:effectRef>
+          <a:fontRef idx="minor">
+            <a:schemeClr val="lt1"/>
+          </a:fontRef>
+        </p:style>
+        <p:txBody>
+          <a:bodyPr rtlCol="0" anchor="ctr"/>
+          <a:lstStyle/>
+          <a:p>
+            <a:pPr algn="ctr"/>
+          </a:p>
+        </p:txBody>
+      </p:sp>
+      <p:sp>
+        <p:nvSpPr>
+          <p:cNvPr id="8" name="TextBox 7"/>
+          <p:cNvSpPr txBox="1"/>
+          <p:nvPr/>
+        </p:nvSpPr>
+        <p:spPr>
+          <a:xfrm>
+            <a:off x="868680" y="1783080"/>
+            <a:ext cx="4937760" cy="731520"/>
+          </a:xfrm>
+          <a:prstGeom prst="rect">
+            <a:avLst/>
+          </a:prstGeom>
+          <a:noFill/>
+        </p:spPr>
+        <p:txBody>
+          <a:bodyPr wrap="none">
+            <a:spAutoFit/>
+          </a:bodyPr>
+          <a:lstStyle/>
+          <a:p>
+            <a:r>
+              <a:rPr sz="3600" b="1">
+                <a:solidFill>
+                  <a:srgbClr val="2D3848"/>
+                </a:solidFill>
+                <a:latin typeface="Segoe UI"/>
+              </a:rPr>
+              <a:t>$15</a:t>
+            </a:r>
+          </a:p>
+        </p:txBody>
+      </p:sp>
+      <p:sp>
+        <p:nvSpPr>
+          <p:cNvPr id="9" name="TextBox 8"/>
+          <p:cNvSpPr txBox="1"/>
+          <p:nvPr/>
+        </p:nvSpPr>
+        <p:spPr>
+          <a:xfrm>
+            <a:off x="868680" y="2148840"/>
+            <a:ext cx="4937760" cy="548640"/>
+          </a:xfrm>
+          <a:prstGeom prst="rect">
+            <a:avLst/>
+          </a:prstGeom>
+          <a:noFill/>
+        </p:spPr>
+        <p:txBody>
+          <a:bodyPr wrap="none">
+            <a:spAutoFit/>
+          </a:bodyPr>
+          <a:lstStyle/>
+          <a:p>
+            <a:r>
+              <a:rPr sz="1300">
+                <a:solidFill>
+                  <a:srgbClr val="2D3848"/>
+                </a:solidFill>
+                <a:latin typeface="Segoe UI"/>
+              </a:rPr>
+              <a:t>Monthly subscription per user</a:t>
+            </a:r>
+          </a:p>
+        </p:txBody>
+      </p:sp>
+      <p:sp>
+        <p:nvSpPr>
+          <p:cNvPr id="10" name="Rounded Rectangle 9"/>
+          <p:cNvSpPr/>
+          <p:nvPr/>
+        </p:nvSpPr>
+        <p:spPr>
+          <a:xfrm>
+            <a:off x="640080" y="2743200"/>
+            <a:ext cx="5303520" cy="914400"/>
+          </a:xfrm>
+          <a:prstGeom prst="roundRect">
+            <a:avLst/>
+          </a:prstGeom>
+          <a:solidFill>
+            <a:srgbClr val="FFFFFF"/>
+          </a:solidFill>
+          <a:ln w="15240">
+            <a:solidFill>
+              <a:srgbClr val="CBD6E5"/>
+            </a:solidFill>
+          </a:ln>
+        </p:spPr>
+        <p:style>
+          <a:lnRef idx="1">
+            <a:schemeClr val="accent1"/>
+          </a:lnRef>
+          <a:fillRef idx="3">
+            <a:schemeClr val="accent1"/>
+          </a:fillRef>
+          <a:effectRef idx="2">
+            <a:schemeClr val="accent1"/>
+          </a:effectRef>
+          <a:fontRef idx="minor">
+            <a:schemeClr val="lt1"/>
+          </a:fontRef>
+        </p:style>
+        <p:txBody>
+          <a:bodyPr rtlCol="0" anchor="ctr"/>
+          <a:lstStyle/>
+          <a:p>
+            <a:pPr algn="ctr"/>
+          </a:p>
+        </p:txBody>
+      </p:sp>
+      <p:sp>
+        <p:nvSpPr>
+          <p:cNvPr id="11" name="TextBox 10"/>
+          <p:cNvSpPr txBox="1"/>
+          <p:nvPr/>
+        </p:nvSpPr>
+        <p:spPr>
+          <a:xfrm>
+            <a:off x="868680" y="2880360"/>
+            <a:ext cx="4937760" cy="731520"/>
+          </a:xfrm>
+          <a:prstGeom prst="rect">
+            <a:avLst/>
+          </a:prstGeom>
+          <a:noFill/>
+        </p:spPr>
+        <p:txBody>
+          <a:bodyPr wrap="none">
+            <a:spAutoFit/>
+          </a:bodyPr>
+          <a:lstStyle/>
+          <a:p>
+            <a:r>
+              <a:rPr sz="3600" b="1">
+                <a:solidFill>
+                  <a:srgbClr val="2D3848"/>
+                </a:solidFill>
+                <a:latin typeface="Segoe UI"/>
+              </a:rPr>
+              <a:t>$150K MRR</a:t>
+            </a:r>
+          </a:p>
+        </p:txBody>
+      </p:sp>
+      <p:sp>
+        <p:nvSpPr>
+          <p:cNvPr id="12" name="TextBox 11"/>
+          <p:cNvSpPr txBox="1"/>
+          <p:nvPr/>
+        </p:nvSpPr>
+        <p:spPr>
+          <a:xfrm>
+            <a:off x="868680" y="3246120"/>
+            <a:ext cx="4937760" cy="548640"/>
+          </a:xfrm>
+          <a:prstGeom prst="rect">
+            <a:avLst/>
+          </a:prstGeom>
+          <a:noFill/>
+        </p:spPr>
+        <p:txBody>
+          <a:bodyPr wrap="none">
+            <a:spAutoFit/>
+          </a:bodyPr>
+          <a:lstStyle/>
+          <a:p>
+            <a:r>
+              <a:rPr sz="1300">
+                <a:solidFill>
+                  <a:srgbClr val="2D3848"/>
+                </a:solidFill>
+                <a:latin typeface="Segoe UI"/>
+              </a:rPr>
+              <a:t>10,000 subscribers × $15</a:t>
+            </a:r>
+          </a:p>
+        </p:txBody>
+      </p:sp>
+      <p:sp>
+        <p:nvSpPr>
+          <p:cNvPr id="13" name="Rounded Rectangle 12"/>
+          <p:cNvSpPr/>
+          <p:nvPr/>
+        </p:nvSpPr>
+        <p:spPr>
+          <a:xfrm>
+            <a:off x="640080" y="3840480"/>
+            <a:ext cx="5303520" cy="914400"/>
+          </a:xfrm>
+          <a:prstGeom prst="roundRect">
+            <a:avLst/>
+          </a:prstGeom>
+          <a:solidFill>
+            <a:srgbClr val="FFFFFF"/>
+          </a:solidFill>
+          <a:ln w="15240">
+            <a:solidFill>
+              <a:srgbClr val="CBD6E5"/>
+            </a:solidFill>
+          </a:ln>
+        </p:spPr>
+        <p:style>
+          <a:lnRef idx="1">
+            <a:schemeClr val="accent1"/>
+          </a:lnRef>
+          <a:fillRef idx="3">
+            <a:schemeClr val="accent1"/>
+          </a:fillRef>
+          <a:effectRef idx="2">
+            <a:schemeClr val="accent1"/>
+          </a:effectRef>
+          <a:fontRef idx="minor">
+            <a:schemeClr val="lt1"/>
+          </a:fontRef>
+        </p:style>
+        <p:txBody>
+          <a:bodyPr rtlCol="0" anchor="ctr"/>
+          <a:lstStyle/>
+          <a:p>
+            <a:pPr algn="ctr"/>
+          </a:p>
+        </p:txBody>
+      </p:sp>
+      <p:sp>
+        <p:nvSpPr>
+          <p:cNvPr id="14" name="TextBox 13"/>
+          <p:cNvSpPr txBox="1"/>
+          <p:nvPr/>
+        </p:nvSpPr>
+        <p:spPr>
+          <a:xfrm>
+            <a:off x="868680" y="3977639"/>
+            <a:ext cx="4937760" cy="731520"/>
+          </a:xfrm>
+          <a:prstGeom prst="rect">
+            <a:avLst/>
+          </a:prstGeom>
+          <a:noFill/>
+        </p:spPr>
+        <p:txBody>
+          <a:bodyPr wrap="none">
+            <a:spAutoFit/>
+          </a:bodyPr>
+          <a:lstStyle/>
+          <a:p>
+            <a:r>
+              <a:rPr sz="3600" b="1">
+                <a:solidFill>
+                  <a:srgbClr val="2D3848"/>
+                </a:solidFill>
+                <a:latin typeface="Segoe UI"/>
+              </a:rPr>
+              <a:t>~$40K</a:t>
+            </a:r>
+          </a:p>
+        </p:txBody>
+      </p:sp>
+      <p:sp>
+        <p:nvSpPr>
+          <p:cNvPr id="15" name="TextBox 14"/>
+          <p:cNvSpPr txBox="1"/>
+          <p:nvPr/>
+        </p:nvSpPr>
+        <p:spPr>
+          <a:xfrm>
+            <a:off x="868680" y="4343400"/>
+            <a:ext cx="4937760" cy="548640"/>
+          </a:xfrm>
+          <a:prstGeom prst="rect">
+            <a:avLst/>
+          </a:prstGeom>
+          <a:noFill/>
+        </p:spPr>
+        <p:txBody>
+          <a:bodyPr wrap="none">
+            <a:spAutoFit/>
+          </a:bodyPr>
+          <a:lstStyle/>
+          <a:p>
+            <a:r>
+              <a:rPr sz="1300">
+                <a:solidFill>
+                  <a:srgbClr val="2D3848"/>
+                </a:solidFill>
+                <a:latin typeface="Segoe UI"/>
+              </a:rPr>
+              <a:t>Estimated monthly cloud + ops cost</a:t>
+            </a:r>
+          </a:p>
+        </p:txBody>
+      </p:sp>
+      <p:sp>
+        <p:nvSpPr>
+          <p:cNvPr id="16" name="TextBox 15"/>
+          <p:cNvSpPr txBox="1"/>
+          <p:nvPr/>
+        </p:nvSpPr>
+        <p:spPr>
+          <a:xfrm>
+            <a:off x="640080" y="4983480"/>
+            <a:ext cx="5303520" cy="822960"/>
+          </a:xfrm>
+          <a:prstGeom prst="rect">
+            <a:avLst/>
+          </a:prstGeom>
+          <a:noFill/>
+        </p:spPr>
+        <p:txBody>
+          <a:bodyPr wrap="none">
+            <a:spAutoFit/>
+          </a:bodyPr>
+          <a:lstStyle/>
+          <a:p>
+            <a:r>
+              <a:rPr sz="1600">
+                <a:solidFill>
+                  <a:srgbClr val="2D3848"/>
+                </a:solidFill>
+                <a:latin typeface="Segoe UI"/>
+              </a:rPr>
+              <a:t>Compared with ~$600 for a typical 2-hour legal consultation, RonyGuard targets affordability and recurring revenue.</a:t>
+            </a:r>
+          </a:p>
+        </p:txBody>
+      </p:sp>
+      <p:sp>
+        <p:nvSpPr>
+          <p:cNvPr id="17" name="TextBox 16"/>
+          <p:cNvSpPr txBox="1"/>
+          <p:nvPr/>
+        </p:nvSpPr>
+        <p:spPr>
+          <a:xfrm>
+            <a:off x="640080" y="5394960"/>
+            <a:ext cx="5303520" cy="365760"/>
+          </a:xfrm>
+          <a:prstGeom prst="rect">
+            <a:avLst/>
+          </a:prstGeom>
+          <a:noFill/>
+        </p:spPr>
+        <p:txBody>
+          <a:bodyPr wrap="none">
+            <a:spAutoFit/>
+          </a:bodyPr>
+          <a:lstStyle/>
+          <a:p>
+            <a:r>
+              <a:rPr sz="1600">
+                <a:solidFill>
+                  <a:srgbClr val="2D3848"/>
+                </a:solidFill>
+                <a:latin typeface="Segoe UI"/>
+              </a:rPr>
+              <a:t>Roadmap to scale</a:t>
+            </a:r>
+          </a:p>
+        </p:txBody>
+      </p:sp>
+      <p:sp>
+        <p:nvSpPr>
+          <p:cNvPr id="18" name="Rectangle 17"/>
+          <p:cNvSpPr/>
+          <p:nvPr/>
+        </p:nvSpPr>
+        <p:spPr>
+          <a:xfrm>
+            <a:off x="1005840" y="5532120"/>
+            <a:ext cx="4389120" cy="45720"/>
+          </a:xfrm>
+          <a:prstGeom prst="rect">
+            <a:avLst/>
+          </a:prstGeom>
+          <a:solidFill>
+            <a:srgbClr val="46629E"/>
+          </a:solidFill>
+          <a:ln>
+            <a:noFill/>
+          </a:ln>
+        </p:spPr>
+        <p:style>
+          <a:lnRef idx="1">
+            <a:schemeClr val="accent1"/>
+          </a:lnRef>
+          <a:fillRef idx="3">
+            <a:schemeClr val="accent1"/>
+          </a:fillRef>
+          <a:effectRef idx="2">
+            <a:schemeClr val="accent1"/>
+          </a:effectRef>
+          <a:fontRef idx="minor">
+            <a:schemeClr val="lt1"/>
+          </a:fontRef>
+        </p:style>
+        <p:txBody>
+          <a:bodyPr rtlCol="0" anchor="ctr"/>
+          <a:lstStyle/>
+          <a:p>
+            <a:pPr algn="ctr"/>
+          </a:p>
+        </p:txBody>
+      </p:sp>
+      <p:sp>
+        <p:nvSpPr>
+          <p:cNvPr id="19" name="Oval 18"/>
+          <p:cNvSpPr/>
+          <p:nvPr/>
+        </p:nvSpPr>
+        <p:spPr>
+          <a:xfrm>
+            <a:off x="1097280" y="5413248"/>
+            <a:ext cx="292608" cy="292608"/>
           </a:xfrm>
           <a:prstGeom prst="ellipse">
             <a:avLst/>
@@ -8357,100 +9157,14 @@
       </p:sp>
       <p:sp>
         <p:nvSpPr>
-          <p:cNvPr id="4" name="Oval 3"/>
-          <p:cNvSpPr/>
-          <p:nvPr/>
-        </p:nvSpPr>
-        <p:spPr>
-          <a:xfrm>
-            <a:off x="7589520" y="1920240"/>
-            <a:ext cx="5029200" cy="5029200"/>
-          </a:xfrm>
-          <a:prstGeom prst="ellipse">
-            <a:avLst/>
-          </a:prstGeom>
-          <a:solidFill>
-            <a:srgbClr val="00D6C9"/>
-          </a:solidFill>
-          <a:ln>
-            <a:noFill/>
-          </a:ln>
-        </p:spPr>
-        <p:style>
-          <a:lnRef idx="1">
-            <a:schemeClr val="accent1"/>
-          </a:lnRef>
-          <a:fillRef idx="3">
-            <a:schemeClr val="accent1"/>
-          </a:fillRef>
-          <a:effectRef idx="2">
-            <a:schemeClr val="accent1"/>
-          </a:effectRef>
-          <a:fontRef idx="minor">
-            <a:schemeClr val="lt1"/>
-          </a:fontRef>
-        </p:style>
-        <p:txBody>
-          <a:bodyPr rtlCol="0" anchor="ctr"/>
-          <a:lstStyle/>
-          <a:p>
-            <a:pPr algn="ctr"/>
-          </a:p>
-        </p:txBody>
-      </p:sp>
-      <p:sp>
-        <p:nvSpPr>
-          <p:cNvPr id="5" name="Rectangle 4"/>
-          <p:cNvSpPr/>
-          <p:nvPr/>
-        </p:nvSpPr>
-        <p:spPr>
-          <a:xfrm>
-            <a:off x="0" y="5394960"/>
-            <a:ext cx="12188952" cy="1463040"/>
-          </a:xfrm>
-          <a:prstGeom prst="rect">
-            <a:avLst/>
-          </a:prstGeom>
-          <a:solidFill>
-            <a:srgbClr val="111C35"/>
-          </a:solidFill>
-          <a:ln>
-            <a:noFill/>
-          </a:ln>
-        </p:spPr>
-        <p:style>
-          <a:lnRef idx="1">
-            <a:schemeClr val="accent1"/>
-          </a:lnRef>
-          <a:fillRef idx="3">
-            <a:schemeClr val="accent1"/>
-          </a:fillRef>
-          <a:effectRef idx="2">
-            <a:schemeClr val="accent1"/>
-          </a:effectRef>
-          <a:fontRef idx="minor">
-            <a:schemeClr val="lt1"/>
-          </a:fontRef>
-        </p:style>
-        <p:txBody>
-          <a:bodyPr rtlCol="0" anchor="ctr"/>
-          <a:lstStyle/>
-          <a:p>
-            <a:pPr algn="ctr"/>
-          </a:p>
-        </p:txBody>
-      </p:sp>
-      <p:sp>
-        <p:nvSpPr>
-          <p:cNvPr id="6" name="TextBox 5"/>
+          <p:cNvPr id="20" name="TextBox 19"/>
           <p:cNvSpPr txBox="1"/>
           <p:nvPr/>
         </p:nvSpPr>
         <p:spPr>
           <a:xfrm>
-            <a:off x="731520" y="411480"/>
-            <a:ext cx="7315200" cy="914400"/>
+            <a:off x="914400" y="5705856"/>
+            <a:ext cx="1097280" cy="274320"/>
           </a:xfrm>
           <a:prstGeom prst="rect">
             <a:avLst/>
@@ -8463,477 +9177,28 @@
           </a:bodyPr>
           <a:lstStyle/>
           <a:p>
-            <a:r>
-              <a:rPr sz="3400" b="1">
+            <a:pPr algn="ctr"/>
+            <a:r>
+              <a:rPr sz="1150">
                 <a:solidFill>
-                  <a:srgbClr val="2997FF"/>
+                  <a:srgbClr val="2D3848"/>
                 </a:solidFill>
-                <a:latin typeface="Poppins"/>
+                <a:latin typeface="Segoe UI"/>
               </a:rPr>
-              <a:t>Traction Model &amp; Unit Economics</a:t>
-            </a:r>
-          </a:p>
-        </p:txBody>
-      </p:sp>
-      <p:sp>
-        <p:nvSpPr>
-          <p:cNvPr id="7" name="Rounded Rectangle 6"/>
+              <a:t>MVP</a:t>
+            </a:r>
+          </a:p>
+        </p:txBody>
+      </p:sp>
+      <p:sp>
+        <p:nvSpPr>
+          <p:cNvPr id="21" name="Oval 20"/>
           <p:cNvSpPr/>
           <p:nvPr/>
         </p:nvSpPr>
         <p:spPr>
           <a:xfrm>
-            <a:off x="777240" y="1325880"/>
-            <a:ext cx="3566160" cy="1920240"/>
-          </a:xfrm>
-          <a:prstGeom prst="roundRect">
-            <a:avLst/>
-          </a:prstGeom>
-          <a:solidFill>
-            <a:srgbClr val="16213D"/>
-          </a:solidFill>
-          <a:ln w="15240">
-            <a:solidFill>
-              <a:srgbClr val="3A5184"/>
-            </a:solidFill>
-          </a:ln>
-        </p:spPr>
-        <p:style>
-          <a:lnRef idx="1">
-            <a:schemeClr val="accent1"/>
-          </a:lnRef>
-          <a:fillRef idx="3">
-            <a:schemeClr val="accent1"/>
-          </a:fillRef>
-          <a:effectRef idx="2">
-            <a:schemeClr val="accent1"/>
-          </a:effectRef>
-          <a:fontRef idx="minor">
-            <a:schemeClr val="lt1"/>
-          </a:fontRef>
-        </p:style>
-        <p:txBody>
-          <a:bodyPr rtlCol="0" anchor="ctr"/>
-          <a:lstStyle/>
-          <a:p>
-            <a:pPr algn="ctr"/>
-          </a:p>
-        </p:txBody>
-      </p:sp>
-      <p:sp>
-        <p:nvSpPr>
-          <p:cNvPr id="8" name="TextBox 7"/>
-          <p:cNvSpPr txBox="1"/>
-          <p:nvPr/>
-        </p:nvSpPr>
-        <p:spPr>
-          <a:xfrm>
-            <a:off x="1005840" y="1600200"/>
-            <a:ext cx="3108960" cy="731520"/>
-          </a:xfrm>
-          <a:prstGeom prst="rect">
-            <a:avLst/>
-          </a:prstGeom>
-          <a:noFill/>
-        </p:spPr>
-        <p:txBody>
-          <a:bodyPr wrap="none">
-            <a:spAutoFit/>
-          </a:bodyPr>
-          <a:lstStyle/>
-          <a:p>
-            <a:r>
-              <a:rPr sz="3600" b="1">
-                <a:solidFill>
-                  <a:srgbClr val="2997FF"/>
-                </a:solidFill>
-                <a:latin typeface="Poppins"/>
-              </a:rPr>
-              <a:t>$15</a:t>
-            </a:r>
-          </a:p>
-        </p:txBody>
-      </p:sp>
-      <p:sp>
-        <p:nvSpPr>
-          <p:cNvPr id="9" name="TextBox 8"/>
-          <p:cNvSpPr txBox="1"/>
-          <p:nvPr/>
-        </p:nvSpPr>
-        <p:spPr>
-          <a:xfrm>
-            <a:off x="1005840" y="2331720"/>
-            <a:ext cx="3108960" cy="548640"/>
-          </a:xfrm>
-          <a:prstGeom prst="rect">
-            <a:avLst/>
-          </a:prstGeom>
-          <a:noFill/>
-        </p:spPr>
-        <p:txBody>
-          <a:bodyPr wrap="none">
-            <a:spAutoFit/>
-          </a:bodyPr>
-          <a:lstStyle/>
-          <a:p>
-            <a:r>
-              <a:rPr sz="1300">
-                <a:solidFill>
-                  <a:srgbClr val="A6B4D1"/>
-                </a:solidFill>
-                <a:latin typeface="Inter"/>
-              </a:rPr>
-              <a:t>Monthly subscription per user</a:t>
-            </a:r>
-          </a:p>
-        </p:txBody>
-      </p:sp>
-      <p:sp>
-        <p:nvSpPr>
-          <p:cNvPr id="10" name="Rounded Rectangle 9"/>
-          <p:cNvSpPr/>
-          <p:nvPr/>
-        </p:nvSpPr>
-        <p:spPr>
-          <a:xfrm>
-            <a:off x="4617720" y="1325880"/>
-            <a:ext cx="3566160" cy="1920240"/>
-          </a:xfrm>
-          <a:prstGeom prst="roundRect">
-            <a:avLst/>
-          </a:prstGeom>
-          <a:solidFill>
-            <a:srgbClr val="16213D"/>
-          </a:solidFill>
-          <a:ln w="15240">
-            <a:solidFill>
-              <a:srgbClr val="3A5184"/>
-            </a:solidFill>
-          </a:ln>
-        </p:spPr>
-        <p:style>
-          <a:lnRef idx="1">
-            <a:schemeClr val="accent1"/>
-          </a:lnRef>
-          <a:fillRef idx="3">
-            <a:schemeClr val="accent1"/>
-          </a:fillRef>
-          <a:effectRef idx="2">
-            <a:schemeClr val="accent1"/>
-          </a:effectRef>
-          <a:fontRef idx="minor">
-            <a:schemeClr val="lt1"/>
-          </a:fontRef>
-        </p:style>
-        <p:txBody>
-          <a:bodyPr rtlCol="0" anchor="ctr"/>
-          <a:lstStyle/>
-          <a:p>
-            <a:pPr algn="ctr"/>
-          </a:p>
-        </p:txBody>
-      </p:sp>
-      <p:sp>
-        <p:nvSpPr>
-          <p:cNvPr id="11" name="TextBox 10"/>
-          <p:cNvSpPr txBox="1"/>
-          <p:nvPr/>
-        </p:nvSpPr>
-        <p:spPr>
-          <a:xfrm>
-            <a:off x="4846320" y="1600200"/>
-            <a:ext cx="3108960" cy="731520"/>
-          </a:xfrm>
-          <a:prstGeom prst="rect">
-            <a:avLst/>
-          </a:prstGeom>
-          <a:noFill/>
-        </p:spPr>
-        <p:txBody>
-          <a:bodyPr wrap="none">
-            <a:spAutoFit/>
-          </a:bodyPr>
-          <a:lstStyle/>
-          <a:p>
-            <a:r>
-              <a:rPr sz="3600" b="1">
-                <a:solidFill>
-                  <a:srgbClr val="2997FF"/>
-                </a:solidFill>
-                <a:latin typeface="Poppins"/>
-              </a:rPr>
-              <a:t>$150K MRR</a:t>
-            </a:r>
-          </a:p>
-        </p:txBody>
-      </p:sp>
-      <p:sp>
-        <p:nvSpPr>
-          <p:cNvPr id="12" name="TextBox 11"/>
-          <p:cNvSpPr txBox="1"/>
-          <p:nvPr/>
-        </p:nvSpPr>
-        <p:spPr>
-          <a:xfrm>
-            <a:off x="4846320" y="2331720"/>
-            <a:ext cx="3108960" cy="548640"/>
-          </a:xfrm>
-          <a:prstGeom prst="rect">
-            <a:avLst/>
-          </a:prstGeom>
-          <a:noFill/>
-        </p:spPr>
-        <p:txBody>
-          <a:bodyPr wrap="none">
-            <a:spAutoFit/>
-          </a:bodyPr>
-          <a:lstStyle/>
-          <a:p>
-            <a:r>
-              <a:rPr sz="1300">
-                <a:solidFill>
-                  <a:srgbClr val="A6B4D1"/>
-                </a:solidFill>
-                <a:latin typeface="Inter"/>
-              </a:rPr>
-              <a:t>10,000 subscribers × $15</a:t>
-            </a:r>
-          </a:p>
-        </p:txBody>
-      </p:sp>
-      <p:sp>
-        <p:nvSpPr>
-          <p:cNvPr id="13" name="Rounded Rectangle 12"/>
-          <p:cNvSpPr/>
-          <p:nvPr/>
-        </p:nvSpPr>
-        <p:spPr>
-          <a:xfrm>
-            <a:off x="8458200" y="1325880"/>
-            <a:ext cx="3566160" cy="1920240"/>
-          </a:xfrm>
-          <a:prstGeom prst="roundRect">
-            <a:avLst/>
-          </a:prstGeom>
-          <a:solidFill>
-            <a:srgbClr val="16213D"/>
-          </a:solidFill>
-          <a:ln w="15240">
-            <a:solidFill>
-              <a:srgbClr val="3A5184"/>
-            </a:solidFill>
-          </a:ln>
-        </p:spPr>
-        <p:style>
-          <a:lnRef idx="1">
-            <a:schemeClr val="accent1"/>
-          </a:lnRef>
-          <a:fillRef idx="3">
-            <a:schemeClr val="accent1"/>
-          </a:fillRef>
-          <a:effectRef idx="2">
-            <a:schemeClr val="accent1"/>
-          </a:effectRef>
-          <a:fontRef idx="minor">
-            <a:schemeClr val="lt1"/>
-          </a:fontRef>
-        </p:style>
-        <p:txBody>
-          <a:bodyPr rtlCol="0" anchor="ctr"/>
-          <a:lstStyle/>
-          <a:p>
-            <a:pPr algn="ctr"/>
-          </a:p>
-        </p:txBody>
-      </p:sp>
-      <p:sp>
-        <p:nvSpPr>
-          <p:cNvPr id="14" name="TextBox 13"/>
-          <p:cNvSpPr txBox="1"/>
-          <p:nvPr/>
-        </p:nvSpPr>
-        <p:spPr>
-          <a:xfrm>
-            <a:off x="8686800" y="1600200"/>
-            <a:ext cx="3108960" cy="731520"/>
-          </a:xfrm>
-          <a:prstGeom prst="rect">
-            <a:avLst/>
-          </a:prstGeom>
-          <a:noFill/>
-        </p:spPr>
-        <p:txBody>
-          <a:bodyPr wrap="none">
-            <a:spAutoFit/>
-          </a:bodyPr>
-          <a:lstStyle/>
-          <a:p>
-            <a:r>
-              <a:rPr sz="3600" b="1">
-                <a:solidFill>
-                  <a:srgbClr val="2997FF"/>
-                </a:solidFill>
-                <a:latin typeface="Poppins"/>
-              </a:rPr>
-              <a:t>~$40K</a:t>
-            </a:r>
-          </a:p>
-        </p:txBody>
-      </p:sp>
-      <p:sp>
-        <p:nvSpPr>
-          <p:cNvPr id="15" name="TextBox 14"/>
-          <p:cNvSpPr txBox="1"/>
-          <p:nvPr/>
-        </p:nvSpPr>
-        <p:spPr>
-          <a:xfrm>
-            <a:off x="8686800" y="2331720"/>
-            <a:ext cx="3108960" cy="548640"/>
-          </a:xfrm>
-          <a:prstGeom prst="rect">
-            <a:avLst/>
-          </a:prstGeom>
-          <a:noFill/>
-        </p:spPr>
-        <p:txBody>
-          <a:bodyPr wrap="none">
-            <a:spAutoFit/>
-          </a:bodyPr>
-          <a:lstStyle/>
-          <a:p>
-            <a:r>
-              <a:rPr sz="1300">
-                <a:solidFill>
-                  <a:srgbClr val="A6B4D1"/>
-                </a:solidFill>
-                <a:latin typeface="Inter"/>
-              </a:rPr>
-              <a:t>Estimated monthly cloud + ops cost</a:t>
-            </a:r>
-          </a:p>
-        </p:txBody>
-      </p:sp>
-      <p:sp>
-        <p:nvSpPr>
-          <p:cNvPr id="16" name="TextBox 15"/>
-          <p:cNvSpPr txBox="1"/>
-          <p:nvPr/>
-        </p:nvSpPr>
-        <p:spPr>
-          <a:xfrm>
-            <a:off x="822960" y="3566160"/>
-            <a:ext cx="10789920" cy="822960"/>
-          </a:xfrm>
-          <a:prstGeom prst="rect">
-            <a:avLst/>
-          </a:prstGeom>
-          <a:noFill/>
-        </p:spPr>
-        <p:txBody>
-          <a:bodyPr wrap="none">
-            <a:spAutoFit/>
-          </a:bodyPr>
-          <a:lstStyle/>
-          <a:p>
-            <a:r>
-              <a:rPr sz="1600">
-                <a:solidFill>
-                  <a:srgbClr val="E6EEFC"/>
-                </a:solidFill>
-                <a:latin typeface="Inter"/>
-              </a:rPr>
-              <a:t>Compared with ~$600 for a typical 2-hour legal consultation, RonyGuard targets affordability and recurring revenue.</a:t>
-            </a:r>
-          </a:p>
-        </p:txBody>
-      </p:sp>
-      <p:sp>
-        <p:nvSpPr>
-          <p:cNvPr id="17" name="TextBox 16"/>
-          <p:cNvSpPr txBox="1"/>
-          <p:nvPr/>
-        </p:nvSpPr>
-        <p:spPr>
-          <a:xfrm>
-            <a:off x="822960" y="4389120"/>
-            <a:ext cx="2286000" cy="365760"/>
-          </a:xfrm>
-          <a:prstGeom prst="rect">
-            <a:avLst/>
-          </a:prstGeom>
-          <a:noFill/>
-        </p:spPr>
-        <p:txBody>
-          <a:bodyPr wrap="none">
-            <a:spAutoFit/>
-          </a:bodyPr>
-          <a:lstStyle/>
-          <a:p>
-            <a:r>
-              <a:rPr sz="1600">
-                <a:solidFill>
-                  <a:srgbClr val="00D6C9"/>
-                </a:solidFill>
-                <a:latin typeface="Inter"/>
-              </a:rPr>
-              <a:t>Roadmap to scale</a:t>
-            </a:r>
-          </a:p>
-        </p:txBody>
-      </p:sp>
-      <p:sp>
-        <p:nvSpPr>
-          <p:cNvPr id="18" name="Rectangle 17"/>
-          <p:cNvSpPr/>
-          <p:nvPr/>
-        </p:nvSpPr>
-        <p:spPr>
-          <a:xfrm>
-            <a:off x="914400" y="4983480"/>
-            <a:ext cx="9875520" cy="45720"/>
-          </a:xfrm>
-          <a:prstGeom prst="rect">
-            <a:avLst/>
-          </a:prstGeom>
-          <a:solidFill>
-            <a:srgbClr val="46629E"/>
-          </a:solidFill>
-          <a:ln>
-            <a:noFill/>
-          </a:ln>
-        </p:spPr>
-        <p:style>
-          <a:lnRef idx="1">
-            <a:schemeClr val="accent1"/>
-          </a:lnRef>
-          <a:fillRef idx="3">
-            <a:schemeClr val="accent1"/>
-          </a:fillRef>
-          <a:effectRef idx="2">
-            <a:schemeClr val="accent1"/>
-          </a:effectRef>
-          <a:fontRef idx="minor">
-            <a:schemeClr val="lt1"/>
-          </a:fontRef>
-        </p:style>
-        <p:txBody>
-          <a:bodyPr rtlCol="0" anchor="ctr"/>
-          <a:lstStyle/>
-          <a:p>
-            <a:pPr algn="ctr"/>
-          </a:p>
-        </p:txBody>
-      </p:sp>
-      <p:sp>
-        <p:nvSpPr>
-          <p:cNvPr id="19" name="Oval 18"/>
-          <p:cNvSpPr/>
-          <p:nvPr/>
-        </p:nvSpPr>
-        <p:spPr>
-          <a:xfrm>
-            <a:off x="1097280" y="4846320"/>
+            <a:off x="2194560" y="5413248"/>
             <a:ext cx="292608" cy="292608"/>
           </a:xfrm>
           <a:prstGeom prst="ellipse">
@@ -8970,14 +9235,14 @@
       </p:sp>
       <p:sp>
         <p:nvSpPr>
-          <p:cNvPr id="20" name="TextBox 19"/>
+          <p:cNvPr id="22" name="TextBox 21"/>
           <p:cNvSpPr txBox="1"/>
           <p:nvPr/>
         </p:nvSpPr>
         <p:spPr>
           <a:xfrm>
-            <a:off x="777240" y="5193792"/>
-            <a:ext cx="1280160" cy="274320"/>
+            <a:off x="2011680" y="5705856"/>
+            <a:ext cx="1097280" cy="274320"/>
           </a:xfrm>
           <a:prstGeom prst="rect">
             <a:avLst/>
@@ -8994,24 +9259,24 @@
             <a:r>
               <a:rPr sz="1150">
                 <a:solidFill>
-                  <a:srgbClr val="A6B4D1"/>
+                  <a:srgbClr val="2D3848"/>
                 </a:solidFill>
-                <a:latin typeface="Inter"/>
+                <a:latin typeface="Segoe UI"/>
               </a:rPr>
-              <a:t>MVP</a:t>
-            </a:r>
-          </a:p>
-        </p:txBody>
-      </p:sp>
-      <p:sp>
-        <p:nvSpPr>
-          <p:cNvPr id="21" name="Oval 20"/>
+              <a:t>Pilot</a:t>
+            </a:r>
+          </a:p>
+        </p:txBody>
+      </p:sp>
+      <p:sp>
+        <p:nvSpPr>
+          <p:cNvPr id="23" name="Oval 22"/>
           <p:cNvSpPr/>
           <p:nvPr/>
         </p:nvSpPr>
         <p:spPr>
           <a:xfrm>
-            <a:off x="4114800" y="4846320"/>
+            <a:off x="3291840" y="5413248"/>
             <a:ext cx="292608" cy="292608"/>
           </a:xfrm>
           <a:prstGeom prst="ellipse">
@@ -9048,14 +9313,14 @@
       </p:sp>
       <p:sp>
         <p:nvSpPr>
-          <p:cNvPr id="22" name="TextBox 21"/>
+          <p:cNvPr id="24" name="TextBox 23"/>
           <p:cNvSpPr txBox="1"/>
           <p:nvPr/>
         </p:nvSpPr>
         <p:spPr>
           <a:xfrm>
-            <a:off x="3794760" y="5193792"/>
-            <a:ext cx="1280160" cy="274320"/>
+            <a:off x="3108960" y="5705856"/>
+            <a:ext cx="1097280" cy="274320"/>
           </a:xfrm>
           <a:prstGeom prst="rect">
             <a:avLst/>
@@ -9072,24 +9337,24 @@
             <a:r>
               <a:rPr sz="1150">
                 <a:solidFill>
-                  <a:srgbClr val="A6B4D1"/>
+                  <a:srgbClr val="2D3848"/>
                 </a:solidFill>
-                <a:latin typeface="Inter"/>
+                <a:latin typeface="Segoe UI"/>
               </a:rPr>
-              <a:t>Pilot</a:t>
-            </a:r>
-          </a:p>
-        </p:txBody>
-      </p:sp>
-      <p:sp>
-        <p:nvSpPr>
-          <p:cNvPr id="23" name="Oval 22"/>
+              <a:t>Regional Launch</a:t>
+            </a:r>
+          </a:p>
+        </p:txBody>
+      </p:sp>
+      <p:sp>
+        <p:nvSpPr>
+          <p:cNvPr id="25" name="Oval 24"/>
           <p:cNvSpPr/>
           <p:nvPr/>
         </p:nvSpPr>
         <p:spPr>
           <a:xfrm>
-            <a:off x="7132320" y="4846320"/>
+            <a:off x="4389120" y="5413248"/>
             <a:ext cx="292608" cy="292608"/>
           </a:xfrm>
           <a:prstGeom prst="ellipse">
@@ -9126,14 +9391,14 @@
       </p:sp>
       <p:sp>
         <p:nvSpPr>
-          <p:cNvPr id="24" name="TextBox 23"/>
+          <p:cNvPr id="26" name="TextBox 25"/>
           <p:cNvSpPr txBox="1"/>
           <p:nvPr/>
         </p:nvSpPr>
         <p:spPr>
           <a:xfrm>
-            <a:off x="6812280" y="5193792"/>
-            <a:ext cx="1280160" cy="274320"/>
+            <a:off x="4206240" y="5705856"/>
+            <a:ext cx="1097280" cy="274320"/>
           </a:xfrm>
           <a:prstGeom prst="rect">
             <a:avLst/>
@@ -9150,93 +9415,39 @@
             <a:r>
               <a:rPr sz="1150">
                 <a:solidFill>
-                  <a:srgbClr val="A6B4D1"/>
+                  <a:srgbClr val="2D3848"/>
                 </a:solidFill>
-                <a:latin typeface="Inter"/>
-              </a:rPr>
-              <a:t>Regional Launch</a:t>
-            </a:r>
-          </a:p>
-        </p:txBody>
-      </p:sp>
-      <p:sp>
-        <p:nvSpPr>
-          <p:cNvPr id="25" name="Oval 24"/>
-          <p:cNvSpPr/>
-          <p:nvPr/>
-        </p:nvSpPr>
-        <p:spPr>
-          <a:xfrm>
-            <a:off x="10149839" y="4846320"/>
-            <a:ext cx="292608" cy="292608"/>
-          </a:xfrm>
-          <a:prstGeom prst="ellipse">
-            <a:avLst/>
-          </a:prstGeom>
-          <a:solidFill>
-            <a:srgbClr val="2997FF"/>
-          </a:solidFill>
-          <a:ln>
-            <a:noFill/>
-          </a:ln>
-        </p:spPr>
-        <p:style>
-          <a:lnRef idx="1">
-            <a:schemeClr val="accent1"/>
-          </a:lnRef>
-          <a:fillRef idx="3">
-            <a:schemeClr val="accent1"/>
-          </a:fillRef>
-          <a:effectRef idx="2">
-            <a:schemeClr val="accent1"/>
-          </a:effectRef>
-          <a:fontRef idx="minor">
-            <a:schemeClr val="lt1"/>
-          </a:fontRef>
-        </p:style>
-        <p:txBody>
-          <a:bodyPr rtlCol="0" anchor="ctr"/>
-          <a:lstStyle/>
-          <a:p>
-            <a:pPr algn="ctr"/>
-          </a:p>
-        </p:txBody>
-      </p:sp>
-      <p:sp>
-        <p:nvSpPr>
-          <p:cNvPr id="26" name="TextBox 25"/>
-          <p:cNvSpPr txBox="1"/>
-          <p:nvPr/>
-        </p:nvSpPr>
-        <p:spPr>
-          <a:xfrm>
-            <a:off x="9829799" y="5193792"/>
-            <a:ext cx="1280160" cy="274320"/>
-          </a:xfrm>
-          <a:prstGeom prst="rect">
-            <a:avLst/>
-          </a:prstGeom>
-          <a:noFill/>
-        </p:spPr>
-        <p:txBody>
-          <a:bodyPr wrap="none">
-            <a:spAutoFit/>
-          </a:bodyPr>
-          <a:lstStyle/>
-          <a:p>
-            <a:pPr algn="ctr"/>
-            <a:r>
-              <a:rPr sz="1150">
-                <a:solidFill>
-                  <a:srgbClr val="A6B4D1"/>
-                </a:solidFill>
-                <a:latin typeface="Inter"/>
+                <a:latin typeface="Segoe UI"/>
               </a:rPr>
               <a:t>Multi-jurisdiction</a:t>
             </a:r>
           </a:p>
         </p:txBody>
       </p:sp>
+      <p:pic>
+        <p:nvPicPr>
+          <p:cNvPr id="27" name="Picture 26" descr="success_rocket.png"/>
+          <p:cNvPicPr>
+            <a:picLocks noChangeAspect="1"/>
+          </p:cNvPicPr>
+          <p:nvPr/>
+        </p:nvPicPr>
+        <p:blipFill>
+          <a:blip r:embed="rId4"/>
+          <a:stretch>
+            <a:fillRect/>
+          </a:stretch>
+        </p:blipFill>
+        <p:spPr>
+          <a:xfrm>
+            <a:off x="6400800" y="1554480"/>
+            <a:ext cx="3840480" cy="4389120"/>
+          </a:xfrm>
+          <a:prstGeom prst="rect">
+            <a:avLst/>
+          </a:prstGeom>
+        </p:spPr>
+      </p:pic>
     </p:spTree>
   </p:cSld>
   <p:clrMapOvr>
@@ -9278,7 +9489,7 @@
             <a:avLst/>
           </a:prstGeom>
           <a:solidFill>
-            <a:srgbClr val="070D1C"/>
+            <a:srgbClr val="F6F8FB"/>
           </a:solidFill>
           <a:ln>
             <a:noFill/>
@@ -9318,6 +9529,203 @@
             <a:ext cx="5029200" cy="5029200"/>
           </a:xfrm>
           <a:prstGeom prst="ellipse">
+            <a:avLst/>
+          </a:prstGeom>
+          <a:solidFill>
+            <a:srgbClr val="DDE4EE"/>
+          </a:solidFill>
+          <a:ln>
+            <a:noFill/>
+          </a:ln>
+        </p:spPr>
+        <p:style>
+          <a:lnRef idx="1">
+            <a:schemeClr val="accent1"/>
+          </a:lnRef>
+          <a:fillRef idx="3">
+            <a:schemeClr val="accent1"/>
+          </a:fillRef>
+          <a:effectRef idx="2">
+            <a:schemeClr val="accent1"/>
+          </a:effectRef>
+          <a:fontRef idx="minor">
+            <a:schemeClr val="lt1"/>
+          </a:fontRef>
+        </p:style>
+        <p:txBody>
+          <a:bodyPr rtlCol="0" anchor="ctr"/>
+          <a:lstStyle/>
+          <a:p>
+            <a:pPr algn="ctr"/>
+          </a:p>
+        </p:txBody>
+      </p:sp>
+      <p:sp>
+        <p:nvSpPr>
+          <p:cNvPr id="4" name="Oval 3"/>
+          <p:cNvSpPr/>
+          <p:nvPr/>
+        </p:nvSpPr>
+        <p:spPr>
+          <a:xfrm>
+            <a:off x="7589520" y="1920240"/>
+            <a:ext cx="5029200" cy="5029200"/>
+          </a:xfrm>
+          <a:prstGeom prst="ellipse">
+            <a:avLst/>
+          </a:prstGeom>
+          <a:solidFill>
+            <a:srgbClr val="DFE6F0"/>
+          </a:solidFill>
+          <a:ln>
+            <a:noFill/>
+          </a:ln>
+        </p:spPr>
+        <p:style>
+          <a:lnRef idx="1">
+            <a:schemeClr val="accent1"/>
+          </a:lnRef>
+          <a:fillRef idx="3">
+            <a:schemeClr val="accent1"/>
+          </a:fillRef>
+          <a:effectRef idx="2">
+            <a:schemeClr val="accent1"/>
+          </a:effectRef>
+          <a:fontRef idx="minor">
+            <a:schemeClr val="lt1"/>
+          </a:fontRef>
+        </p:style>
+        <p:txBody>
+          <a:bodyPr rtlCol="0" anchor="ctr"/>
+          <a:lstStyle/>
+          <a:p>
+            <a:pPr algn="ctr"/>
+          </a:p>
+        </p:txBody>
+      </p:sp>
+      <p:sp>
+        <p:nvSpPr>
+          <p:cNvPr id="5" name="Rectangle 4"/>
+          <p:cNvSpPr/>
+          <p:nvPr/>
+        </p:nvSpPr>
+        <p:spPr>
+          <a:xfrm>
+            <a:off x="0" y="5394960"/>
+            <a:ext cx="12188952" cy="1463040"/>
+          </a:xfrm>
+          <a:prstGeom prst="rect">
+            <a:avLst/>
+          </a:prstGeom>
+          <a:solidFill>
+            <a:srgbClr val="E7ECF4"/>
+          </a:solidFill>
+          <a:ln>
+            <a:noFill/>
+          </a:ln>
+        </p:spPr>
+        <p:style>
+          <a:lnRef idx="1">
+            <a:schemeClr val="accent1"/>
+          </a:lnRef>
+          <a:fillRef idx="3">
+            <a:schemeClr val="accent1"/>
+          </a:fillRef>
+          <a:effectRef idx="2">
+            <a:schemeClr val="accent1"/>
+          </a:effectRef>
+          <a:fontRef idx="minor">
+            <a:schemeClr val="lt1"/>
+          </a:fontRef>
+        </p:style>
+        <p:txBody>
+          <a:bodyPr rtlCol="0" anchor="ctr"/>
+          <a:lstStyle/>
+          <a:p>
+            <a:pPr algn="ctr"/>
+          </a:p>
+        </p:txBody>
+      </p:sp>
+      <p:sp>
+        <p:nvSpPr>
+          <p:cNvPr id="6" name="TextBox 5"/>
+          <p:cNvSpPr txBox="1"/>
+          <p:nvPr/>
+        </p:nvSpPr>
+        <p:spPr>
+          <a:xfrm>
+            <a:off x="1005840" y="1188720"/>
+            <a:ext cx="9601200" cy="1097280"/>
+          </a:xfrm>
+          <a:prstGeom prst="rect">
+            <a:avLst/>
+          </a:prstGeom>
+          <a:noFill/>
+        </p:spPr>
+        <p:txBody>
+          <a:bodyPr wrap="none">
+            <a:spAutoFit/>
+          </a:bodyPr>
+          <a:lstStyle/>
+          <a:p>
+            <a:r>
+              <a:rPr sz="4800" b="1">
+                <a:solidFill>
+                  <a:srgbClr val="102B52"/>
+                </a:solidFill>
+                <a:latin typeface="Segoe UI"/>
+              </a:rPr>
+              <a:t>Close the Justice Gap, at Scale.</a:t>
+            </a:r>
+          </a:p>
+        </p:txBody>
+      </p:sp>
+      <p:sp>
+        <p:nvSpPr>
+          <p:cNvPr id="7" name="TextBox 6"/>
+          <p:cNvSpPr txBox="1"/>
+          <p:nvPr/>
+        </p:nvSpPr>
+        <p:spPr>
+          <a:xfrm>
+            <a:off x="1005840" y="2331720"/>
+            <a:ext cx="9692640" cy="914400"/>
+          </a:xfrm>
+          <a:prstGeom prst="rect">
+            <a:avLst/>
+          </a:prstGeom>
+          <a:noFill/>
+        </p:spPr>
+        <p:txBody>
+          <a:bodyPr wrap="none">
+            <a:spAutoFit/>
+          </a:bodyPr>
+          <a:lstStyle/>
+          <a:p>
+            <a:r>
+              <a:rPr sz="2200">
+                <a:solidFill>
+                  <a:srgbClr val="2D3848"/>
+                </a:solidFill>
+                <a:latin typeface="Segoe UI"/>
+              </a:rPr>
+              <a:t>RonyGuard combines AI + modern MIS to deliver accessible legal-rights support when people need it most.</a:t>
+            </a:r>
+          </a:p>
+        </p:txBody>
+      </p:sp>
+      <p:sp>
+        <p:nvSpPr>
+          <p:cNvPr id="8" name="Rounded Rectangle 7"/>
+          <p:cNvSpPr/>
+          <p:nvPr/>
+        </p:nvSpPr>
+        <p:spPr>
+          <a:xfrm>
+            <a:off x="1005840" y="3794760"/>
+            <a:ext cx="2834640" cy="822960"/>
+          </a:xfrm>
+          <a:prstGeom prst="roundRect">
             <a:avLst/>
           </a:prstGeom>
           <a:solidFill>
@@ -9351,100 +9759,14 @@
       </p:sp>
       <p:sp>
         <p:nvSpPr>
-          <p:cNvPr id="4" name="Oval 3"/>
-          <p:cNvSpPr/>
-          <p:nvPr/>
-        </p:nvSpPr>
-        <p:spPr>
-          <a:xfrm>
-            <a:off x="7589520" y="1920240"/>
-            <a:ext cx="5029200" cy="5029200"/>
-          </a:xfrm>
-          <a:prstGeom prst="ellipse">
-            <a:avLst/>
-          </a:prstGeom>
-          <a:solidFill>
-            <a:srgbClr val="00D6C9"/>
-          </a:solidFill>
-          <a:ln>
-            <a:noFill/>
-          </a:ln>
-        </p:spPr>
-        <p:style>
-          <a:lnRef idx="1">
-            <a:schemeClr val="accent1"/>
-          </a:lnRef>
-          <a:fillRef idx="3">
-            <a:schemeClr val="accent1"/>
-          </a:fillRef>
-          <a:effectRef idx="2">
-            <a:schemeClr val="accent1"/>
-          </a:effectRef>
-          <a:fontRef idx="minor">
-            <a:schemeClr val="lt1"/>
-          </a:fontRef>
-        </p:style>
-        <p:txBody>
-          <a:bodyPr rtlCol="0" anchor="ctr"/>
-          <a:lstStyle/>
-          <a:p>
-            <a:pPr algn="ctr"/>
-          </a:p>
-        </p:txBody>
-      </p:sp>
-      <p:sp>
-        <p:nvSpPr>
-          <p:cNvPr id="5" name="Rectangle 4"/>
-          <p:cNvSpPr/>
-          <p:nvPr/>
-        </p:nvSpPr>
-        <p:spPr>
-          <a:xfrm>
-            <a:off x="0" y="5394960"/>
-            <a:ext cx="12188952" cy="1463040"/>
-          </a:xfrm>
-          <a:prstGeom prst="rect">
-            <a:avLst/>
-          </a:prstGeom>
-          <a:solidFill>
-            <a:srgbClr val="111C35"/>
-          </a:solidFill>
-          <a:ln>
-            <a:noFill/>
-          </a:ln>
-        </p:spPr>
-        <p:style>
-          <a:lnRef idx="1">
-            <a:schemeClr val="accent1"/>
-          </a:lnRef>
-          <a:fillRef idx="3">
-            <a:schemeClr val="accent1"/>
-          </a:fillRef>
-          <a:effectRef idx="2">
-            <a:schemeClr val="accent1"/>
-          </a:effectRef>
-          <a:fontRef idx="minor">
-            <a:schemeClr val="lt1"/>
-          </a:fontRef>
-        </p:style>
-        <p:txBody>
-          <a:bodyPr rtlCol="0" anchor="ctr"/>
-          <a:lstStyle/>
-          <a:p>
-            <a:pPr algn="ctr"/>
-          </a:p>
-        </p:txBody>
-      </p:sp>
-      <p:sp>
-        <p:nvSpPr>
-          <p:cNvPr id="6" name="TextBox 5"/>
+          <p:cNvPr id="9" name="TextBox 8"/>
           <p:cNvSpPr txBox="1"/>
           <p:nvPr/>
         </p:nvSpPr>
         <p:spPr>
           <a:xfrm>
-            <a:off x="1005840" y="1188720"/>
-            <a:ext cx="9601200" cy="1097280"/>
+            <a:off x="1005840" y="3986784"/>
+            <a:ext cx="2834640" cy="457200"/>
           </a:xfrm>
           <a:prstGeom prst="rect">
             <a:avLst/>
@@ -9457,28 +9779,29 @@
           </a:bodyPr>
           <a:lstStyle/>
           <a:p>
-            <a:r>
-              <a:rPr sz="4800" b="1">
+            <a:pPr algn="ctr"/>
+            <a:r>
+              <a:rPr b="1" sz="1800">
                 <a:solidFill>
-                  <a:srgbClr val="2997FF"/>
+                  <a:srgbClr val="2D3848"/>
                 </a:solidFill>
-                <a:latin typeface="Poppins"/>
+                <a:latin typeface="Segoe UI"/>
               </a:rPr>
-              <a:t>Close the Justice Gap, at Scale.</a:t>
-            </a:r>
-          </a:p>
-        </p:txBody>
-      </p:sp>
-      <p:sp>
-        <p:nvSpPr>
-          <p:cNvPr id="7" name="TextBox 6"/>
+              <a:t>Request a Demo</a:t>
+            </a:r>
+          </a:p>
+        </p:txBody>
+      </p:sp>
+      <p:sp>
+        <p:nvSpPr>
+          <p:cNvPr id="10" name="TextBox 9"/>
           <p:cNvSpPr txBox="1"/>
           <p:nvPr/>
         </p:nvSpPr>
         <p:spPr>
           <a:xfrm>
-            <a:off x="1005840" y="2331720"/>
-            <a:ext cx="9692640" cy="914400"/>
+            <a:off x="1005840" y="4800600"/>
+            <a:ext cx="7315200" cy="365760"/>
           </a:xfrm>
           <a:prstGeom prst="rect">
             <a:avLst/>
@@ -9492,123 +9815,11 @@
           <a:lstStyle/>
           <a:p>
             <a:r>
-              <a:rPr sz="2200">
-                <a:solidFill>
-                  <a:srgbClr val="E6EEFC"/>
-                </a:solidFill>
-                <a:latin typeface="Inter"/>
-              </a:rPr>
-              <a:t>RonyGuard combines AI + modern MIS to deliver accessible legal-rights support when people need it most.</a:t>
-            </a:r>
-          </a:p>
-        </p:txBody>
-      </p:sp>
-      <p:sp>
-        <p:nvSpPr>
-          <p:cNvPr id="8" name="Rounded Rectangle 7"/>
-          <p:cNvSpPr/>
-          <p:nvPr/>
-        </p:nvSpPr>
-        <p:spPr>
-          <a:xfrm>
-            <a:off x="1005840" y="3794760"/>
-            <a:ext cx="2834640" cy="822960"/>
-          </a:xfrm>
-          <a:prstGeom prst="roundRect">
-            <a:avLst/>
-          </a:prstGeom>
-          <a:solidFill>
-            <a:srgbClr val="2997FF"/>
-          </a:solidFill>
-          <a:ln>
-            <a:noFill/>
-          </a:ln>
-        </p:spPr>
-        <p:style>
-          <a:lnRef idx="1">
-            <a:schemeClr val="accent1"/>
-          </a:lnRef>
-          <a:fillRef idx="3">
-            <a:schemeClr val="accent1"/>
-          </a:fillRef>
-          <a:effectRef idx="2">
-            <a:schemeClr val="accent1"/>
-          </a:effectRef>
-          <a:fontRef idx="minor">
-            <a:schemeClr val="lt1"/>
-          </a:fontRef>
-        </p:style>
-        <p:txBody>
-          <a:bodyPr rtlCol="0" anchor="ctr"/>
-          <a:lstStyle/>
-          <a:p>
-            <a:pPr algn="ctr"/>
-          </a:p>
-        </p:txBody>
-      </p:sp>
-      <p:sp>
-        <p:nvSpPr>
-          <p:cNvPr id="9" name="TextBox 8"/>
-          <p:cNvSpPr txBox="1"/>
-          <p:nvPr/>
-        </p:nvSpPr>
-        <p:spPr>
-          <a:xfrm>
-            <a:off x="1005840" y="3986784"/>
-            <a:ext cx="2834640" cy="457200"/>
-          </a:xfrm>
-          <a:prstGeom prst="rect">
-            <a:avLst/>
-          </a:prstGeom>
-          <a:noFill/>
-        </p:spPr>
-        <p:txBody>
-          <a:bodyPr wrap="none">
-            <a:spAutoFit/>
-          </a:bodyPr>
-          <a:lstStyle/>
-          <a:p>
-            <a:pPr algn="ctr"/>
-            <a:r>
-              <a:rPr b="1" sz="1800">
-                <a:solidFill>
-                  <a:srgbClr val="070D1C"/>
-                </a:solidFill>
-                <a:latin typeface="Poppins"/>
-              </a:rPr>
-              <a:t>Request a Demo</a:t>
-            </a:r>
-          </a:p>
-        </p:txBody>
-      </p:sp>
-      <p:sp>
-        <p:nvSpPr>
-          <p:cNvPr id="10" name="TextBox 9"/>
-          <p:cNvSpPr txBox="1"/>
-          <p:nvPr/>
-        </p:nvSpPr>
-        <p:spPr>
-          <a:xfrm>
-            <a:off x="1005840" y="4800600"/>
-            <a:ext cx="7315200" cy="365760"/>
-          </a:xfrm>
-          <a:prstGeom prst="rect">
-            <a:avLst/>
-          </a:prstGeom>
-          <a:noFill/>
-        </p:spPr>
-        <p:txBody>
-          <a:bodyPr wrap="none">
-            <a:spAutoFit/>
-          </a:bodyPr>
-          <a:lstStyle/>
-          <a:p>
-            <a:r>
               <a:rPr sz="1300">
                 <a:solidFill>
-                  <a:srgbClr val="A6B4D1"/>
+                  <a:srgbClr val="2D3848"/>
                 </a:solidFill>
-                <a:latin typeface="Inter"/>
+                <a:latin typeface="Segoe UI"/>
               </a:rPr>
               <a:t>Contact: ronald.kipkemboi@example.com  ·  ronyguard.app (placeholder)</a:t>
             </a:r>
@@ -9685,9 +9896,9 @@
             <a:r>
               <a:rPr sz="2000" b="1">
                 <a:solidFill>
-                  <a:srgbClr val="E6EEFC"/>
+                  <a:srgbClr val="2D3848"/>
                 </a:solidFill>
-                <a:latin typeface="Poppins"/>
+                <a:latin typeface="Segoe UI"/>
               </a:rPr>
               <a:t>Visual Placeholder</a:t>
             </a:r>
@@ -9697,9 +9908,9 @@
             <a:r>
               <a:rPr sz="1800">
                 <a:solidFill>
-                  <a:srgbClr val="A6B4D1"/>
+                  <a:srgbClr val="2D3848"/>
                 </a:solidFill>
-                <a:latin typeface="Inter"/>
+                <a:latin typeface="Segoe UI"/>
               </a:rPr>
               <a:t>• Add product screenshot or QR code</a:t>
             </a:r>

</xml_diff>